<commit_message>
Add multi-machine run to report (8.23), deck, case study, host guide, paper; refresh finals
</commit_message>
<xml_diff>
--- a/docs/final/RUDP_Host_Guide.pptx
+++ b/docs/final/RUDP_Host_Guide.pptx
@@ -47,9 +47,10 @@
     <p:sldId id="295" r:id="rId41"/>
     <p:sldId id="296" r:id="rId42"/>
     <p:sldId id="297" r:id="rId43"/>
+    <p:sldId id="298" r:id="rId44"/>
   </p:sldIdLst>
   <p:notesMasterIdLst>
-    <p:notesMasterId r:id="rId44"/>
+    <p:notesMasterId r:id="rId45"/>
   </p:notesMasterIdLst>
   <p:sldSz cx="12192000" cy="6858000"/>
   <p:notesSz cx="6858000" cy="12192000"/>
@@ -3735,6 +3736,94 @@
             <a:fld id="{F7021451-1387-4CA6-816F-3879F97B5CBC}" type="slidenum">
               <a:rPr lang="en-US"/>
               <a:t>42</a:t>
+            </a:fld>
+            <a:endParaRPr lang="en-US"/>
+          </a:p>
+        </p:txBody>
+      </p:sp>
+    </p:spTree>
+    <p:extLst>
+      <p:ext uri="{BB962C8B-B14F-4D97-AF65-F5344CB8AC3E}">
+        <p14:creationId xmlns:p14="http://schemas.microsoft.com/office/powerpoint/2010/main" val="1024086991"/>
+      </p:ext>
+    </p:extLst>
+  </p:cSld>
+  <p:clrMapOvr>
+    <a:masterClrMapping/>
+  </p:clrMapOvr>
+</p:notes>
+</file>
+
+<file path=ppt/notesSlides/notesSlide43.xml><?xml version="1.0" encoding="utf-8"?>
+<p:notes xmlns:a="http://schemas.openxmlformats.org/drawingml/2006/main" xmlns:r="http://schemas.openxmlformats.org/officeDocument/2006/relationships" xmlns:p="http://schemas.openxmlformats.org/presentationml/2006/main">
+  <p:cSld>
+    <p:spTree>
+      <p:nvGrpSpPr>
+        <p:cNvPr id="1" name=""/>
+        <p:cNvGrpSpPr/>
+        <p:nvPr/>
+      </p:nvGrpSpPr>
+      <p:grpSpPr>
+        <a:xfrm>
+          <a:off x="0" y="0"/>
+          <a:ext cx="0" cy="0"/>
+          <a:chOff x="0" y="0"/>
+          <a:chExt cx="0" cy="0"/>
+        </a:xfrm>
+      </p:grpSpPr>
+      <p:sp>
+        <p:nvSpPr>
+          <p:cNvPr id="2" name="Slide Image Placeholder 1"/>
+          <p:cNvSpPr>
+            <a:spLocks noGrp="1" noRot="1" noChangeAspect="1"/>
+          </p:cNvSpPr>
+          <p:nvPr>
+            <p:ph type="sldImg"/>
+          </p:nvPr>
+        </p:nvSpPr>
+        <p:spPr/>
+      </p:sp>
+      <p:sp>
+        <p:nvSpPr>
+          <p:cNvPr id="3" name="Notes Placeholder 2"/>
+          <p:cNvSpPr>
+            <a:spLocks noGrp="1"/>
+          </p:cNvSpPr>
+          <p:nvPr>
+            <p:ph type="body" idx="1"/>
+          </p:nvPr>
+        </p:nvSpPr>
+        <p:spPr/>
+        <p:txBody>
+          <a:bodyPr/>
+          <a:lstStyle/>
+          <a:p>
+            <a:r>
+              <a:rPr lang="en-US" dirty="0"/>
+              <a:t/>
+            </a:r>
+            <a:endParaRPr lang="en-US" dirty="0"/>
+          </a:p>
+        </p:txBody>
+      </p:sp>
+      <p:sp>
+        <p:nvSpPr>
+          <p:cNvPr id="4" name="Slide Number Placeholder 3"/>
+          <p:cNvSpPr>
+            <a:spLocks noGrp="1"/>
+          </p:cNvSpPr>
+          <p:nvPr>
+            <p:ph type="sldNum" sz="quarter" idx="10"/>
+          </p:nvPr>
+        </p:nvSpPr>
+        <p:spPr/>
+        <p:txBody>
+          <a:bodyPr/>
+          <a:lstStyle/>
+          <a:p>
+            <a:fld id="{F7021451-1387-4CA6-816F-3879F97B5CBC}" type="slidenum">
+              <a:rPr lang="en-US"/>
+              <a:t>43</a:t>
             </a:fld>
             <a:endParaRPr lang="en-US"/>
           </a:p>
@@ -15246,7 +15335,7 @@
                           <a:ea typeface="Calibri" pitchFamily="34" charset="-122"/>
                           <a:cs typeface="Calibri" pitchFamily="34" charset="-120"/>
                         </a:rPr>
-                        <a:t>Learnings and future work</a:t>
+                        <a:t>First run between two machines</a:t>
                       </a:r>
                       <a:endParaRPr lang="en-US" sz="1200" dirty="0">
                         <a:latin typeface="Calibri" charset="0"/>
@@ -15311,7 +15400,7 @@
                           <a:ea typeface="Calibri" pitchFamily="34" charset="-122"/>
                           <a:cs typeface="Calibri" pitchFamily="34" charset="-120"/>
                         </a:rPr>
-                        <a:t>0:50</a:t>
+                        <a:t>0:45</a:t>
                       </a:r>
                       <a:endParaRPr lang="en-US" sz="1200" dirty="0">
                         <a:latin typeface="Calibri" charset="0"/>
@@ -15638,7 +15727,7 @@
                           <a:ea typeface="Calibri" pitchFamily="34" charset="-122"/>
                           <a:cs typeface="Calibri" pitchFamily="34" charset="-120"/>
                         </a:rPr>
-                        <a:t>Thank you</a:t>
+                        <a:t>Learnings and future work</a:t>
                       </a:r>
                       <a:endParaRPr lang="en-US" sz="1200" dirty="0">
                         <a:latin typeface="Calibri" charset="0"/>
@@ -15703,7 +15792,7 @@
                           <a:ea typeface="Calibri" pitchFamily="34" charset="-122"/>
                           <a:cs typeface="Calibri" pitchFamily="34" charset="-120"/>
                         </a:rPr>
-                        <a:t>0:15</a:t>
+                        <a:t>0:50</a:t>
                       </a:r>
                       <a:endParaRPr lang="en-US" sz="1200" dirty="0">
                         <a:latin typeface="Calibri" charset="0"/>
@@ -16030,7 +16119,7 @@
                           <a:ea typeface="Calibri" pitchFamily="34" charset="-122"/>
                           <a:cs typeface="Calibri" pitchFamily="34" charset="-120"/>
                         </a:rPr>
-                        <a:t>Appendix: slow start</a:t>
+                        <a:t>Thank you</a:t>
                       </a:r>
                       <a:endParaRPr lang="en-US" sz="1200" dirty="0">
                         <a:latin typeface="Calibri" charset="0"/>
@@ -16095,7 +16184,7 @@
                           <a:ea typeface="Calibri" pitchFamily="34" charset="-122"/>
                           <a:cs typeface="Calibri" pitchFamily="34" charset="-120"/>
                         </a:rPr>
-                        <a:t>-</a:t>
+                        <a:t>0:15</a:t>
                       </a:r>
                       <a:endParaRPr lang="en-US" sz="1200" dirty="0">
                         <a:latin typeface="Calibri" charset="0"/>
@@ -16348,6 +16437,17 @@
                       <a:pPr indent="0" marL="0">
                         <a:buNone/>
                       </a:pPr>
+                      <a:r>
+                        <a:rPr lang="en-US" sz="1200" dirty="0">
+                          <a:solidFill>
+                            <a:srgbClr val="1B2430"/>
+                          </a:solidFill>
+                          <a:latin typeface="Calibri" pitchFamily="34" charset="0"/>
+                          <a:ea typeface="Calibri" pitchFamily="34" charset="-122"/>
+                          <a:cs typeface="Calibri" pitchFamily="34" charset="-120"/>
+                        </a:rPr>
+                        <a:t>38</a:t>
+                      </a:r>
                       <a:endParaRPr lang="en-US" sz="1200" dirty="0">
                         <a:latin typeface="Calibri" charset="0"/>
                         <a:ea typeface="Calibri" charset="0"/>
@@ -16402,6 +16502,17 @@
                       <a:pPr indent="0" marL="0">
                         <a:buNone/>
                       </a:pPr>
+                      <a:r>
+                        <a:rPr lang="en-US" sz="1200" dirty="0">
+                          <a:solidFill>
+                            <a:srgbClr val="1B2430"/>
+                          </a:solidFill>
+                          <a:latin typeface="Calibri" pitchFamily="34" charset="0"/>
+                          <a:ea typeface="Calibri" pitchFamily="34" charset="-122"/>
+                          <a:cs typeface="Calibri" pitchFamily="34" charset="-120"/>
+                        </a:rPr>
+                        <a:t>Appendix: slow start</a:t>
+                      </a:r>
                       <a:endParaRPr lang="en-US" sz="1200" dirty="0">
                         <a:latin typeface="Calibri" charset="0"/>
                         <a:ea typeface="Calibri" charset="0"/>
@@ -16456,6 +16567,17 @@
                       <a:pPr indent="0" marL="0">
                         <a:buNone/>
                       </a:pPr>
+                      <a:r>
+                        <a:rPr lang="en-US" sz="1200" dirty="0">
+                          <a:solidFill>
+                            <a:srgbClr val="1B2430"/>
+                          </a:solidFill>
+                          <a:latin typeface="Calibri" pitchFamily="34" charset="0"/>
+                          <a:ea typeface="Calibri" pitchFamily="34" charset="-122"/>
+                          <a:cs typeface="Calibri" pitchFamily="34" charset="-120"/>
+                        </a:rPr>
+                        <a:t>-</a:t>
+                      </a:r>
                       <a:endParaRPr lang="en-US" sz="1200" dirty="0">
                         <a:latin typeface="Calibri" charset="0"/>
                         <a:ea typeface="Calibri" charset="0"/>
@@ -23799,7 +23921,7 @@
                 <a:ea typeface="Calibri" pitchFamily="34" charset="-122"/>
                 <a:cs typeface="Calibri" pitchFamily="34" charset="-120"/>
               </a:rPr>
-              <a:t>35. Learnings and future work</a:t>
+              <a:t>35. First run between two machines</a:t>
             </a:r>
             <a:endParaRPr lang="en-US" sz="2600" dirty="0"/>
           </a:p>
@@ -23838,7 +23960,7 @@
                 <a:ea typeface="Calibri" pitchFamily="34" charset="-122"/>
                 <a:cs typeface="Calibri" pitchFamily="34" charset="-120"/>
               </a:rPr>
-              <a:t>Time on this slide: 0:50</a:t>
+              <a:t>Time on this slide: 0:45</a:t>
             </a:r>
             <a:endParaRPr lang="en-US" sz="1300" dirty="0"/>
           </a:p>
@@ -23991,7 +24113,7 @@
                 <a:ea typeface="Calibri" pitchFamily="34" charset="-122"/>
                 <a:cs typeface="Calibri" pitchFamily="34" charset="-120"/>
               </a:rPr>
-              <a:t>What we learned: reliability is a set of simple rules working together, congestion control matters as much as retransmission, and tests tell you things about your own results that you do not want to hear.</a:t>
+              <a:t>Until now every test ran on one computer. We ran the sender on one laptop and the receiver on another, on different networks, joined by Tailscale. It could not connect directly, so traffic went through a relay, about 79 milliseconds round trip.</a:t>
             </a:r>
             <a:endParaRPr lang="en-US" sz="1400" dirty="0"/>
           </a:p>
@@ -24012,7 +24134,7 @@
                 <a:ea typeface="Calibri" pitchFamily="34" charset="-122"/>
                 <a:cs typeface="Calibri" pitchFamily="34" charset="-120"/>
               </a:rPr>
-              <a:t>Our limits: no kernel netem or multi-machine test, the agent is not a polite neighbour, there is no gain at 10 percent random loss, and the tabular agent did not beat AIMD.</a:t>
+              <a:t>RUDP works between real machines: every transfer that finished delivered all 4,000 packets, with all four policies.</a:t>
             </a:r>
             <a:endParaRPr lang="en-US" sz="1400" dirty="0"/>
           </a:p>
@@ -24033,7 +24155,7 @@
                 <a:ea typeface="Calibri" pitchFamily="34" charset="-122"/>
                 <a:cs typeface="Calibri" pitchFamily="34" charset="-120"/>
               </a:rPr>
-              <a:t>Next: fairness-aware training with TCP coexistence, training on real traces, and kernel and multi-machine tests.</a:t>
+              <a:t>Be honest about the numbers: the path drifted, kernel TCP alone took anywhere from 2 to 51 seconds, and 4 of 20 RUDP runs timed out, so this is a demonstration and not a ranking. On the two clean repetitions kernel TCP was 2 to 6 times faster, and in repetition 1 the neural agent beat tuned AIMD, 4.7 against 14.2 seconds.</a:t>
             </a:r>
             <a:endParaRPr lang="en-US" sz="1400" dirty="0"/>
           </a:p>
@@ -24111,7 +24233,7 @@
                 <a:ea typeface="Calibri" pitchFamily="34" charset="-122"/>
                 <a:cs typeface="Calibri" pitchFamily="34" charset="-120"/>
               </a:rPr>
-              <a:t>What would you do first? Run the netem script on a Linux machine for kernel TCP and RUDP on the same path, then add a competing flow to the training.</a:t>
+              <a:t>Why not a better test? The other laptop was a one-time setup over the internet; the next step is a direct local network with more repetitions.</a:t>
             </a:r>
             <a:endParaRPr lang="en-US" sz="1400" dirty="0"/>
           </a:p>
@@ -24182,7 +24304,7 @@
                 <a:ea typeface="Calibri" pitchFamily="34" charset="-122"/>
                 <a:cs typeface="Calibri" pitchFamily="34" charset="-120"/>
               </a:rPr>
-              <a:t>36. Thank you</a:t>
+              <a:t>36. Learnings and future work</a:t>
             </a:r>
             <a:endParaRPr lang="en-US" sz="2600" dirty="0"/>
           </a:p>
@@ -24221,7 +24343,7 @@
                 <a:ea typeface="Calibri" pitchFamily="34" charset="-122"/>
                 <a:cs typeface="Calibri" pitchFamily="34" charset="-120"/>
               </a:rPr>
-              <a:t>Time on this slide: 0:15</a:t>
+              <a:t>Time on this slide: 0:50</a:t>
             </a:r>
             <a:endParaRPr lang="en-US" sz="1300" dirty="0"/>
           </a:p>
@@ -24366,7 +24488,7 @@
               <a:buChar char="•"/>
             </a:pPr>
             <a:r>
-              <a:rPr lang="en-US" sz="1600" dirty="0">
+              <a:rPr lang="en-US" sz="1400" dirty="0">
                 <a:solidFill>
                   <a:srgbClr val="1B2430"/>
                 </a:solidFill>
@@ -24374,9 +24496,51 @@
                 <a:ea typeface="Calibri" pitchFamily="34" charset="-122"/>
                 <a:cs typeface="Calibri" pitchFamily="34" charset="-120"/>
               </a:rPr>
-              <a:t>Thank you. The code, report and captures are at github.com/Capsturrrr/rudp. Happy to take questions.</a:t>
-            </a:r>
-            <a:endParaRPr lang="en-US" sz="1600" dirty="0"/>
+              <a:t>What we learned: reliability is a set of simple rules working together, congestion control matters as much as retransmission, and tests tell you things about your own results that you do not want to hear.</a:t>
+            </a:r>
+            <a:endParaRPr lang="en-US" sz="1400" dirty="0"/>
+          </a:p>
+          <a:p>
+            <a:pPr marL="342900" indent="-342900">
+              <a:spcAft>
+                <a:spcPts val="600"/>
+              </a:spcAft>
+              <a:buSzPct val="100000"/>
+              <a:buChar char="•"/>
+            </a:pPr>
+            <a:r>
+              <a:rPr lang="en-US" sz="1400" dirty="0">
+                <a:solidFill>
+                  <a:srgbClr val="1B2430"/>
+                </a:solidFill>
+                <a:latin typeface="Calibri" pitchFamily="34" charset="0"/>
+                <a:ea typeface="Calibri" pitchFamily="34" charset="-122"/>
+                <a:cs typeface="Calibri" pitchFamily="34" charset="-120"/>
+              </a:rPr>
+              <a:t>Our limits: only one noisy two-machine run, the agent is not a polite neighbour, there is no gain at 10 percent random loss, and the tabular agent did not beat AIMD.</a:t>
+            </a:r>
+            <a:endParaRPr lang="en-US" sz="1400" dirty="0"/>
+          </a:p>
+          <a:p>
+            <a:pPr marL="342900" indent="-342900">
+              <a:spcAft>
+                <a:spcPts val="600"/>
+              </a:spcAft>
+              <a:buSzPct val="100000"/>
+              <a:buChar char="•"/>
+            </a:pPr>
+            <a:r>
+              <a:rPr lang="en-US" sz="1400" dirty="0">
+                <a:solidFill>
+                  <a:srgbClr val="1B2430"/>
+                </a:solidFill>
+                <a:latin typeface="Calibri" pitchFamily="34" charset="0"/>
+                <a:ea typeface="Calibri" pitchFamily="34" charset="-122"/>
+                <a:cs typeface="Calibri" pitchFamily="34" charset="-120"/>
+              </a:rPr>
+              <a:t>Next: fairness-aware training with TCP coexistence, training on real traces, and controlled multi-machine tests.</a:t>
+            </a:r>
+            <a:endParaRPr lang="en-US" sz="1400" dirty="0"/>
           </a:p>
         </p:txBody>
       </p:sp>
@@ -24452,7 +24616,7 @@
                 <a:ea typeface="Calibri" pitchFamily="34" charset="-122"/>
                 <a:cs typeface="Calibri" pitchFamily="34" charset="-120"/>
               </a:rPr>
-              <a:t>Pause and smile; hand over to questions.</a:t>
+              <a:t>What would you do first? Run the netem script on a Linux machine for kernel TCP and RUDP on the same path, then add a competing flow to the training.</a:t>
             </a:r>
             <a:endParaRPr lang="en-US" sz="1400" dirty="0"/>
           </a:p>
@@ -24523,7 +24687,7 @@
                 <a:ea typeface="Calibri" pitchFamily="34" charset="-122"/>
                 <a:cs typeface="Calibri" pitchFamily="34" charset="-120"/>
               </a:rPr>
-              <a:t>37. Appendix: slow start</a:t>
+              <a:t>37. Thank you</a:t>
             </a:r>
             <a:endParaRPr lang="en-US" sz="2600" dirty="0"/>
           </a:p>
@@ -24562,7 +24726,7 @@
                 <a:ea typeface="Calibri" pitchFamily="34" charset="-122"/>
                 <a:cs typeface="Calibri" pitchFamily="34" charset="-120"/>
               </a:rPr>
-              <a:t>Time on this slide: -</a:t>
+              <a:t>Time on this slide: 0:15</a:t>
             </a:r>
             <a:endParaRPr lang="en-US" sz="1300" dirty="0"/>
           </a:p>
@@ -24715,7 +24879,7 @@
                 <a:ea typeface="Calibri" pitchFamily="34" charset="-122"/>
                 <a:cs typeface="Calibri" pitchFamily="34" charset="-120"/>
               </a:rPr>
-              <a:t>Only if asked: the window starts at 1, adds 1 per ACK until the threshold 16, then 1/window per ACK. In the 62-packet run the final window was 18.71.</a:t>
+              <a:t>Thank you. The code, report and captures are at github.com/Capsturrrr/rudp. Happy to take questions.</a:t>
             </a:r>
             <a:endParaRPr lang="en-US" sz="1600" dirty="0"/>
           </a:p>
@@ -24793,7 +24957,7 @@
                 <a:ea typeface="Calibri" pitchFamily="34" charset="-122"/>
                 <a:cs typeface="Calibri" pitchFamily="34" charset="-120"/>
               </a:rPr>
-              <a:t>Use this slide to answer 'show me congestion avoidance'.</a:t>
+              <a:t>Pause and smile; hand over to questions.</a:t>
             </a:r>
             <a:endParaRPr lang="en-US" sz="1400" dirty="0"/>
           </a:p>
@@ -25268,7 +25432,7 @@
                 <a:ea typeface="Calibri" pitchFamily="34" charset="-122"/>
                 <a:cs typeface="Calibri" pitchFamily="34" charset="-120"/>
               </a:rPr>
-              <a:t>Hard questions and short answers (1 of 3)</a:t>
+              <a:t>38. Appendix: slow start</a:t>
             </a:r>
             <a:endParaRPr lang="en-US" sz="2600" dirty="0"/>
           </a:p>
@@ -25276,7 +25440,46 @@
       </p:sp>
       <p:sp>
         <p:nvSpPr>
-          <p:cNvPr id="3" name="Shape 1"/>
+          <p:cNvPr id="3" name="Text 1"/>
+          <p:cNvSpPr/>
+          <p:nvPr/>
+        </p:nvSpPr>
+        <p:spPr>
+          <a:xfrm>
+            <a:off x="457200" y="804672"/>
+            <a:ext cx="10972800" cy="320040"/>
+          </a:xfrm>
+          <a:prstGeom prst="rect">
+            <a:avLst/>
+          </a:prstGeom>
+          <a:noFill/>
+          <a:ln/>
+        </p:spPr>
+        <p:txBody>
+          <a:bodyPr wrap="square" lIns="0" tIns="0" rIns="0" bIns="0" rtlCol="0" anchor="ctr"/>
+          <a:lstStyle/>
+          <a:p>
+            <a:pPr indent="0" marL="0">
+              <a:buNone/>
+            </a:pPr>
+            <a:r>
+              <a:rPr lang="en-US" sz="1300" dirty="0">
+                <a:solidFill>
+                  <a:srgbClr val="5B6775"/>
+                </a:solidFill>
+                <a:latin typeface="Calibri" pitchFamily="34" charset="0"/>
+                <a:ea typeface="Calibri" pitchFamily="34" charset="-122"/>
+                <a:cs typeface="Calibri" pitchFamily="34" charset="-120"/>
+              </a:rPr>
+              <a:t>Time on this slide: -</a:t>
+            </a:r>
+            <a:endParaRPr lang="en-US" sz="1300" dirty="0"/>
+          </a:p>
+        </p:txBody>
+      </p:sp>
+      <p:sp>
+        <p:nvSpPr>
+          <p:cNvPr id="4" name="Shape 2"/>
           <p:cNvSpPr/>
           <p:nvPr/>
         </p:nvSpPr>
@@ -25299,26 +25502,47 @@
           </a:ln>
         </p:spPr>
       </p:sp>
-      <p:sp>
-        <p:nvSpPr>
-          <p:cNvPr id="4" name="Shape 2"/>
-          <p:cNvSpPr/>
-          <p:nvPr/>
-        </p:nvSpPr>
+      <p:pic>
+        <p:nvPicPr>
+          <p:cNvPr id="5" name="Image 0" descr="th-38.png">    </p:cNvPr>
+          <p:cNvPicPr>
+            <a:picLocks noChangeAspect="1"/>
+          </p:cNvPicPr>
+          <p:nvPr/>
+        </p:nvPicPr>
+        <p:blipFill>
+          <a:blip r:embed="rId1"/>
+          <a:stretch>
+            <a:fillRect/>
+          </a:stretch>
+        </p:blipFill>
         <p:spPr>
           <a:xfrm>
             <a:off x="457200" y="1371600"/>
-            <a:ext cx="11274552" cy="914400"/>
-          </a:xfrm>
-          <a:prstGeom prst="rect">
-            <a:avLst/>
-          </a:prstGeom>
-          <a:solidFill>
-            <a:srgbClr val="F2F6FB"/>
-          </a:solidFill>
-          <a:ln w="9525">
+            <a:ext cx="5669280" cy="3188970"/>
+          </a:xfrm>
+          <a:prstGeom prst="rect">
+            <a:avLst/>
+          </a:prstGeom>
+        </p:spPr>
+      </p:pic>
+      <p:sp>
+        <p:nvSpPr>
+          <p:cNvPr id="6" name="Shape 3"/>
+          <p:cNvSpPr/>
+          <p:nvPr/>
+        </p:nvSpPr>
+        <p:spPr>
+          <a:xfrm>
+            <a:off x="457200" y="1371600"/>
+            <a:ext cx="5669280" cy="3188970"/>
+          </a:xfrm>
+          <a:prstGeom prst="rect">
+            <a:avLst/>
+          </a:prstGeom>
+          <a:ln w="12700">
             <a:solidFill>
-              <a:srgbClr val="D5DEE9"/>
+              <a:srgbClr val="C9D3E0"/>
             </a:solidFill>
             <a:prstDash val="solid"/>
           </a:ln>
@@ -25326,14 +25550,14 @@
       </p:sp>
       <p:sp>
         <p:nvSpPr>
-          <p:cNvPr id="5" name="Text 3"/>
-          <p:cNvSpPr/>
-          <p:nvPr/>
-        </p:nvSpPr>
-        <p:spPr>
-          <a:xfrm>
-            <a:off x="640080" y="1417320"/>
-            <a:ext cx="10972800" cy="320040"/>
+          <p:cNvPr id="7" name="Text 4"/>
+          <p:cNvSpPr/>
+          <p:nvPr/>
+        </p:nvSpPr>
+        <p:spPr>
+          <a:xfrm>
+            <a:off x="6400800" y="1325880"/>
+            <a:ext cx="1828800" cy="320040"/>
           </a:xfrm>
           <a:prstGeom prst="rect">
             <a:avLst/>
@@ -25349,7 +25573,7 @@
               <a:buNone/>
             </a:pPr>
             <a:r>
-              <a:rPr lang="en-US" sz="1500" b="1" dirty="0">
+              <a:rPr lang="en-US" sz="1300" b="1" dirty="0">
                 <a:solidFill>
                   <a:srgbClr val="1F6FEB"/>
                 </a:solidFill>
@@ -25357,22 +25581,22 @@
                 <a:ea typeface="Calibri" pitchFamily="34" charset="-122"/>
                 <a:cs typeface="Calibri" pitchFamily="34" charset="-120"/>
               </a:rPr>
-              <a:t>Is this a lab exercise?</a:t>
-            </a:r>
-            <a:endParaRPr lang="en-US" sz="1500" dirty="0"/>
-          </a:p>
-        </p:txBody>
-      </p:sp>
-      <p:sp>
-        <p:nvSpPr>
-          <p:cNvPr id="6" name="Text 4"/>
-          <p:cNvSpPr/>
-          <p:nvPr/>
-        </p:nvSpPr>
-        <p:spPr>
-          <a:xfrm>
-            <a:off x="640080" y="1737360"/>
-            <a:ext cx="10972800" cy="530352"/>
+              <a:t>SAY</a:t>
+            </a:r>
+            <a:endParaRPr lang="en-US" sz="1300" dirty="0"/>
+          </a:p>
+        </p:txBody>
+      </p:sp>
+      <p:sp>
+        <p:nvSpPr>
+          <p:cNvPr id="8" name="Text 5"/>
+          <p:cNvSpPr/>
+          <p:nvPr/>
+        </p:nvSpPr>
+        <p:spPr>
+          <a:xfrm>
+            <a:off x="6400800" y="1645920"/>
+            <a:ext cx="5349240" cy="3017520"/>
           </a:xfrm>
           <a:prstGeom prst="rect">
             <a:avLst/>
@@ -25384,11 +25608,15 @@
           <a:bodyPr wrap="square" lIns="0" tIns="0" rIns="0" bIns="0" rtlCol="0" anchor="t"/>
           <a:lstStyle/>
           <a:p>
-            <a:pPr indent="0" marL="0">
-              <a:buNone/>
-            </a:pPr>
-            <a:r>
-              <a:rPr lang="en-US" sz="1350" dirty="0">
+            <a:pPr marL="342900" indent="-342900">
+              <a:spcAft>
+                <a:spcPts val="600"/>
+              </a:spcAft>
+              <a:buSzPct val="100000"/>
+              <a:buChar char="•"/>
+            </a:pPr>
+            <a:r>
+              <a:rPr lang="en-US" sz="1600" dirty="0">
                 <a:solidFill>
                   <a:srgbClr val="1B2430"/>
                 </a:solidFill>
@@ -25396,32 +25624,32 @@
                 <a:ea typeface="Calibri" pitchFamily="34" charset="-122"/>
                 <a:cs typeface="Calibri" pitchFamily="34" charset="-120"/>
               </a:rPr>
-              <a:t>A lab sends datagrams. We built reliability and congestion control on top, measured them, and used them in a real chat and a routed network.</a:t>
-            </a:r>
-            <a:endParaRPr lang="en-US" sz="1350" dirty="0"/>
-          </a:p>
-        </p:txBody>
-      </p:sp>
-      <p:sp>
-        <p:nvSpPr>
-          <p:cNvPr id="7" name="Shape 5"/>
-          <p:cNvSpPr/>
-          <p:nvPr/>
-        </p:nvSpPr>
-        <p:spPr>
-          <a:xfrm>
-            <a:off x="457200" y="2377440"/>
-            <a:ext cx="11274552" cy="914400"/>
+              <a:t>Only if asked: the window starts at 1, adds 1 per ACK until the threshold 16, then 1/window per ACK. In the 62-packet run the final window was 18.71.</a:t>
+            </a:r>
+            <a:endParaRPr lang="en-US" sz="1600" dirty="0"/>
+          </a:p>
+        </p:txBody>
+      </p:sp>
+      <p:sp>
+        <p:nvSpPr>
+          <p:cNvPr id="9" name="Shape 6"/>
+          <p:cNvSpPr/>
+          <p:nvPr/>
+        </p:nvSpPr>
+        <p:spPr>
+          <a:xfrm>
+            <a:off x="457200" y="4709160"/>
+            <a:ext cx="5669280" cy="1737360"/>
           </a:xfrm>
           <a:prstGeom prst="rect">
             <a:avLst/>
           </a:prstGeom>
           <a:solidFill>
-            <a:srgbClr val="F2F6FB"/>
+            <a:srgbClr val="FFF6E5"/>
           </a:solidFill>
-          <a:ln w="9525">
+          <a:ln w="12700">
             <a:solidFill>
-              <a:srgbClr val="D5DEE9"/>
+              <a:srgbClr val="F0C987"/>
             </a:solidFill>
             <a:prstDash val="solid"/>
           </a:ln>
@@ -25429,14 +25657,14 @@
       </p:sp>
       <p:sp>
         <p:nvSpPr>
-          <p:cNvPr id="8" name="Text 6"/>
-          <p:cNvSpPr/>
-          <p:nvPr/>
-        </p:nvSpPr>
-        <p:spPr>
-          <a:xfrm>
-            <a:off x="640080" y="2423160"/>
-            <a:ext cx="10972800" cy="320040"/>
+          <p:cNvPr id="10" name="Text 7"/>
+          <p:cNvSpPr/>
+          <p:nvPr/>
+        </p:nvSpPr>
+        <p:spPr>
+          <a:xfrm>
+            <a:off x="594360" y="4754880"/>
+            <a:ext cx="5394960" cy="1645920"/>
           </a:xfrm>
           <a:prstGeom prst="rect">
             <a:avLst/>
@@ -25445,53 +25673,28 @@
           <a:ln/>
         </p:spPr>
         <p:txBody>
-          <a:bodyPr wrap="square" lIns="0" tIns="0" rIns="0" bIns="0" rtlCol="0" anchor="ctr"/>
+          <a:bodyPr wrap="square" lIns="0" tIns="0" rIns="0" bIns="0" rtlCol="0" anchor="t"/>
           <a:lstStyle/>
           <a:p>
             <a:pPr indent="0" marL="0">
               <a:buNone/>
             </a:pPr>
             <a:r>
-              <a:rPr lang="en-US" sz="1500" b="1" dirty="0">
-                <a:solidFill>
-                  <a:srgbClr val="1F6FEB"/>
-                </a:solidFill>
-                <a:latin typeface="Calibri" pitchFamily="34" charset="0"/>
-                <a:ea typeface="Calibri" pitchFamily="34" charset="-122"/>
-                <a:cs typeface="Calibri" pitchFamily="34" charset="-120"/>
-              </a:rPr>
-              <a:t>Why not TCP?</a:t>
-            </a:r>
-            <a:endParaRPr lang="en-US" sz="1500" dirty="0"/>
-          </a:p>
-        </p:txBody>
-      </p:sp>
-      <p:sp>
-        <p:nvSpPr>
-          <p:cNvPr id="9" name="Text 7"/>
-          <p:cNvSpPr/>
-          <p:nvPr/>
-        </p:nvSpPr>
-        <p:spPr>
-          <a:xfrm>
-            <a:off x="640080" y="2743200"/>
-            <a:ext cx="10972800" cy="530352"/>
-          </a:xfrm>
-          <a:prstGeom prst="rect">
-            <a:avLst/>
-          </a:prstGeom>
-          <a:noFill/>
-          <a:ln/>
-        </p:spPr>
-        <p:txBody>
-          <a:bodyPr wrap="square" lIns="0" tIns="0" rIns="0" bIns="0" rtlCol="0" anchor="t"/>
-          <a:lstStyle/>
-          <a:p>
+              <a:rPr lang="en-US" sz="1400" b="1" dirty="0">
+                <a:solidFill>
+                  <a:srgbClr val="B45309"/>
+                </a:solidFill>
+                <a:latin typeface="Calibri" pitchFamily="34" charset="0"/>
+                <a:ea typeface="Calibri" pitchFamily="34" charset="-122"/>
+                <a:cs typeface="Calibri" pitchFamily="34" charset="-120"/>
+              </a:rPr>
+              <a:t>IF ASKED  </a:t>
+            </a:r>
             <a:pPr indent="0" marL="0">
               <a:buNone/>
             </a:pPr>
             <a:r>
-              <a:rPr lang="en-US" sz="1350" dirty="0">
+              <a:rPr lang="en-US" sz="1400" dirty="0">
                 <a:solidFill>
                   <a:srgbClr val="1B2430"/>
                 </a:solidFill>
@@ -25499,318 +25702,9 @@
                 <a:ea typeface="Calibri" pitchFamily="34" charset="-122"/>
                 <a:cs typeface="Calibri" pitchFamily="34" charset="-120"/>
               </a:rPr>
-              <a:t>TCP is in the kernel and cannot be changed. Building our own makes every mechanism visible. QUIC and HTTP/3 do the same.</a:t>
-            </a:r>
-            <a:endParaRPr lang="en-US" sz="1350" dirty="0"/>
-          </a:p>
-        </p:txBody>
-      </p:sp>
-      <p:sp>
-        <p:nvSpPr>
-          <p:cNvPr id="10" name="Shape 8"/>
-          <p:cNvSpPr/>
-          <p:nvPr/>
-        </p:nvSpPr>
-        <p:spPr>
-          <a:xfrm>
-            <a:off x="457200" y="3383280"/>
-            <a:ext cx="11274552" cy="914400"/>
-          </a:xfrm>
-          <a:prstGeom prst="rect">
-            <a:avLst/>
-          </a:prstGeom>
-          <a:solidFill>
-            <a:srgbClr val="F2F6FB"/>
-          </a:solidFill>
-          <a:ln w="9525">
-            <a:solidFill>
-              <a:srgbClr val="D5DEE9"/>
-            </a:solidFill>
-            <a:prstDash val="solid"/>
-          </a:ln>
-        </p:spPr>
-      </p:sp>
-      <p:sp>
-        <p:nvSpPr>
-          <p:cNvPr id="11" name="Text 9"/>
-          <p:cNvSpPr/>
-          <p:nvPr/>
-        </p:nvSpPr>
-        <p:spPr>
-          <a:xfrm>
-            <a:off x="640080" y="3429000"/>
-            <a:ext cx="10972800" cy="320040"/>
-          </a:xfrm>
-          <a:prstGeom prst="rect">
-            <a:avLst/>
-          </a:prstGeom>
-          <a:noFill/>
-          <a:ln/>
-        </p:spPr>
-        <p:txBody>
-          <a:bodyPr wrap="square" lIns="0" tIns="0" rIns="0" bIns="0" rtlCol="0" anchor="ctr"/>
-          <a:lstStyle/>
-          <a:p>
-            <a:pPr indent="0" marL="0">
-              <a:buNone/>
-            </a:pPr>
-            <a:r>
-              <a:rPr lang="en-US" sz="1500" b="1" dirty="0">
-                <a:solidFill>
-                  <a:srgbClr val="1F6FEB"/>
-                </a:solidFill>
-                <a:latin typeface="Calibri" pitchFamily="34" charset="0"/>
-                <a:ea typeface="Calibri" pitchFamily="34" charset="-122"/>
-                <a:cs typeface="Calibri" pitchFamily="34" charset="-120"/>
-              </a:rPr>
-              <a:t>Did Smart-RUDP win?</a:t>
-            </a:r>
-            <a:endParaRPr lang="en-US" sz="1500" dirty="0"/>
-          </a:p>
-        </p:txBody>
-      </p:sp>
-      <p:sp>
-        <p:nvSpPr>
-          <p:cNvPr id="12" name="Text 10"/>
-          <p:cNvSpPr/>
-          <p:nvPr/>
-        </p:nvSpPr>
-        <p:spPr>
-          <a:xfrm>
-            <a:off x="640080" y="3749040"/>
-            <a:ext cx="10972800" cy="530352"/>
-          </a:xfrm>
-          <a:prstGeom prst="rect">
-            <a:avLst/>
-          </a:prstGeom>
-          <a:noFill/>
-          <a:ln/>
-        </p:spPr>
-        <p:txBody>
-          <a:bodyPr wrap="square" lIns="0" tIns="0" rIns="0" bIns="0" rtlCol="0" anchor="t"/>
-          <a:lstStyle/>
-          <a:p>
-            <a:pPr indent="0" marL="0">
-              <a:buNone/>
-            </a:pPr>
-            <a:r>
-              <a:rPr lang="en-US" sz="1350" dirty="0">
-                <a:solidFill>
-                  <a:srgbClr val="1B2430"/>
-                </a:solidFill>
-                <a:latin typeface="Calibri" pitchFamily="34" charset="0"/>
-                <a:ea typeface="Calibri" pitchFamily="34" charset="-122"/>
-                <a:cs typeface="Calibri" pitchFamily="34" charset="-120"/>
-              </a:rPr>
-              <a:t>Yes, in the final C transport against tuned baselines: 15 to 52 percent less time than tuned AIMD on four ordinary paths (real clock, real sockets and 100 random held-out paths agree), a tie on the 10 percent loss path. Against a simplified BBR it wins on the satellite-like and fast paths and loses on the 2 percent lossy path. The first tabular agent did not beat AIMD, and we say so.</a:t>
-            </a:r>
-            <a:endParaRPr lang="en-US" sz="1350" dirty="0"/>
-          </a:p>
-        </p:txBody>
-      </p:sp>
-      <p:sp>
-        <p:nvSpPr>
-          <p:cNvPr id="13" name="Shape 11"/>
-          <p:cNvSpPr/>
-          <p:nvPr/>
-        </p:nvSpPr>
-        <p:spPr>
-          <a:xfrm>
-            <a:off x="457200" y="4389120"/>
-            <a:ext cx="11274552" cy="914400"/>
-          </a:xfrm>
-          <a:prstGeom prst="rect">
-            <a:avLst/>
-          </a:prstGeom>
-          <a:solidFill>
-            <a:srgbClr val="F2F6FB"/>
-          </a:solidFill>
-          <a:ln w="9525">
-            <a:solidFill>
-              <a:srgbClr val="D5DEE9"/>
-            </a:solidFill>
-            <a:prstDash val="solid"/>
-          </a:ln>
-        </p:spPr>
-      </p:sp>
-      <p:sp>
-        <p:nvSpPr>
-          <p:cNvPr id="14" name="Text 12"/>
-          <p:cNvSpPr/>
-          <p:nvPr/>
-        </p:nvSpPr>
-        <p:spPr>
-          <a:xfrm>
-            <a:off x="640080" y="4434840"/>
-            <a:ext cx="10972800" cy="320040"/>
-          </a:xfrm>
-          <a:prstGeom prst="rect">
-            <a:avLst/>
-          </a:prstGeom>
-          <a:noFill/>
-          <a:ln/>
-        </p:spPr>
-        <p:txBody>
-          <a:bodyPr wrap="square" lIns="0" tIns="0" rIns="0" bIns="0" rtlCol="0" anchor="ctr"/>
-          <a:lstStyle/>
-          <a:p>
-            <a:pPr indent="0" marL="0">
-              <a:buNone/>
-            </a:pPr>
-            <a:r>
-              <a:rPr lang="en-US" sz="1500" b="1" dirty="0">
-                <a:solidFill>
-                  <a:srgbClr val="1F6FEB"/>
-                </a:solidFill>
-                <a:latin typeface="Calibri" pitchFamily="34" charset="0"/>
-                <a:ea typeface="Calibri" pitchFamily="34" charset="-122"/>
-                <a:cs typeface="Calibri" pitchFamily="34" charset="-120"/>
-              </a:rPr>
-              <a:t>Why Go-Back-N?</a:t>
-            </a:r>
-            <a:endParaRPr lang="en-US" sz="1500" dirty="0"/>
-          </a:p>
-        </p:txBody>
-      </p:sp>
-      <p:sp>
-        <p:nvSpPr>
-          <p:cNvPr id="15" name="Text 13"/>
-          <p:cNvSpPr/>
-          <p:nvPr/>
-        </p:nvSpPr>
-        <p:spPr>
-          <a:xfrm>
-            <a:off x="640080" y="4754880"/>
-            <a:ext cx="10972800" cy="530352"/>
-          </a:xfrm>
-          <a:prstGeom prst="rect">
-            <a:avLst/>
-          </a:prstGeom>
-          <a:noFill/>
-          <a:ln/>
-        </p:spPr>
-        <p:txBody>
-          <a:bodyPr wrap="square" lIns="0" tIns="0" rIns="0" bIns="0" rtlCol="0" anchor="t"/>
-          <a:lstStyle/>
-          <a:p>
-            <a:pPr indent="0" marL="0">
-              <a:buNone/>
-            </a:pPr>
-            <a:r>
-              <a:rPr lang="en-US" sz="1350" dirty="0">
-                <a:solidFill>
-                  <a:srgbClr val="1B2430"/>
-                </a:solidFill>
-                <a:latin typeface="Calibri" pitchFamily="34" charset="0"/>
-                <a:ea typeface="Calibri" pitchFamily="34" charset="-122"/>
-                <a:cs typeface="Calibri" pitchFamily="34" charset="-120"/>
-              </a:rPr>
-              <a:t>We started with it because it is simple to build and explain, then replaced it as the default with Selective Repeat: the receiver buffers out-of-order packets and reports them in an ACK bitmap, and the sender resends only what is missing. Go-Back-N stays behind a flag for comparison.</a:t>
-            </a:r>
-            <a:endParaRPr lang="en-US" sz="1350" dirty="0"/>
-          </a:p>
-        </p:txBody>
-      </p:sp>
-      <p:sp>
-        <p:nvSpPr>
-          <p:cNvPr id="16" name="Shape 14"/>
-          <p:cNvSpPr/>
-          <p:nvPr/>
-        </p:nvSpPr>
-        <p:spPr>
-          <a:xfrm>
-            <a:off x="457200" y="5394960"/>
-            <a:ext cx="11274552" cy="914400"/>
-          </a:xfrm>
-          <a:prstGeom prst="rect">
-            <a:avLst/>
-          </a:prstGeom>
-          <a:solidFill>
-            <a:srgbClr val="F2F6FB"/>
-          </a:solidFill>
-          <a:ln w="9525">
-            <a:solidFill>
-              <a:srgbClr val="D5DEE9"/>
-            </a:solidFill>
-            <a:prstDash val="solid"/>
-          </a:ln>
-        </p:spPr>
-      </p:sp>
-      <p:sp>
-        <p:nvSpPr>
-          <p:cNvPr id="17" name="Text 15"/>
-          <p:cNvSpPr/>
-          <p:nvPr/>
-        </p:nvSpPr>
-        <p:spPr>
-          <a:xfrm>
-            <a:off x="640080" y="5440680"/>
-            <a:ext cx="10972800" cy="320040"/>
-          </a:xfrm>
-          <a:prstGeom prst="rect">
-            <a:avLst/>
-          </a:prstGeom>
-          <a:noFill/>
-          <a:ln/>
-        </p:spPr>
-        <p:txBody>
-          <a:bodyPr wrap="square" lIns="0" tIns="0" rIns="0" bIns="0" rtlCol="0" anchor="ctr"/>
-          <a:lstStyle/>
-          <a:p>
-            <a:pPr indent="0" marL="0">
-              <a:buNone/>
-            </a:pPr>
-            <a:r>
-              <a:rPr lang="en-US" sz="1500" b="1" dirty="0">
-                <a:solidFill>
-                  <a:srgbClr val="1F6FEB"/>
-                </a:solidFill>
-                <a:latin typeface="Calibri" pitchFamily="34" charset="0"/>
-                <a:ea typeface="Calibri" pitchFamily="34" charset="-122"/>
-                <a:cs typeface="Calibri" pitchFamily="34" charset="-120"/>
-              </a:rPr>
-              <a:t>Tests ran on one machine?</a:t>
-            </a:r>
-            <a:endParaRPr lang="en-US" sz="1500" dirty="0"/>
-          </a:p>
-        </p:txBody>
-      </p:sp>
-      <p:sp>
-        <p:nvSpPr>
-          <p:cNvPr id="18" name="Text 16"/>
-          <p:cNvSpPr/>
-          <p:nvPr/>
-        </p:nvSpPr>
-        <p:spPr>
-          <a:xfrm>
-            <a:off x="640080" y="5760720"/>
-            <a:ext cx="10972800" cy="530352"/>
-          </a:xfrm>
-          <a:prstGeom prst="rect">
-            <a:avLst/>
-          </a:prstGeom>
-          <a:noFill/>
-          <a:ln/>
-        </p:spPr>
-        <p:txBody>
-          <a:bodyPr wrap="square" lIns="0" tIns="0" rIns="0" bIns="0" rtlCol="0" anchor="t"/>
-          <a:lstStyle/>
-          <a:p>
-            <a:pPr indent="0" marL="0">
-              <a:buNone/>
-            </a:pPr>
-            <a:r>
-              <a:rPr lang="en-US" sz="1350" dirty="0">
-                <a:solidFill>
-                  <a:srgbClr val="1B2430"/>
-                </a:solidFill>
-                <a:latin typeface="Calibri" pitchFamily="34" charset="0"/>
-                <a:ea typeface="Calibri" pitchFamily="34" charset="-122"/>
-                <a:cs typeface="Calibri" pitchFamily="34" charset="-120"/>
-              </a:rPr>
-              <a:t>Yes. Delay, loss and jitter are emulated in our client, in a separate proxy on real UDP sockets, and in virtual time; these agree with each other. We also ran it once on the Linux kernel with tc netem on one laptop: the agent beat tuned AIMD there, but kernel TCP was 1.5 to 1.7 times faster than us. No multi-machine path was tested.</a:t>
-            </a:r>
-            <a:endParaRPr lang="en-US" sz="1350" dirty="0"/>
+              <a:t>Use this slide to answer 'show me congestion avoidance'.</a:t>
+            </a:r>
+            <a:endParaRPr lang="en-US" sz="1400" dirty="0"/>
           </a:p>
         </p:txBody>
       </p:sp>
@@ -25879,7 +25773,7 @@
                 <a:ea typeface="Calibri" pitchFamily="34" charset="-122"/>
                 <a:cs typeface="Calibri" pitchFamily="34" charset="-120"/>
               </a:rPr>
-              <a:t>Hard questions and short answers (2 of 3)</a:t>
+              <a:t>Hard questions and short answers (1 of 3)</a:t>
             </a:r>
             <a:endParaRPr lang="en-US" sz="2600" dirty="0"/>
           </a:p>
@@ -25968,7 +25862,7 @@
                 <a:ea typeface="Calibri" pitchFamily="34" charset="-122"/>
                 <a:cs typeface="Calibri" pitchFamily="34" charset="-120"/>
               </a:rPr>
-              <a:t>What does Packet Tracer prove?</a:t>
+              <a:t>Is this a lab exercise?</a:t>
             </a:r>
             <a:endParaRPr lang="en-US" sz="1500" dirty="0"/>
           </a:p>
@@ -26007,7 +25901,7 @@
                 <a:ea typeface="Calibri" pitchFamily="34" charset="-122"/>
                 <a:cs typeface="Calibri" pitchFamily="34" charset="-120"/>
               </a:rPr>
-              <a:t>The network design: OSPF, VLANs, ACL, 70/71 failover. The protocol is validated separately with emulation and Wireshark.</a:t>
+              <a:t>A lab sends datagrams. We built reliability and congestion control on top, measured them, and used them in a real chat and a routed network.</a:t>
             </a:r>
             <a:endParaRPr lang="en-US" sz="1350" dirty="0"/>
           </a:p>
@@ -26071,7 +25965,7 @@
                 <a:ea typeface="Calibri" pitchFamily="34" charset="-122"/>
                 <a:cs typeface="Calibri" pitchFamily="34" charset="-120"/>
               </a:rPr>
-              <a:t>Peer disappears?</a:t>
+              <a:t>Why not TCP?</a:t>
             </a:r>
             <a:endParaRPr lang="en-US" sz="1500" dirty="0"/>
           </a:p>
@@ -26110,7 +26004,7 @@
                 <a:ea typeface="Calibri" pitchFamily="34" charset="-122"/>
                 <a:cs typeface="Calibri" pitchFamily="34" charset="-120"/>
               </a:rPr>
-              <a:t>Sender keeps retransmitting on timeout. A connection abort after repeated timeouts is not built; it is the fix we would add.</a:t>
+              <a:t>TCP is in the kernel and cannot be changed. Building our own makes every mechanism visible. QUIC and HTTP/3 do the same.</a:t>
             </a:r>
             <a:endParaRPr lang="en-US" sz="1350" dirty="0"/>
           </a:p>
@@ -26174,7 +26068,7 @@
                 <a:ea typeface="Calibri" pitchFamily="34" charset="-122"/>
                 <a:cs typeface="Calibri" pitchFamily="34" charset="-120"/>
               </a:rPr>
-              <a:t>Does the checksum catch errors?</a:t>
+              <a:t>Did Smart-RUDP win?</a:t>
             </a:r>
             <a:endParaRPr lang="en-US" sz="1500" dirty="0"/>
           </a:p>
@@ -26213,7 +26107,7 @@
                 <a:ea typeface="Calibri" pitchFamily="34" charset="-122"/>
                 <a:cs typeface="Calibri" pitchFamily="34" charset="-120"/>
               </a:rPr>
-              <a:t>It is CRC-16/CCITT now. The first version was a byte sum and a fuzzer showed 2 percent of corrupted packets got through; with CRC-16 none of 333,000 did. It cannot catch every error pattern, as no 16-bit check can.</a:t>
+              <a:t>Yes, in the final C transport against tuned baselines: 15 to 52 percent less time than tuned AIMD on four ordinary paths (real clock, real sockets and 100 random held-out paths agree), a tie on the 10 percent loss path. Against a simplified BBR it wins on the satellite-like and fast paths and loses on the 2 percent lossy path. The first tabular agent did not beat AIMD, and we say so.</a:t>
             </a:r>
             <a:endParaRPr lang="en-US" sz="1350" dirty="0"/>
           </a:p>
@@ -26277,7 +26171,7 @@
                 <a:ea typeface="Calibri" pitchFamily="34" charset="-122"/>
                 <a:cs typeface="Calibri" pitchFamily="34" charset="-120"/>
               </a:rPr>
-              <a:t>Why no handshake in the exported trace?</a:t>
+              <a:t>Why Go-Back-N?</a:t>
             </a:r>
             <a:endParaRPr lang="en-US" sz="1500" dirty="0"/>
           </a:p>
@@ -26316,7 +26210,7 @@
                 <a:ea typeface="Calibri" pitchFamily="34" charset="-122"/>
                 <a:cs typeface="Calibri" pitchFamily="34" charset="-120"/>
               </a:rPr>
-              <a:t>The export builds synthetic packets. The real tshark capture shows SYN, SYN-ACK, ACK.</a:t>
+              <a:t>We started with it because it is simple to build and explain, then replaced it as the default with Selective Repeat: the receiver buffers out-of-order packets and reports them in an ACK bitmap, and the sender resends only what is missing. Go-Back-N stays behind a flag for comparison.</a:t>
             </a:r>
             <a:endParaRPr lang="en-US" sz="1350" dirty="0"/>
           </a:p>
@@ -26380,7 +26274,7 @@
                 <a:ea typeface="Calibri" pitchFamily="34" charset="-122"/>
                 <a:cs typeface="Calibri" pitchFamily="34" charset="-120"/>
               </a:rPr>
-              <a:t>Is the baseline fair?</a:t>
+              <a:t>Was it tested between machines?</a:t>
             </a:r>
             <a:endParaRPr lang="en-US" sz="1500" dirty="0"/>
           </a:p>
@@ -26419,7 +26313,7 @@
                 <a:ea typeface="Calibri" pitchFamily="34" charset="-122"/>
                 <a:cs typeface="Calibri" pitchFamily="34" charset="-120"/>
               </a:rPr>
-              <a:t>We tuned it: window cap 128 and a high start threshold, plus the same retransmission-timer floor for every policy. We also compare against tuned CUBIC. Tuned AIMD improved a lot, and the agent is still ahead on four paths.</a:t>
+              <a:t>Yes. Delay, loss and jitter are emulated in our client, in a separate proxy on real UDP sockets, and in virtual time; these agree with each other. We also ran it once on the Linux kernel with tc netem on one laptop: the agent beat tuned AIMD there, but kernel TCP was 1.5 to 1.7 times faster than us. We also made one run between two laptops on different networks over a Tailscale relay: RUDP delivered every transfer that finished, but the path drifted and four of twenty runs timed out, so we do not rank the policies from it; kernel TCP was 2 to 6 times faster on the clean repetitions.</a:t>
             </a:r>
             <a:endParaRPr lang="en-US" sz="1350" dirty="0"/>
           </a:p>
@@ -26436,6 +26330,617 @@
 <file path=ppt/slides/slide42.xml><?xml version="1.0" encoding="utf-8"?>
 <p:sld xmlns:a="http://schemas.openxmlformats.org/drawingml/2006/main" xmlns:r="http://schemas.openxmlformats.org/officeDocument/2006/relationships" xmlns:p="http://schemas.openxmlformats.org/presentationml/2006/main">
   <p:cSld name="Slide 42">
+    <p:bg>
+      <p:bgPr>
+        <a:solidFill>
+          <a:srgbClr val="FFFFFF"/>
+        </a:solidFill>
+      </p:bgPr>
+    </p:bg>
+    <p:spTree>
+      <p:nvGrpSpPr>
+        <p:cNvPr id="1" name=""/>
+        <p:cNvGrpSpPr/>
+        <p:nvPr/>
+      </p:nvGrpSpPr>
+      <p:grpSpPr>
+        <a:xfrm>
+          <a:off x="0" y="0"/>
+          <a:ext cx="0" cy="0"/>
+          <a:chOff x="0" y="0"/>
+          <a:chExt cx="0" cy="0"/>
+        </a:xfrm>
+      </p:grpSpPr>
+      <p:sp>
+        <p:nvSpPr>
+          <p:cNvPr id="2" name="Text 0"/>
+          <p:cNvSpPr/>
+          <p:nvPr/>
+        </p:nvSpPr>
+        <p:spPr>
+          <a:xfrm>
+            <a:off x="457200" y="274320"/>
+            <a:ext cx="9601200" cy="548640"/>
+          </a:xfrm>
+          <a:prstGeom prst="rect">
+            <a:avLst/>
+          </a:prstGeom>
+          <a:noFill/>
+          <a:ln/>
+        </p:spPr>
+        <p:txBody>
+          <a:bodyPr wrap="square" lIns="0" tIns="0" rIns="0" bIns="0" rtlCol="0" anchor="ctr"/>
+          <a:lstStyle/>
+          <a:p>
+            <a:pPr indent="0" marL="0">
+              <a:buNone/>
+            </a:pPr>
+            <a:r>
+              <a:rPr lang="en-US" sz="2600" b="1" dirty="0">
+                <a:solidFill>
+                  <a:srgbClr val="1B2430"/>
+                </a:solidFill>
+                <a:latin typeface="Calibri" pitchFamily="34" charset="0"/>
+                <a:ea typeface="Calibri" pitchFamily="34" charset="-122"/>
+                <a:cs typeface="Calibri" pitchFamily="34" charset="-120"/>
+              </a:rPr>
+              <a:t>Hard questions and short answers (2 of 3)</a:t>
+            </a:r>
+            <a:endParaRPr lang="en-US" sz="2600" dirty="0"/>
+          </a:p>
+        </p:txBody>
+      </p:sp>
+      <p:sp>
+        <p:nvSpPr>
+          <p:cNvPr id="3" name="Shape 1"/>
+          <p:cNvSpPr/>
+          <p:nvPr/>
+        </p:nvSpPr>
+        <p:spPr>
+          <a:xfrm>
+            <a:off x="457200" y="1143000"/>
+            <a:ext cx="11274552" cy="36576"/>
+          </a:xfrm>
+          <a:prstGeom prst="rect">
+            <a:avLst/>
+          </a:prstGeom>
+          <a:solidFill>
+            <a:srgbClr val="1F6FEB"/>
+          </a:solidFill>
+          <a:ln w="12700">
+            <a:solidFill>
+              <a:srgbClr val="1F6FEB"/>
+            </a:solidFill>
+            <a:prstDash val="solid"/>
+          </a:ln>
+        </p:spPr>
+      </p:sp>
+      <p:sp>
+        <p:nvSpPr>
+          <p:cNvPr id="4" name="Shape 2"/>
+          <p:cNvSpPr/>
+          <p:nvPr/>
+        </p:nvSpPr>
+        <p:spPr>
+          <a:xfrm>
+            <a:off x="457200" y="1371600"/>
+            <a:ext cx="11274552" cy="914400"/>
+          </a:xfrm>
+          <a:prstGeom prst="rect">
+            <a:avLst/>
+          </a:prstGeom>
+          <a:solidFill>
+            <a:srgbClr val="F2F6FB"/>
+          </a:solidFill>
+          <a:ln w="9525">
+            <a:solidFill>
+              <a:srgbClr val="D5DEE9"/>
+            </a:solidFill>
+            <a:prstDash val="solid"/>
+          </a:ln>
+        </p:spPr>
+      </p:sp>
+      <p:sp>
+        <p:nvSpPr>
+          <p:cNvPr id="5" name="Text 3"/>
+          <p:cNvSpPr/>
+          <p:nvPr/>
+        </p:nvSpPr>
+        <p:spPr>
+          <a:xfrm>
+            <a:off x="640080" y="1417320"/>
+            <a:ext cx="10972800" cy="320040"/>
+          </a:xfrm>
+          <a:prstGeom prst="rect">
+            <a:avLst/>
+          </a:prstGeom>
+          <a:noFill/>
+          <a:ln/>
+        </p:spPr>
+        <p:txBody>
+          <a:bodyPr wrap="square" lIns="0" tIns="0" rIns="0" bIns="0" rtlCol="0" anchor="ctr"/>
+          <a:lstStyle/>
+          <a:p>
+            <a:pPr indent="0" marL="0">
+              <a:buNone/>
+            </a:pPr>
+            <a:r>
+              <a:rPr lang="en-US" sz="1500" b="1" dirty="0">
+                <a:solidFill>
+                  <a:srgbClr val="1F6FEB"/>
+                </a:solidFill>
+                <a:latin typeface="Calibri" pitchFamily="34" charset="0"/>
+                <a:ea typeface="Calibri" pitchFamily="34" charset="-122"/>
+                <a:cs typeface="Calibri" pitchFamily="34" charset="-120"/>
+              </a:rPr>
+              <a:t>What does Packet Tracer prove?</a:t>
+            </a:r>
+            <a:endParaRPr lang="en-US" sz="1500" dirty="0"/>
+          </a:p>
+        </p:txBody>
+      </p:sp>
+      <p:sp>
+        <p:nvSpPr>
+          <p:cNvPr id="6" name="Text 4"/>
+          <p:cNvSpPr/>
+          <p:nvPr/>
+        </p:nvSpPr>
+        <p:spPr>
+          <a:xfrm>
+            <a:off x="640080" y="1737360"/>
+            <a:ext cx="10972800" cy="530352"/>
+          </a:xfrm>
+          <a:prstGeom prst="rect">
+            <a:avLst/>
+          </a:prstGeom>
+          <a:noFill/>
+          <a:ln/>
+        </p:spPr>
+        <p:txBody>
+          <a:bodyPr wrap="square" lIns="0" tIns="0" rIns="0" bIns="0" rtlCol="0" anchor="t"/>
+          <a:lstStyle/>
+          <a:p>
+            <a:pPr indent="0" marL="0">
+              <a:buNone/>
+            </a:pPr>
+            <a:r>
+              <a:rPr lang="en-US" sz="1350" dirty="0">
+                <a:solidFill>
+                  <a:srgbClr val="1B2430"/>
+                </a:solidFill>
+                <a:latin typeface="Calibri" pitchFamily="34" charset="0"/>
+                <a:ea typeface="Calibri" pitchFamily="34" charset="-122"/>
+                <a:cs typeface="Calibri" pitchFamily="34" charset="-120"/>
+              </a:rPr>
+              <a:t>The network design: OSPF, VLANs, ACL, 70/71 failover. The protocol is validated separately with emulation and Wireshark.</a:t>
+            </a:r>
+            <a:endParaRPr lang="en-US" sz="1350" dirty="0"/>
+          </a:p>
+        </p:txBody>
+      </p:sp>
+      <p:sp>
+        <p:nvSpPr>
+          <p:cNvPr id="7" name="Shape 5"/>
+          <p:cNvSpPr/>
+          <p:nvPr/>
+        </p:nvSpPr>
+        <p:spPr>
+          <a:xfrm>
+            <a:off x="457200" y="2377440"/>
+            <a:ext cx="11274552" cy="914400"/>
+          </a:xfrm>
+          <a:prstGeom prst="rect">
+            <a:avLst/>
+          </a:prstGeom>
+          <a:solidFill>
+            <a:srgbClr val="F2F6FB"/>
+          </a:solidFill>
+          <a:ln w="9525">
+            <a:solidFill>
+              <a:srgbClr val="D5DEE9"/>
+            </a:solidFill>
+            <a:prstDash val="solid"/>
+          </a:ln>
+        </p:spPr>
+      </p:sp>
+      <p:sp>
+        <p:nvSpPr>
+          <p:cNvPr id="8" name="Text 6"/>
+          <p:cNvSpPr/>
+          <p:nvPr/>
+        </p:nvSpPr>
+        <p:spPr>
+          <a:xfrm>
+            <a:off x="640080" y="2423160"/>
+            <a:ext cx="10972800" cy="320040"/>
+          </a:xfrm>
+          <a:prstGeom prst="rect">
+            <a:avLst/>
+          </a:prstGeom>
+          <a:noFill/>
+          <a:ln/>
+        </p:spPr>
+        <p:txBody>
+          <a:bodyPr wrap="square" lIns="0" tIns="0" rIns="0" bIns="0" rtlCol="0" anchor="ctr"/>
+          <a:lstStyle/>
+          <a:p>
+            <a:pPr indent="0" marL="0">
+              <a:buNone/>
+            </a:pPr>
+            <a:r>
+              <a:rPr lang="en-US" sz="1500" b="1" dirty="0">
+                <a:solidFill>
+                  <a:srgbClr val="1F6FEB"/>
+                </a:solidFill>
+                <a:latin typeface="Calibri" pitchFamily="34" charset="0"/>
+                <a:ea typeface="Calibri" pitchFamily="34" charset="-122"/>
+                <a:cs typeface="Calibri" pitchFamily="34" charset="-120"/>
+              </a:rPr>
+              <a:t>Peer disappears?</a:t>
+            </a:r>
+            <a:endParaRPr lang="en-US" sz="1500" dirty="0"/>
+          </a:p>
+        </p:txBody>
+      </p:sp>
+      <p:sp>
+        <p:nvSpPr>
+          <p:cNvPr id="9" name="Text 7"/>
+          <p:cNvSpPr/>
+          <p:nvPr/>
+        </p:nvSpPr>
+        <p:spPr>
+          <a:xfrm>
+            <a:off x="640080" y="2743200"/>
+            <a:ext cx="10972800" cy="530352"/>
+          </a:xfrm>
+          <a:prstGeom prst="rect">
+            <a:avLst/>
+          </a:prstGeom>
+          <a:noFill/>
+          <a:ln/>
+        </p:spPr>
+        <p:txBody>
+          <a:bodyPr wrap="square" lIns="0" tIns="0" rIns="0" bIns="0" rtlCol="0" anchor="t"/>
+          <a:lstStyle/>
+          <a:p>
+            <a:pPr indent="0" marL="0">
+              <a:buNone/>
+            </a:pPr>
+            <a:r>
+              <a:rPr lang="en-US" sz="1350" dirty="0">
+                <a:solidFill>
+                  <a:srgbClr val="1B2430"/>
+                </a:solidFill>
+                <a:latin typeface="Calibri" pitchFamily="34" charset="0"/>
+                <a:ea typeface="Calibri" pitchFamily="34" charset="-122"/>
+                <a:cs typeface="Calibri" pitchFamily="34" charset="-120"/>
+              </a:rPr>
+              <a:t>Sender keeps retransmitting on timeout. A connection abort after repeated timeouts is not built; it is the fix we would add.</a:t>
+            </a:r>
+            <a:endParaRPr lang="en-US" sz="1350" dirty="0"/>
+          </a:p>
+        </p:txBody>
+      </p:sp>
+      <p:sp>
+        <p:nvSpPr>
+          <p:cNvPr id="10" name="Shape 8"/>
+          <p:cNvSpPr/>
+          <p:nvPr/>
+        </p:nvSpPr>
+        <p:spPr>
+          <a:xfrm>
+            <a:off x="457200" y="3383280"/>
+            <a:ext cx="11274552" cy="914400"/>
+          </a:xfrm>
+          <a:prstGeom prst="rect">
+            <a:avLst/>
+          </a:prstGeom>
+          <a:solidFill>
+            <a:srgbClr val="F2F6FB"/>
+          </a:solidFill>
+          <a:ln w="9525">
+            <a:solidFill>
+              <a:srgbClr val="D5DEE9"/>
+            </a:solidFill>
+            <a:prstDash val="solid"/>
+          </a:ln>
+        </p:spPr>
+      </p:sp>
+      <p:sp>
+        <p:nvSpPr>
+          <p:cNvPr id="11" name="Text 9"/>
+          <p:cNvSpPr/>
+          <p:nvPr/>
+        </p:nvSpPr>
+        <p:spPr>
+          <a:xfrm>
+            <a:off x="640080" y="3429000"/>
+            <a:ext cx="10972800" cy="320040"/>
+          </a:xfrm>
+          <a:prstGeom prst="rect">
+            <a:avLst/>
+          </a:prstGeom>
+          <a:noFill/>
+          <a:ln/>
+        </p:spPr>
+        <p:txBody>
+          <a:bodyPr wrap="square" lIns="0" tIns="0" rIns="0" bIns="0" rtlCol="0" anchor="ctr"/>
+          <a:lstStyle/>
+          <a:p>
+            <a:pPr indent="0" marL="0">
+              <a:buNone/>
+            </a:pPr>
+            <a:r>
+              <a:rPr lang="en-US" sz="1500" b="1" dirty="0">
+                <a:solidFill>
+                  <a:srgbClr val="1F6FEB"/>
+                </a:solidFill>
+                <a:latin typeface="Calibri" pitchFamily="34" charset="0"/>
+                <a:ea typeface="Calibri" pitchFamily="34" charset="-122"/>
+                <a:cs typeface="Calibri" pitchFamily="34" charset="-120"/>
+              </a:rPr>
+              <a:t>Does the checksum catch errors?</a:t>
+            </a:r>
+            <a:endParaRPr lang="en-US" sz="1500" dirty="0"/>
+          </a:p>
+        </p:txBody>
+      </p:sp>
+      <p:sp>
+        <p:nvSpPr>
+          <p:cNvPr id="12" name="Text 10"/>
+          <p:cNvSpPr/>
+          <p:nvPr/>
+        </p:nvSpPr>
+        <p:spPr>
+          <a:xfrm>
+            <a:off x="640080" y="3749040"/>
+            <a:ext cx="10972800" cy="530352"/>
+          </a:xfrm>
+          <a:prstGeom prst="rect">
+            <a:avLst/>
+          </a:prstGeom>
+          <a:noFill/>
+          <a:ln/>
+        </p:spPr>
+        <p:txBody>
+          <a:bodyPr wrap="square" lIns="0" tIns="0" rIns="0" bIns="0" rtlCol="0" anchor="t"/>
+          <a:lstStyle/>
+          <a:p>
+            <a:pPr indent="0" marL="0">
+              <a:buNone/>
+            </a:pPr>
+            <a:r>
+              <a:rPr lang="en-US" sz="1350" dirty="0">
+                <a:solidFill>
+                  <a:srgbClr val="1B2430"/>
+                </a:solidFill>
+                <a:latin typeface="Calibri" pitchFamily="34" charset="0"/>
+                <a:ea typeface="Calibri" pitchFamily="34" charset="-122"/>
+                <a:cs typeface="Calibri" pitchFamily="34" charset="-120"/>
+              </a:rPr>
+              <a:t>It is CRC-16/CCITT now. The first version was a byte sum and a fuzzer showed 2 percent of corrupted packets got through; with CRC-16 none of 333,000 did. It cannot catch every error pattern, as no 16-bit check can.</a:t>
+            </a:r>
+            <a:endParaRPr lang="en-US" sz="1350" dirty="0"/>
+          </a:p>
+        </p:txBody>
+      </p:sp>
+      <p:sp>
+        <p:nvSpPr>
+          <p:cNvPr id="13" name="Shape 11"/>
+          <p:cNvSpPr/>
+          <p:nvPr/>
+        </p:nvSpPr>
+        <p:spPr>
+          <a:xfrm>
+            <a:off x="457200" y="4389120"/>
+            <a:ext cx="11274552" cy="914400"/>
+          </a:xfrm>
+          <a:prstGeom prst="rect">
+            <a:avLst/>
+          </a:prstGeom>
+          <a:solidFill>
+            <a:srgbClr val="F2F6FB"/>
+          </a:solidFill>
+          <a:ln w="9525">
+            <a:solidFill>
+              <a:srgbClr val="D5DEE9"/>
+            </a:solidFill>
+            <a:prstDash val="solid"/>
+          </a:ln>
+        </p:spPr>
+      </p:sp>
+      <p:sp>
+        <p:nvSpPr>
+          <p:cNvPr id="14" name="Text 12"/>
+          <p:cNvSpPr/>
+          <p:nvPr/>
+        </p:nvSpPr>
+        <p:spPr>
+          <a:xfrm>
+            <a:off x="640080" y="4434840"/>
+            <a:ext cx="10972800" cy="320040"/>
+          </a:xfrm>
+          <a:prstGeom prst="rect">
+            <a:avLst/>
+          </a:prstGeom>
+          <a:noFill/>
+          <a:ln/>
+        </p:spPr>
+        <p:txBody>
+          <a:bodyPr wrap="square" lIns="0" tIns="0" rIns="0" bIns="0" rtlCol="0" anchor="ctr"/>
+          <a:lstStyle/>
+          <a:p>
+            <a:pPr indent="0" marL="0">
+              <a:buNone/>
+            </a:pPr>
+            <a:r>
+              <a:rPr lang="en-US" sz="1500" b="1" dirty="0">
+                <a:solidFill>
+                  <a:srgbClr val="1F6FEB"/>
+                </a:solidFill>
+                <a:latin typeface="Calibri" pitchFamily="34" charset="0"/>
+                <a:ea typeface="Calibri" pitchFamily="34" charset="-122"/>
+                <a:cs typeface="Calibri" pitchFamily="34" charset="-120"/>
+              </a:rPr>
+              <a:t>Why no handshake in the exported trace?</a:t>
+            </a:r>
+            <a:endParaRPr lang="en-US" sz="1500" dirty="0"/>
+          </a:p>
+        </p:txBody>
+      </p:sp>
+      <p:sp>
+        <p:nvSpPr>
+          <p:cNvPr id="15" name="Text 13"/>
+          <p:cNvSpPr/>
+          <p:nvPr/>
+        </p:nvSpPr>
+        <p:spPr>
+          <a:xfrm>
+            <a:off x="640080" y="4754880"/>
+            <a:ext cx="10972800" cy="530352"/>
+          </a:xfrm>
+          <a:prstGeom prst="rect">
+            <a:avLst/>
+          </a:prstGeom>
+          <a:noFill/>
+          <a:ln/>
+        </p:spPr>
+        <p:txBody>
+          <a:bodyPr wrap="square" lIns="0" tIns="0" rIns="0" bIns="0" rtlCol="0" anchor="t"/>
+          <a:lstStyle/>
+          <a:p>
+            <a:pPr indent="0" marL="0">
+              <a:buNone/>
+            </a:pPr>
+            <a:r>
+              <a:rPr lang="en-US" sz="1350" dirty="0">
+                <a:solidFill>
+                  <a:srgbClr val="1B2430"/>
+                </a:solidFill>
+                <a:latin typeface="Calibri" pitchFamily="34" charset="0"/>
+                <a:ea typeface="Calibri" pitchFamily="34" charset="-122"/>
+                <a:cs typeface="Calibri" pitchFamily="34" charset="-120"/>
+              </a:rPr>
+              <a:t>The export builds synthetic packets. The real tshark capture shows SYN, SYN-ACK, ACK.</a:t>
+            </a:r>
+            <a:endParaRPr lang="en-US" sz="1350" dirty="0"/>
+          </a:p>
+        </p:txBody>
+      </p:sp>
+      <p:sp>
+        <p:nvSpPr>
+          <p:cNvPr id="16" name="Shape 14"/>
+          <p:cNvSpPr/>
+          <p:nvPr/>
+        </p:nvSpPr>
+        <p:spPr>
+          <a:xfrm>
+            <a:off x="457200" y="5394960"/>
+            <a:ext cx="11274552" cy="914400"/>
+          </a:xfrm>
+          <a:prstGeom prst="rect">
+            <a:avLst/>
+          </a:prstGeom>
+          <a:solidFill>
+            <a:srgbClr val="F2F6FB"/>
+          </a:solidFill>
+          <a:ln w="9525">
+            <a:solidFill>
+              <a:srgbClr val="D5DEE9"/>
+            </a:solidFill>
+            <a:prstDash val="solid"/>
+          </a:ln>
+        </p:spPr>
+      </p:sp>
+      <p:sp>
+        <p:nvSpPr>
+          <p:cNvPr id="17" name="Text 15"/>
+          <p:cNvSpPr/>
+          <p:nvPr/>
+        </p:nvSpPr>
+        <p:spPr>
+          <a:xfrm>
+            <a:off x="640080" y="5440680"/>
+            <a:ext cx="10972800" cy="320040"/>
+          </a:xfrm>
+          <a:prstGeom prst="rect">
+            <a:avLst/>
+          </a:prstGeom>
+          <a:noFill/>
+          <a:ln/>
+        </p:spPr>
+        <p:txBody>
+          <a:bodyPr wrap="square" lIns="0" tIns="0" rIns="0" bIns="0" rtlCol="0" anchor="ctr"/>
+          <a:lstStyle/>
+          <a:p>
+            <a:pPr indent="0" marL="0">
+              <a:buNone/>
+            </a:pPr>
+            <a:r>
+              <a:rPr lang="en-US" sz="1500" b="1" dirty="0">
+                <a:solidFill>
+                  <a:srgbClr val="1F6FEB"/>
+                </a:solidFill>
+                <a:latin typeface="Calibri" pitchFamily="34" charset="0"/>
+                <a:ea typeface="Calibri" pitchFamily="34" charset="-122"/>
+                <a:cs typeface="Calibri" pitchFamily="34" charset="-120"/>
+              </a:rPr>
+              <a:t>Is the baseline fair?</a:t>
+            </a:r>
+            <a:endParaRPr lang="en-US" sz="1500" dirty="0"/>
+          </a:p>
+        </p:txBody>
+      </p:sp>
+      <p:sp>
+        <p:nvSpPr>
+          <p:cNvPr id="18" name="Text 16"/>
+          <p:cNvSpPr/>
+          <p:nvPr/>
+        </p:nvSpPr>
+        <p:spPr>
+          <a:xfrm>
+            <a:off x="640080" y="5760720"/>
+            <a:ext cx="10972800" cy="530352"/>
+          </a:xfrm>
+          <a:prstGeom prst="rect">
+            <a:avLst/>
+          </a:prstGeom>
+          <a:noFill/>
+          <a:ln/>
+        </p:spPr>
+        <p:txBody>
+          <a:bodyPr wrap="square" lIns="0" tIns="0" rIns="0" bIns="0" rtlCol="0" anchor="t"/>
+          <a:lstStyle/>
+          <a:p>
+            <a:pPr indent="0" marL="0">
+              <a:buNone/>
+            </a:pPr>
+            <a:r>
+              <a:rPr lang="en-US" sz="1350" dirty="0">
+                <a:solidFill>
+                  <a:srgbClr val="1B2430"/>
+                </a:solidFill>
+                <a:latin typeface="Calibri" pitchFamily="34" charset="0"/>
+                <a:ea typeface="Calibri" pitchFamily="34" charset="-122"/>
+                <a:cs typeface="Calibri" pitchFamily="34" charset="-120"/>
+              </a:rPr>
+              <a:t>We tuned it: window cap 128 and a high start threshold, plus the same retransmission-timer floor for every policy. We also compare against tuned CUBIC. Tuned AIMD improved a lot, and the agent is still ahead on four paths.</a:t>
+            </a:r>
+            <a:endParaRPr lang="en-US" sz="1350" dirty="0"/>
+          </a:p>
+        </p:txBody>
+      </p:sp>
+    </p:spTree>
+  </p:cSld>
+  <p:clrMapOvr>
+    <a:masterClrMapping/>
+  </p:clrMapOvr>
+</p:sld>
+</file>
+
+<file path=ppt/slides/slide43.xml><?xml version="1.0" encoding="utf-8"?>
+<p:sld xmlns:a="http://schemas.openxmlformats.org/drawingml/2006/main" xmlns:r="http://schemas.openxmlformats.org/officeDocument/2006/relationships" xmlns:p="http://schemas.openxmlformats.org/presentationml/2006/main">
+  <p:cSld name="Slide 43">
     <p:bg>
       <p:bgPr>
         <a:solidFill>

</xml_diff>

<commit_message>
Deck: add RUDP Drop slide (44 slides)
</commit_message>
<xml_diff>
--- a/docs/final/RUDP_Host_Guide.pptx
+++ b/docs/final/RUDP_Host_Guide.pptx
@@ -53,9 +53,10 @@
     <p:sldId id="301" r:id="rId47"/>
     <p:sldId id="302" r:id="rId48"/>
     <p:sldId id="303" r:id="rId49"/>
+    <p:sldId id="304" r:id="rId50"/>
   </p:sldIdLst>
   <p:notesMasterIdLst>
-    <p:notesMasterId r:id="rId50"/>
+    <p:notesMasterId r:id="rId51"/>
   </p:notesMasterIdLst>
   <p:sldSz cx="12192000" cy="6858000"/>
   <p:notesSz cx="6858000" cy="12192000"/>
@@ -4269,6 +4270,94 @@
             <a:fld id="{F7021451-1387-4CA6-816F-3879F97B5CBC}" type="slidenum">
               <a:rPr lang="en-US"/>
               <a:t>48</a:t>
+            </a:fld>
+            <a:endParaRPr lang="en-US"/>
+          </a:p>
+        </p:txBody>
+      </p:sp>
+    </p:spTree>
+    <p:extLst>
+      <p:ext uri="{BB962C8B-B14F-4D97-AF65-F5344CB8AC3E}">
+        <p14:creationId xmlns:p14="http://schemas.microsoft.com/office/powerpoint/2010/main" val="1024086991"/>
+      </p:ext>
+    </p:extLst>
+  </p:cSld>
+  <p:clrMapOvr>
+    <a:masterClrMapping/>
+  </p:clrMapOvr>
+</p:notes>
+</file>
+
+<file path=ppt/notesSlides/notesSlide49.xml><?xml version="1.0" encoding="utf-8"?>
+<p:notes xmlns:a="http://schemas.openxmlformats.org/drawingml/2006/main" xmlns:r="http://schemas.openxmlformats.org/officeDocument/2006/relationships" xmlns:p="http://schemas.openxmlformats.org/presentationml/2006/main">
+  <p:cSld>
+    <p:spTree>
+      <p:nvGrpSpPr>
+        <p:cNvPr id="1" name=""/>
+        <p:cNvGrpSpPr/>
+        <p:nvPr/>
+      </p:nvGrpSpPr>
+      <p:grpSpPr>
+        <a:xfrm>
+          <a:off x="0" y="0"/>
+          <a:ext cx="0" cy="0"/>
+          <a:chOff x="0" y="0"/>
+          <a:chExt cx="0" cy="0"/>
+        </a:xfrm>
+      </p:grpSpPr>
+      <p:sp>
+        <p:nvSpPr>
+          <p:cNvPr id="2" name="Slide Image Placeholder 1"/>
+          <p:cNvSpPr>
+            <a:spLocks noGrp="1" noRot="1" noChangeAspect="1"/>
+          </p:cNvSpPr>
+          <p:nvPr>
+            <p:ph type="sldImg"/>
+          </p:nvPr>
+        </p:nvSpPr>
+        <p:spPr/>
+      </p:sp>
+      <p:sp>
+        <p:nvSpPr>
+          <p:cNvPr id="3" name="Notes Placeholder 2"/>
+          <p:cNvSpPr>
+            <a:spLocks noGrp="1"/>
+          </p:cNvSpPr>
+          <p:nvPr>
+            <p:ph type="body" idx="1"/>
+          </p:nvPr>
+        </p:nvSpPr>
+        <p:spPr/>
+        <p:txBody>
+          <a:bodyPr/>
+          <a:lstStyle/>
+          <a:p>
+            <a:r>
+              <a:rPr lang="en-US" dirty="0"/>
+              <a:t/>
+            </a:r>
+            <a:endParaRPr lang="en-US" dirty="0"/>
+          </a:p>
+        </p:txBody>
+      </p:sp>
+      <p:sp>
+        <p:nvSpPr>
+          <p:cNvPr id="4" name="Slide Number Placeholder 3"/>
+          <p:cNvSpPr>
+            <a:spLocks noGrp="1"/>
+          </p:cNvSpPr>
+          <p:nvPr>
+            <p:ph type="sldNum" sz="quarter" idx="10"/>
+          </p:nvPr>
+        </p:nvSpPr>
+        <p:spPr/>
+        <p:txBody>
+          <a:bodyPr/>
+          <a:lstStyle/>
+          <a:p>
+            <a:fld id="{F7021451-1387-4CA6-816F-3879F97B5CBC}" type="slidenum">
+              <a:rPr lang="en-US"/>
+              <a:t>49</a:t>
             </a:fld>
             <a:endParaRPr lang="en-US"/>
           </a:p>
@@ -9963,7 +10052,7 @@
                           <a:ea typeface="Calibri" pitchFamily="34" charset="-122"/>
                           <a:cs typeface="Calibri" pitchFamily="34" charset="-120"/>
                         </a:rPr>
-                        <a:t>Smart-RUDP: a Q-learning window controller</a:t>
+                        <a:t>Congestion control: AIMD</a:t>
                       </a:r>
                       <a:endParaRPr lang="en-US" sz="1200" dirty="0">
                         <a:latin typeface="Calibri" charset="0"/>
@@ -10355,7 +10444,7 @@
                           <a:ea typeface="Calibri" pitchFamily="34" charset="-122"/>
                           <a:cs typeface="Calibri" pitchFamily="34" charset="-120"/>
                         </a:rPr>
-                        <a:t>The AI agent in our code</a:t>
+                        <a:t>Smart-RUDP: a Q-learning window controller</a:t>
                       </a:r>
                       <a:endParaRPr lang="en-US" sz="1200" dirty="0">
                         <a:latin typeface="Calibri" charset="0"/>
@@ -10420,7 +10509,7 @@
                           <a:ea typeface="Calibri" pitchFamily="34" charset="-122"/>
                           <a:cs typeface="Calibri" pitchFamily="34" charset="-120"/>
                         </a:rPr>
-                        <a:t>1:00</a:t>
+                        <a:t>0:50</a:t>
                       </a:r>
                       <a:endParaRPr lang="en-US" sz="1200" dirty="0">
                         <a:latin typeface="Calibri" charset="0"/>
@@ -10747,7 +10836,7 @@
                           <a:ea typeface="Calibri" pitchFamily="34" charset="-122"/>
                           <a:cs typeface="Calibri" pitchFamily="34" charset="-120"/>
                         </a:rPr>
-                        <a:t>Neural agent in the C transport</a:t>
+                        <a:t>The AI agent in our code</a:t>
                       </a:r>
                       <a:endParaRPr lang="en-US" sz="1200" dirty="0">
                         <a:latin typeface="Calibri" charset="0"/>
@@ -11139,7 +11228,7 @@
                           <a:ea typeface="Calibri" pitchFamily="34" charset="-122"/>
                           <a:cs typeface="Calibri" pitchFamily="34" charset="-120"/>
                         </a:rPr>
-                        <a:t>Literature behind the design</a:t>
+                        <a:t>Neural agent in the C transport</a:t>
                       </a:r>
                       <a:endParaRPr lang="en-US" sz="1200" dirty="0">
                         <a:latin typeface="Calibri" charset="0"/>
@@ -11204,7 +11293,7 @@
                           <a:ea typeface="Calibri" pitchFamily="34" charset="-122"/>
                           <a:cs typeface="Calibri" pitchFamily="34" charset="-120"/>
                         </a:rPr>
-                        <a:t>0:30</a:t>
+                        <a:t>1:00</a:t>
                       </a:r>
                       <a:endParaRPr lang="en-US" sz="1200" dirty="0">
                         <a:latin typeface="Calibri" charset="0"/>
@@ -11531,7 +11620,7 @@
                           <a:ea typeface="Calibri" pitchFamily="34" charset="-122"/>
                           <a:cs typeface="Calibri" pitchFamily="34" charset="-120"/>
                         </a:rPr>
-                        <a:t>How it was tested</a:t>
+                        <a:t>Literature behind the design</a:t>
                       </a:r>
                       <a:endParaRPr lang="en-US" sz="1200" dirty="0">
                         <a:latin typeface="Calibri" charset="0"/>
@@ -11596,7 +11685,7 @@
                           <a:ea typeface="Calibri" pitchFamily="34" charset="-122"/>
                           <a:cs typeface="Calibri" pitchFamily="34" charset="-120"/>
                         </a:rPr>
-                        <a:t>0:40</a:t>
+                        <a:t>0:30</a:t>
                       </a:r>
                       <a:endParaRPr lang="en-US" sz="1200" dirty="0">
                         <a:latin typeface="Calibri" charset="0"/>
@@ -11923,7 +12012,7 @@
                           <a:ea typeface="Calibri" pitchFamily="34" charset="-122"/>
                           <a:cs typeface="Calibri" pitchFamily="34" charset="-120"/>
                         </a:rPr>
-                        <a:t>A fast, faithful C simulator, and what it showed</a:t>
+                        <a:t>How it was tested</a:t>
                       </a:r>
                       <a:endParaRPr lang="en-US" sz="1200" dirty="0">
                         <a:latin typeface="Calibri" charset="0"/>
@@ -11988,7 +12077,7 @@
                           <a:ea typeface="Calibri" pitchFamily="34" charset="-122"/>
                           <a:cs typeface="Calibri" pitchFamily="34" charset="-120"/>
                         </a:rPr>
-                        <a:t>1:00</a:t>
+                        <a:t>0:40</a:t>
                       </a:r>
                       <a:endParaRPr lang="en-US" sz="1200" dirty="0">
                         <a:latin typeface="Calibri" charset="0"/>
@@ -12315,7 +12404,7 @@
                           <a:ea typeface="Calibri" pitchFamily="34" charset="-122"/>
                           <a:cs typeface="Calibri" pitchFamily="34" charset="-120"/>
                         </a:rPr>
-                        <a:t>Issues we found along the way</a:t>
+                        <a:t>A fast, faithful C simulator, and what it showed</a:t>
                       </a:r>
                       <a:endParaRPr lang="en-US" sz="1200" dirty="0">
                         <a:latin typeface="Calibri" charset="0"/>
@@ -12380,7 +12469,7 @@
                           <a:ea typeface="Calibri" pitchFamily="34" charset="-122"/>
                           <a:cs typeface="Calibri" pitchFamily="34" charset="-120"/>
                         </a:rPr>
-                        <a:t>0:50</a:t>
+                        <a:t>1:00</a:t>
                       </a:r>
                       <a:endParaRPr lang="en-US" sz="1200" dirty="0">
                         <a:latin typeface="Calibri" charset="0"/>
@@ -12707,7 +12796,7 @@
                           <a:ea typeface="Calibri" pitchFamily="34" charset="-122"/>
                           <a:cs typeface="Calibri" pitchFamily="34" charset="-120"/>
                         </a:rPr>
-                        <a:t>What we changed to make it better</a:t>
+                        <a:t>Issues we found along the way</a:t>
                       </a:r>
                       <a:endParaRPr lang="en-US" sz="1200" dirty="0">
                         <a:latin typeface="Calibri" charset="0"/>
@@ -12772,7 +12861,7 @@
                           <a:ea typeface="Calibri" pitchFamily="34" charset="-122"/>
                           <a:cs typeface="Calibri" pitchFamily="34" charset="-120"/>
                         </a:rPr>
-                        <a:t>1:00</a:t>
+                        <a:t>0:50</a:t>
                       </a:r>
                       <a:endParaRPr lang="en-US" sz="1200" dirty="0">
                         <a:latin typeface="Calibri" charset="0"/>
@@ -13099,7 +13188,7 @@
                           <a:ea typeface="Calibri" pitchFamily="34" charset="-122"/>
                           <a:cs typeface="Calibri" pitchFamily="34" charset="-120"/>
                         </a:rPr>
-                        <a:t>Benchmark results</a:t>
+                        <a:t>What we changed to make it better</a:t>
                       </a:r>
                       <a:endParaRPr lang="en-US" sz="1200" dirty="0">
                         <a:latin typeface="Calibri" charset="0"/>
@@ -13164,7 +13253,7 @@
                           <a:ea typeface="Calibri" pitchFamily="34" charset="-122"/>
                           <a:cs typeface="Calibri" pitchFamily="34" charset="-120"/>
                         </a:rPr>
-                        <a:t>0:40</a:t>
+                        <a:t>1:00</a:t>
                       </a:r>
                       <a:endParaRPr lang="en-US" sz="1200" dirty="0">
                         <a:latin typeface="Calibri" charset="0"/>
@@ -13491,7 +13580,7 @@
                           <a:ea typeface="Calibri" pitchFamily="34" charset="-122"/>
                           <a:cs typeface="Calibri" pitchFamily="34" charset="-120"/>
                         </a:rPr>
-                        <a:t>Problems we hit and fixed</a:t>
+                        <a:t>Benchmark results</a:t>
                       </a:r>
                       <a:endParaRPr lang="en-US" sz="1200" dirty="0">
                         <a:latin typeface="Calibri" charset="0"/>
@@ -13883,7 +13972,7 @@
                           <a:ea typeface="Calibri" pitchFamily="34" charset="-122"/>
                           <a:cs typeface="Calibri" pitchFamily="34" charset="-120"/>
                         </a:rPr>
-                        <a:t>Our first learned agent: an honest result</a:t>
+                        <a:t>Problems we hit and fixed</a:t>
                       </a:r>
                       <a:endParaRPr lang="en-US" sz="1200" dirty="0">
                         <a:latin typeface="Calibri" charset="0"/>
@@ -13948,7 +14037,7 @@
                           <a:ea typeface="Calibri" pitchFamily="34" charset="-122"/>
                           <a:cs typeface="Calibri" pitchFamily="34" charset="-120"/>
                         </a:rPr>
-                        <a:t>0:50</a:t>
+                        <a:t>0:40</a:t>
                       </a:r>
                       <a:endParaRPr lang="en-US" sz="1200" dirty="0">
                         <a:latin typeface="Calibri" charset="0"/>
@@ -14275,7 +14364,7 @@
                           <a:ea typeface="Calibri" pitchFamily="34" charset="-122"/>
                           <a:cs typeface="Calibri" pitchFamily="34" charset="-120"/>
                         </a:rPr>
-                        <a:t>More evidence: baselines, SACK, reordering</a:t>
+                        <a:t>Our first learned agent: an honest result</a:t>
                       </a:r>
                       <a:endParaRPr lang="en-US" sz="1200" dirty="0">
                         <a:latin typeface="Calibri" charset="0"/>
@@ -14340,7 +14429,7 @@
                           <a:ea typeface="Calibri" pitchFamily="34" charset="-122"/>
                           <a:cs typeface="Calibri" pitchFamily="34" charset="-120"/>
                         </a:rPr>
-                        <a:t>1:00</a:t>
+                        <a:t>0:50</a:t>
                       </a:r>
                       <a:endParaRPr lang="en-US" sz="1200" dirty="0">
                         <a:latin typeface="Calibri" charset="0"/>
@@ -14667,7 +14756,7 @@
                           <a:ea typeface="Calibri" pitchFamily="34" charset="-122"/>
                           <a:cs typeface="Calibri" pitchFamily="34" charset="-120"/>
                         </a:rPr>
-                        <a:t>Real sockets found what the emulator could not</a:t>
+                        <a:t>More evidence: baselines, SACK, reordering</a:t>
                       </a:r>
                       <a:endParaRPr lang="en-US" sz="1200" dirty="0">
                         <a:latin typeface="Calibri" charset="0"/>
@@ -14732,7 +14821,7 @@
                           <a:ea typeface="Calibri" pitchFamily="34" charset="-122"/>
                           <a:cs typeface="Calibri" pitchFamily="34" charset="-120"/>
                         </a:rPr>
-                        <a:t>0:50</a:t>
+                        <a:t>1:00</a:t>
                       </a:r>
                       <a:endParaRPr lang="en-US" sz="1200" dirty="0">
                         <a:latin typeface="Calibri" charset="0"/>
@@ -15059,7 +15148,7 @@
                           <a:ea typeface="Calibri" pitchFamily="34" charset="-122"/>
                           <a:cs typeface="Calibri" pitchFamily="34" charset="-120"/>
                         </a:rPr>
-                        <a:t>Safety net: hand over to AIMD</a:t>
+                        <a:t>Real sockets found what the emulator could not</a:t>
                       </a:r>
                       <a:endParaRPr lang="en-US" sz="1200" dirty="0">
                         <a:latin typeface="Calibri" charset="0"/>
@@ -15451,7 +15540,7 @@
                           <a:ea typeface="Calibri" pitchFamily="34" charset="-122"/>
                           <a:cs typeface="Calibri" pitchFamily="34" charset="-120"/>
                         </a:rPr>
-                        <a:t>Fairness, ablations, chat fixes</a:t>
+                        <a:t>Safety net: hand over to AIMD</a:t>
                       </a:r>
                       <a:endParaRPr lang="en-US" sz="1200" dirty="0">
                         <a:latin typeface="Calibri" charset="0"/>
@@ -15843,7 +15932,7 @@
                           <a:ea typeface="Calibri" pitchFamily="34" charset="-122"/>
                           <a:cs typeface="Calibri" pitchFamily="34" charset="-120"/>
                         </a:rPr>
-                        <a:t>Fairness and file transfer</a:t>
+                        <a:t>Fairness, ablations, chat fixes</a:t>
                       </a:r>
                       <a:endParaRPr lang="en-US" sz="1200" dirty="0">
                         <a:latin typeface="Calibri" charset="0"/>
@@ -16235,7 +16324,7 @@
                           <a:ea typeface="Calibri" pitchFamily="34" charset="-122"/>
                           <a:cs typeface="Calibri" pitchFamily="34" charset="-120"/>
                         </a:rPr>
-                        <a:t>Closing gaps: fairness and cross traffic</a:t>
+                        <a:t>Fairness and file transfer</a:t>
                       </a:r>
                       <a:endParaRPr lang="en-US" sz="1200" dirty="0">
                         <a:latin typeface="Calibri" charset="0"/>
@@ -16432,7 +16521,7 @@
                           <a:ea typeface="Calibri" pitchFamily="34" charset="-122"/>
                           <a:cs typeface="Calibri" pitchFamily="34" charset="-120"/>
                         </a:rPr>
-                        <a:t>The RUDP packet header: 13 bytes</a:t>
+                        <a:t>RUDP Drop: race the policies on any file</a:t>
                       </a:r>
                       <a:endParaRPr lang="en-US" sz="1200" dirty="0">
                         <a:latin typeface="Calibri" charset="0"/>
@@ -16497,7 +16586,7 @@
                           <a:ea typeface="Calibri" pitchFamily="34" charset="-122"/>
                           <a:cs typeface="Calibri" pitchFamily="34" charset="-120"/>
                         </a:rPr>
-                        <a:t>0:40</a:t>
+                        <a:t>1:00</a:t>
                       </a:r>
                       <a:endParaRPr lang="en-US" sz="1200" dirty="0">
                         <a:latin typeface="Calibri" charset="0"/>
@@ -16627,7 +16716,7 @@
                           <a:ea typeface="Calibri" pitchFamily="34" charset="-122"/>
                           <a:cs typeface="Calibri" pitchFamily="34" charset="-120"/>
                         </a:rPr>
-                        <a:t>Limits we state openly</a:t>
+                        <a:t>Closing gaps: fairness and cross traffic</a:t>
                       </a:r>
                       <a:endParaRPr lang="en-US" sz="1200" dirty="0">
                         <a:latin typeface="Calibri" charset="0"/>
@@ -16824,7 +16913,7 @@
                           <a:ea typeface="Calibri" pitchFamily="34" charset="-122"/>
                           <a:cs typeface="Calibri" pitchFamily="34" charset="-120"/>
                         </a:rPr>
-                        <a:t>Handshake and data flow</a:t>
+                        <a:t>The RUDP packet header: 13 bytes</a:t>
                       </a:r>
                       <a:endParaRPr lang="en-US" sz="1200" dirty="0">
                         <a:latin typeface="Calibri" charset="0"/>
@@ -16889,7 +16978,7 @@
                           <a:ea typeface="Calibri" pitchFamily="34" charset="-122"/>
                           <a:cs typeface="Calibri" pitchFamily="34" charset="-120"/>
                         </a:rPr>
-                        <a:t>0:50</a:t>
+                        <a:t>0:40</a:t>
                       </a:r>
                       <a:endParaRPr lang="en-US" sz="1200" dirty="0">
                         <a:latin typeface="Calibri" charset="0"/>
@@ -17019,7 +17108,7 @@
                           <a:ea typeface="Calibri" pitchFamily="34" charset="-122"/>
                           <a:cs typeface="Calibri" pitchFamily="34" charset="-120"/>
                         </a:rPr>
-                        <a:t>Learnings and future work</a:t>
+                        <a:t>Limits we state openly</a:t>
                       </a:r>
                       <a:endParaRPr lang="en-US" sz="1200" dirty="0">
                         <a:latin typeface="Calibri" charset="0"/>
@@ -17216,7 +17305,7 @@
                           <a:ea typeface="Calibri" pitchFamily="34" charset="-122"/>
                           <a:cs typeface="Calibri" pitchFamily="34" charset="-120"/>
                         </a:rPr>
-                        <a:t>Reliability: Go-Back-N</a:t>
+                        <a:t>Handshake and data flow</a:t>
                       </a:r>
                       <a:endParaRPr lang="en-US" sz="1200" dirty="0">
                         <a:latin typeface="Calibri" charset="0"/>
@@ -17411,7 +17500,7 @@
                           <a:ea typeface="Calibri" pitchFamily="34" charset="-122"/>
                           <a:cs typeface="Calibri" pitchFamily="34" charset="-120"/>
                         </a:rPr>
-                        <a:t>Thank you</a:t>
+                        <a:t>Learnings and future work</a:t>
                       </a:r>
                       <a:endParaRPr lang="en-US" sz="1200" dirty="0">
                         <a:latin typeface="Calibri" charset="0"/>
@@ -17476,7 +17565,7 @@
                           <a:ea typeface="Calibri" pitchFamily="34" charset="-122"/>
                           <a:cs typeface="Calibri" pitchFamily="34" charset="-120"/>
                         </a:rPr>
-                        <a:t>0:15</a:t>
+                        <a:t>0:50</a:t>
                       </a:r>
                       <a:endParaRPr lang="en-US" sz="1200" dirty="0">
                         <a:latin typeface="Calibri" charset="0"/>
@@ -17608,7 +17697,7 @@
                           <a:ea typeface="Calibri" pitchFamily="34" charset="-122"/>
                           <a:cs typeface="Calibri" pitchFamily="34" charset="-120"/>
                         </a:rPr>
-                        <a:t>Reliability: Selective Repeat (the default)</a:t>
+                        <a:t>Reliability: Go-Back-N</a:t>
                       </a:r>
                       <a:endParaRPr lang="en-US" sz="1200" dirty="0">
                         <a:latin typeface="Calibri" charset="0"/>
@@ -17803,7 +17892,7 @@
                           <a:ea typeface="Calibri" pitchFamily="34" charset="-122"/>
                           <a:cs typeface="Calibri" pitchFamily="34" charset="-120"/>
                         </a:rPr>
-                        <a:t>Appendix: slow start and congestion avoidance</a:t>
+                        <a:t>Thank you</a:t>
                       </a:r>
                       <a:endParaRPr lang="en-US" sz="1200" dirty="0">
                         <a:latin typeface="Calibri" charset="0"/>
@@ -17868,7 +17957,7 @@
                           <a:ea typeface="Calibri" pitchFamily="34" charset="-122"/>
                           <a:cs typeface="Calibri" pitchFamily="34" charset="-120"/>
                         </a:rPr>
-                        <a:t>-</a:t>
+                        <a:t>0:15</a:t>
                       </a:r>
                       <a:endParaRPr lang="en-US" sz="1200" dirty="0">
                         <a:latin typeface="Calibri" charset="0"/>
@@ -18000,7 +18089,7 @@
                           <a:ea typeface="Calibri" pitchFamily="34" charset="-122"/>
                           <a:cs typeface="Calibri" pitchFamily="34" charset="-120"/>
                         </a:rPr>
-                        <a:t>Congestion control: AIMD</a:t>
+                        <a:t>Reliability: Selective Repeat (the default)</a:t>
                       </a:r>
                       <a:endParaRPr lang="en-US" sz="1200" dirty="0">
                         <a:latin typeface="Calibri" charset="0"/>
@@ -18121,6 +18210,17 @@
                       <a:pPr indent="0" marL="0">
                         <a:buNone/>
                       </a:pPr>
+                      <a:r>
+                        <a:rPr lang="en-US" sz="1200" dirty="0">
+                          <a:solidFill>
+                            <a:srgbClr val="1B2430"/>
+                          </a:solidFill>
+                          <a:latin typeface="Calibri" pitchFamily="34" charset="0"/>
+                          <a:ea typeface="Calibri" pitchFamily="34" charset="-122"/>
+                          <a:cs typeface="Calibri" pitchFamily="34" charset="-120"/>
+                        </a:rPr>
+                        <a:t>44</a:t>
+                      </a:r>
                       <a:endParaRPr lang="en-US" sz="1200" dirty="0">
                         <a:latin typeface="Calibri" charset="0"/>
                         <a:ea typeface="Calibri" charset="0"/>
@@ -18175,6 +18275,17 @@
                       <a:pPr indent="0" marL="0">
                         <a:buNone/>
                       </a:pPr>
+                      <a:r>
+                        <a:rPr lang="en-US" sz="1200" dirty="0">
+                          <a:solidFill>
+                            <a:srgbClr val="1B2430"/>
+                          </a:solidFill>
+                          <a:latin typeface="Calibri" pitchFamily="34" charset="0"/>
+                          <a:ea typeface="Calibri" pitchFamily="34" charset="-122"/>
+                          <a:cs typeface="Calibri" pitchFamily="34" charset="-120"/>
+                        </a:rPr>
+                        <a:t>Appendix: slow start and congestion avoidance</a:t>
+                      </a:r>
                       <a:endParaRPr lang="en-US" sz="1200" dirty="0">
                         <a:latin typeface="Calibri" charset="0"/>
                         <a:ea typeface="Calibri" charset="0"/>
@@ -18229,6 +18340,17 @@
                       <a:pPr indent="0" marL="0">
                         <a:buNone/>
                       </a:pPr>
+                      <a:r>
+                        <a:rPr lang="en-US" sz="1200" dirty="0">
+                          <a:solidFill>
+                            <a:srgbClr val="1B2430"/>
+                          </a:solidFill>
+                          <a:latin typeface="Calibri" pitchFamily="34" charset="0"/>
+                          <a:ea typeface="Calibri" pitchFamily="34" charset="-122"/>
+                          <a:cs typeface="Calibri" pitchFamily="34" charset="-120"/>
+                        </a:rPr>
+                        <a:t>-</a:t>
+                      </a:r>
                       <a:endParaRPr lang="en-US" sz="1200" dirty="0">
                         <a:latin typeface="Calibri" charset="0"/>
                         <a:ea typeface="Calibri" charset="0"/>
@@ -18384,7 +18506,7 @@
                 <a:ea typeface="Calibri" pitchFamily="34" charset="-122"/>
                 <a:cs typeface="Calibri" pitchFamily="34" charset="-120"/>
               </a:rPr>
-              <a:t>18. The RUDP packet header: 13 bytes</a:t>
+              <a:t>18. RUDP Drop: race the policies on any file</a:t>
             </a:r>
             <a:endParaRPr lang="en-US" sz="2600" dirty="0"/>
           </a:p>
@@ -18423,7 +18545,7 @@
                 <a:ea typeface="Calibri" pitchFamily="34" charset="-122"/>
                 <a:cs typeface="Calibri" pitchFamily="34" charset="-120"/>
               </a:rPr>
-              <a:t>Time on this slide: 0:40</a:t>
+              <a:t>Time on this slide: 1:00</a:t>
             </a:r>
             <a:endParaRPr lang="en-US" sz="1300" dirty="0"/>
           </a:p>
@@ -18568,7 +18690,7 @@
               <a:buChar char="•"/>
             </a:pPr>
             <a:r>
-              <a:rPr lang="en-US" sz="1600" dirty="0">
+              <a:rPr lang="en-US" sz="1400" dirty="0">
                 <a:solidFill>
                   <a:srgbClr val="1B2430"/>
                 </a:solidFill>
@@ -18576,9 +18698,9 @@
                 <a:ea typeface="Calibri" pitchFamily="34" charset="-122"/>
                 <a:cs typeface="Calibri" pitchFamily="34" charset="-120"/>
               </a:rPr>
-              <a:t>13-byte header: sequence 4, ack 4, flags 1, checksum 2, payload length 2.</a:t>
-            </a:r>
-            <a:endParaRPr lang="en-US" sz="1600" dirty="0"/>
+              <a:t>This is an application built on our library. You drop in any file, pick a network such as lossy Wi-Fi or satellite, and it sends the file through our real C stack with three policies, one after another.</a:t>
+            </a:r>
+            <a:endParaRPr lang="en-US" sz="1400" dirty="0"/>
           </a:p>
           <a:p>
             <a:pPr marL="342900" indent="-342900">
@@ -18589,7 +18711,7 @@
               <a:buChar char="•"/>
             </a:pPr>
             <a:r>
-              <a:rPr lang="en-US" sz="1600" dirty="0">
+              <a:rPr lang="en-US" sz="1400" dirty="0">
                 <a:solidFill>
                   <a:srgbClr val="1B2430"/>
                 </a:solidFill>
@@ -18597,9 +18719,9 @@
                 <a:ea typeface="Calibri" pitchFamily="34" charset="-122"/>
                 <a:cs typeface="Calibri" pitchFamily="34" charset="-120"/>
               </a:rPr>
-              <a:t>Fields are packed byte by byte so compiler padding never changes the wire format.</a:t>
-            </a:r>
-            <a:endParaRPr lang="en-US" sz="1600" dirty="0"/>
+              <a:t>In this run a 2 MB file took 13 seconds with the neural agent and 27 and 29 seconds with the two AIMD settings. Every received copy is compared byte for byte, so you can see it is the same file.</a:t>
+            </a:r>
+            <a:endParaRPr lang="en-US" sz="1400" dirty="0"/>
           </a:p>
           <a:p>
             <a:pPr marL="342900" indent="-342900">
@@ -18610,7 +18732,7 @@
               <a:buChar char="•"/>
             </a:pPr>
             <a:r>
-              <a:rPr lang="en-US" sz="1600" dirty="0">
+              <a:rPr lang="en-US" sz="1400" dirty="0">
                 <a:solidFill>
                   <a:srgbClr val="1B2430"/>
                 </a:solidFill>
@@ -18618,9 +18740,9 @@
                 <a:ea typeface="Calibri" pitchFamily="34" charset="-122"/>
                 <a:cs typeface="Calibri" pitchFamily="34" charset="-120"/>
               </a:rPr>
-              <a:t>A data packet is 53 bytes on the wire; ACKs and handshake packets are 13.</a:t>
-            </a:r>
-            <a:endParaRPr lang="en-US" sz="1600" dirty="0"/>
+              <a:t>It is one run per policy, so small gaps are noise. The point is that the protocol is usable by an ordinary program through a small library.</a:t>
+            </a:r>
+            <a:endParaRPr lang="en-US" sz="1400" dirty="0"/>
           </a:p>
         </p:txBody>
       </p:sp>
@@ -18696,7 +18818,7 @@
                 <a:ea typeface="Calibri" pitchFamily="34" charset="-122"/>
                 <a:cs typeface="Calibri" pitchFamily="34" charset="-120"/>
               </a:rPr>
-              <a:t>Q: How does the checksum work? A: 16-bit one's-complement sum over header and payload, like UDP/TCP. A corrupted packet fails and is recovered by retransmission.</a:t>
+              <a:t>Is kernel TCP in the race? No, it cannot run through a UDP proxy. The kernel comparison is in the netem results.</a:t>
             </a:r>
             <a:endParaRPr lang="en-US" sz="1400" dirty="0"/>
           </a:p>
@@ -18767,7 +18889,7 @@
                 <a:ea typeface="Calibri" pitchFamily="34" charset="-122"/>
                 <a:cs typeface="Calibri" pitchFamily="34" charset="-120"/>
               </a:rPr>
-              <a:t>19. Handshake and data flow</a:t>
+              <a:t>19. The RUDP packet header: 13 bytes</a:t>
             </a:r>
             <a:endParaRPr lang="en-US" sz="2600" dirty="0"/>
           </a:p>
@@ -18806,7 +18928,7 @@
                 <a:ea typeface="Calibri" pitchFamily="34" charset="-122"/>
                 <a:cs typeface="Calibri" pitchFamily="34" charset="-120"/>
               </a:rPr>
-              <a:t>Time on this slide: 0:50</a:t>
+              <a:t>Time on this slide: 0:40</a:t>
             </a:r>
             <a:endParaRPr lang="en-US" sz="1300" dirty="0"/>
           </a:p>
@@ -18959,7 +19081,7 @@
                 <a:ea typeface="Calibri" pitchFamily="34" charset="-122"/>
                 <a:cs typeface="Calibri" pitchFamily="34" charset="-120"/>
               </a:rPr>
-              <a:t>Three-way handshake: SYN, SYN-ACK, ACK. Then data, up to a window of packets in flight.</a:t>
+              <a:t>13-byte header: sequence 4, ack 4, flags 1, checksum 2, payload length 2.</a:t>
             </a:r>
             <a:endParaRPr lang="en-US" sz="1600" dirty="0"/>
           </a:p>
@@ -18980,7 +19102,7 @@
                 <a:ea typeface="Calibri" pitchFamily="34" charset="-122"/>
                 <a:cs typeface="Calibri" pitchFamily="34" charset="-120"/>
               </a:rPr>
-              <a:t>ACKs are cumulative: ACK N confirms everything before N. FIN closes the connection.</a:t>
+              <a:t>Fields are packed byte by byte so compiler padding never changes the wire format.</a:t>
             </a:r>
             <a:endParaRPr lang="en-US" sz="1600" dirty="0"/>
           </a:p>
@@ -19001,7 +19123,7 @@
                 <a:ea typeface="Calibri" pitchFamily="34" charset="-122"/>
                 <a:cs typeface="Calibri" pitchFamily="34" charset="-120"/>
               </a:rPr>
-              <a:t>The server accepts a new SYN in any state, so a killed client can never leave it stuck. That was a real bug we fixed.</a:t>
+              <a:t>A data packet is 53 bytes on the wire; ACKs and handshake packets are 13.</a:t>
             </a:r>
             <a:endParaRPr lang="en-US" sz="1600" dirty="0"/>
           </a:p>
@@ -19079,7 +19201,7 @@
                 <a:ea typeface="Calibri" pitchFamily="34" charset="-122"/>
                 <a:cs typeface="Calibri" pitchFamily="34" charset="-120"/>
               </a:rPr>
-              <a:t>Q: What if the peer disappears? A: Sender keeps retransmitting on timeout. An abort after repeated timeouts is not implemented; it is the fix we would add.</a:t>
+              <a:t>Q: How does the checksum work? A: 16-bit one's-complement sum over header and payload, like UDP/TCP. A corrupted packet fails and is recovered by retransmission.</a:t>
             </a:r>
             <a:endParaRPr lang="en-US" sz="1400" dirty="0"/>
           </a:p>
@@ -19150,7 +19272,7 @@
                 <a:ea typeface="Calibri" pitchFamily="34" charset="-122"/>
                 <a:cs typeface="Calibri" pitchFamily="34" charset="-120"/>
               </a:rPr>
-              <a:t>20. Reliability: Go-Back-N</a:t>
+              <a:t>20. Handshake and data flow</a:t>
             </a:r>
             <a:endParaRPr lang="en-US" sz="2600" dirty="0"/>
           </a:p>
@@ -19342,7 +19464,7 @@
                 <a:ea typeface="Calibri" pitchFamily="34" charset="-122"/>
                 <a:cs typeface="Calibri" pitchFamily="34" charset="-120"/>
               </a:rPr>
-              <a:t>The window is the number of packets in flight; it started fixed at 4 and is now driven by the congestion window.</a:t>
+              <a:t>Three-way handshake: SYN, SYN-ACK, ACK. Then data, up to a window of packets in flight.</a:t>
             </a:r>
             <a:endParaRPr lang="en-US" sz="1600" dirty="0"/>
           </a:p>
@@ -19363,7 +19485,7 @@
                 <a:ea typeface="Calibri" pitchFamily="34" charset="-122"/>
                 <a:cs typeface="Calibri" pitchFamily="34" charset="-120"/>
               </a:rPr>
-              <a:t>Timeout is 500 ms; fast retransmit triggers after 3 duplicate ACKs, no waiting for the timer.</a:t>
+              <a:t>ACKs are cumulative: ACK N confirms everything before N. FIN closes the connection.</a:t>
             </a:r>
             <a:endParaRPr lang="en-US" sz="1600" dirty="0"/>
           </a:p>
@@ -19384,7 +19506,7 @@
                 <a:ea typeface="Calibri" pitchFamily="34" charset="-122"/>
                 <a:cs typeface="Calibri" pitchFamily="34" charset="-120"/>
               </a:rPr>
-              <a:t>Proof: in a 20% loss netem capture we saw 12 timeouts about 500 ms apart. Result: the 2,442-byte message reassembled correctly.</a:t>
+              <a:t>The server accepts a new SYN in any state, so a killed client can never leave it stuck. That was a real bug we fixed.</a:t>
             </a:r>
             <a:endParaRPr lang="en-US" sz="1600" dirty="0"/>
           </a:p>
@@ -19462,7 +19584,7 @@
                 <a:ea typeface="Calibri" pitchFamily="34" charset="-122"/>
                 <a:cs typeface="Calibri" pitchFamily="34" charset="-120"/>
               </a:rPr>
-              <a:t>Q: Why Go-Back-N? A: Simpler to build and explain. It wastes bandwidth under loss; Selective Repeat with SACK is our stated future work.</a:t>
+              <a:t>Q: What if the peer disappears? A: Sender keeps retransmitting on timeout. An abort after repeated timeouts is not implemented; it is the fix we would add.</a:t>
             </a:r>
             <a:endParaRPr lang="en-US" sz="1400" dirty="0"/>
           </a:p>
@@ -19533,7 +19655,7 @@
                 <a:ea typeface="Calibri" pitchFamily="34" charset="-122"/>
                 <a:cs typeface="Calibri" pitchFamily="34" charset="-120"/>
               </a:rPr>
-              <a:t>21. Reliability: Selective Repeat (the default)</a:t>
+              <a:t>21. Reliability: Go-Back-N</a:t>
             </a:r>
             <a:endParaRPr lang="en-US" sz="2600" dirty="0"/>
           </a:p>
@@ -19717,7 +19839,7 @@
               <a:buChar char="•"/>
             </a:pPr>
             <a:r>
-              <a:rPr lang="en-US" sz="1400" dirty="0">
+              <a:rPr lang="en-US" sz="1600" dirty="0">
                 <a:solidFill>
                   <a:srgbClr val="1B2430"/>
                 </a:solidFill>
@@ -19725,9 +19847,9 @@
                 <a:ea typeface="Calibri" pitchFamily="34" charset="-122"/>
                 <a:cs typeface="Calibri" pitchFamily="34" charset="-120"/>
               </a:rPr>
-              <a:t>We swapped Go-Back-N for Selective Repeat as the default. The receiver now keeps out-of-order packets and tells the sender exactly which ones it holds in a bitmap inside every ACK; the sender has one timer per packet and resends only what is missing.</a:t>
-            </a:r>
-            <a:endParaRPr lang="en-US" sz="1400" dirty="0"/>
+              <a:t>The window is the number of packets in flight; it started fixed at 4 and is now driven by the congestion window.</a:t>
+            </a:r>
+            <a:endParaRPr lang="en-US" sz="1600" dirty="0"/>
           </a:p>
           <a:p>
             <a:pPr marL="342900" indent="-342900">
@@ -19738,7 +19860,7 @@
               <a:buChar char="•"/>
             </a:pPr>
             <a:r>
-              <a:rPr lang="en-US" sz="1400" dirty="0">
+              <a:rPr lang="en-US" sz="1600" dirty="0">
                 <a:solidFill>
                   <a:srgbClr val="1B2430"/>
                 </a:solidFill>
@@ -19746,9 +19868,9 @@
                 <a:ea typeface="Calibri" pitchFamily="34" charset="-122"/>
                 <a:cs typeface="Calibri" pitchFamily="34" charset="-120"/>
               </a:rPr>
-              <a:t>The result: about ten times fewer retransmissions, and the neural agent's lead over AIMD grows to 46 percent on the lossy path and 50 percent on the satellite path.</a:t>
-            </a:r>
-            <a:endParaRPr lang="en-US" sz="1400" dirty="0"/>
+              <a:t>Timeout is 500 ms; fast retransmit triggers after 3 duplicate ACKs, no waiting for the timer.</a:t>
+            </a:r>
+            <a:endParaRPr lang="en-US" sz="1600" dirty="0"/>
           </a:p>
           <a:p>
             <a:pPr marL="342900" indent="-342900">
@@ -19759,7 +19881,7 @@
               <a:buChar char="•"/>
             </a:pPr>
             <a:r>
-              <a:rPr lang="en-US" sz="1400" dirty="0">
+              <a:rPr lang="en-US" sz="1600" dirty="0">
                 <a:solidFill>
                   <a:srgbClr val="1B2430"/>
                 </a:solidFill>
@@ -19767,30 +19889,9 @@
                 <a:ea typeface="Calibri" pitchFamily="34" charset="-122"/>
                 <a:cs typeface="Calibri" pitchFamily="34" charset="-120"/>
               </a:rPr>
-              <a:t>The 10 percent loss failure we found earlier was mostly a Go-Back-N effect: with Selective Repeat the agent ties AIMD there.</a:t>
-            </a:r>
-            <a:endParaRPr lang="en-US" sz="1400" dirty="0"/>
-          </a:p>
-          <a:p>
-            <a:pPr marL="342900" indent="-342900">
-              <a:spcAft>
-                <a:spcPts val="600"/>
-              </a:spcAft>
-              <a:buSzPct val="100000"/>
-              <a:buChar char="•"/>
-            </a:pPr>
-            <a:r>
-              <a:rPr lang="en-US" sz="1400" dirty="0">
-                <a:solidFill>
-                  <a:srgbClr val="1B2430"/>
-                </a:solidFill>
-                <a:latin typeface="Calibri" pitchFamily="34" charset="0"/>
-                <a:ea typeface="Calibri" pitchFamily="34" charset="-122"/>
-                <a:cs typeface="Calibri" pitchFamily="34" charset="-120"/>
-              </a:rPr>
-              <a:t>Go-Back-N is still in the code behind a flag, and the earlier tables in the report were measured with it and are labelled that way.</a:t>
-            </a:r>
-            <a:endParaRPr lang="en-US" sz="1400" dirty="0"/>
+              <a:t>Proof: in a 20% loss netem capture we saw 12 timeouts about 500 ms apart. Result: the 2,442-byte message reassembled correctly.</a:t>
+            </a:r>
+            <a:endParaRPr lang="en-US" sz="1600" dirty="0"/>
           </a:p>
         </p:txBody>
       </p:sp>
@@ -19866,7 +19967,7 @@
                 <a:ea typeface="Calibri" pitchFamily="34" charset="-122"/>
                 <a:cs typeface="Calibri" pitchFamily="34" charset="-120"/>
               </a:rPr>
-              <a:t>Is it textbook Selective Repeat? Nearly: per-packet timers and a buffering receiver, but we use a cumulative ACK plus a 64-bit bitmap instead of one ACK per packet, and the window is capped at 60.</a:t>
+              <a:t>Q: Why Go-Back-N? A: Simpler to build and explain. It wastes bandwidth under loss; Selective Repeat with SACK is our stated future work.</a:t>
             </a:r>
             <a:endParaRPr lang="en-US" sz="1400" dirty="0"/>
           </a:p>
@@ -19937,7 +20038,7 @@
                 <a:ea typeface="Calibri" pitchFamily="34" charset="-122"/>
                 <a:cs typeface="Calibri" pitchFamily="34" charset="-120"/>
               </a:rPr>
-              <a:t>22. Congestion control: AIMD</a:t>
+              <a:t>22. Reliability: Selective Repeat (the default)</a:t>
             </a:r>
             <a:endParaRPr lang="en-US" sz="2600" dirty="0"/>
           </a:p>
@@ -20121,7 +20222,7 @@
               <a:buChar char="•"/>
             </a:pPr>
             <a:r>
-              <a:rPr lang="en-US" sz="1600" dirty="0">
+              <a:rPr lang="en-US" sz="1400" dirty="0">
                 <a:solidFill>
                   <a:srgbClr val="1B2430"/>
                 </a:solidFill>
@@ -20129,9 +20230,9 @@
                 <a:ea typeface="Calibri" pitchFamily="34" charset="-122"/>
                 <a:cs typeface="Calibri" pitchFamily="34" charset="-120"/>
               </a:rPr>
-              <a:t>Slow start: window grows by one per ACK until the threshold of 16. Then avoidance: plus 1/window per ACK.</a:t>
-            </a:r>
-            <a:endParaRPr lang="en-US" sz="1600" dirty="0"/>
+              <a:t>We swapped Go-Back-N for Selective Repeat as the default. The receiver now keeps out-of-order packets and tells the sender exactly which ones it holds in a bitmap inside every ACK; the sender has one timer per packet and resends only what is missing.</a:t>
+            </a:r>
+            <a:endParaRPr lang="en-US" sz="1400" dirty="0"/>
           </a:p>
           <a:p>
             <a:pPr marL="342900" indent="-342900">
@@ -20142,7 +20243,7 @@
               <a:buChar char="•"/>
             </a:pPr>
             <a:r>
-              <a:rPr lang="en-US" sz="1600" dirty="0">
+              <a:rPr lang="en-US" sz="1400" dirty="0">
                 <a:solidFill>
                   <a:srgbClr val="1B2430"/>
                 </a:solidFill>
@@ -20150,9 +20251,9 @@
                 <a:ea typeface="Calibri" pitchFamily="34" charset="-122"/>
                 <a:cs typeface="Calibri" pitchFamily="34" charset="-120"/>
               </a:rPr>
-              <a:t>Three duplicate ACKs: window halves. A timeout: window resets to 1 and the threshold halves. Cap is 32.</a:t>
-            </a:r>
-            <a:endParaRPr lang="en-US" sz="1600" dirty="0"/>
+              <a:t>The result: about ten times fewer retransmissions, and the neural agent's lead over AIMD grows to 46 percent on the lossy path and 50 percent on the satellite path.</a:t>
+            </a:r>
+            <a:endParaRPr lang="en-US" sz="1400" dirty="0"/>
           </a:p>
           <a:p>
             <a:pPr marL="342900" indent="-342900">
@@ -20163,7 +20264,7 @@
               <a:buChar char="•"/>
             </a:pPr>
             <a:r>
-              <a:rPr lang="en-US" sz="1600" dirty="0">
+              <a:rPr lang="en-US" sz="1400" dirty="0">
                 <a:solidFill>
                   <a:srgbClr val="1B2430"/>
                 </a:solidFill>
@@ -20171,9 +20272,30 @@
                 <a:ea typeface="Calibri" pitchFamily="34" charset="-122"/>
                 <a:cs typeface="Calibri" pitchFamily="34" charset="-120"/>
               </a:rPr>
-              <a:t>The graph shows fresh runs at 0, 10, 20 and 40 percent loss. Red marks are timeouts, green are fast retransmits.</a:t>
-            </a:r>
-            <a:endParaRPr lang="en-US" sz="1600" dirty="0"/>
+              <a:t>The 10 percent loss failure we found earlier was mostly a Go-Back-N effect: with Selective Repeat the agent ties AIMD there.</a:t>
+            </a:r>
+            <a:endParaRPr lang="en-US" sz="1400" dirty="0"/>
+          </a:p>
+          <a:p>
+            <a:pPr marL="342900" indent="-342900">
+              <a:spcAft>
+                <a:spcPts val="600"/>
+              </a:spcAft>
+              <a:buSzPct val="100000"/>
+              <a:buChar char="•"/>
+            </a:pPr>
+            <a:r>
+              <a:rPr lang="en-US" sz="1400" dirty="0">
+                <a:solidFill>
+                  <a:srgbClr val="1B2430"/>
+                </a:solidFill>
+                <a:latin typeface="Calibri" pitchFamily="34" charset="0"/>
+                <a:ea typeface="Calibri" pitchFamily="34" charset="-122"/>
+                <a:cs typeface="Calibri" pitchFamily="34" charset="-120"/>
+              </a:rPr>
+              <a:t>Go-Back-N is still in the code behind a flag, and the earlier tables in the report were measured with it and are labelled that way.</a:t>
+            </a:r>
+            <a:endParaRPr lang="en-US" sz="1400" dirty="0"/>
           </a:p>
         </p:txBody>
       </p:sp>
@@ -20249,7 +20371,7 @@
                 <a:ea typeface="Calibri" pitchFamily="34" charset="-122"/>
                 <a:cs typeface="Calibri" pitchFamily="34" charset="-120"/>
               </a:rPr>
-              <a:t>Q: Why cap 32 and ssthresh 16? A: The cap stops a lossless run growing without bound; 16 is where doubling switches to linear growth.</a:t>
+              <a:t>Is it textbook Selective Repeat? Nearly: per-packet timers and a buffering receiver, but we use a cumulative ACK plus a 64-bit bitmap instead of one ACK per packet, and the window is capped at 60.</a:t>
             </a:r>
             <a:endParaRPr lang="en-US" sz="1400" dirty="0"/>
           </a:p>
@@ -20320,7 +20442,7 @@
                 <a:ea typeface="Calibri" pitchFamily="34" charset="-122"/>
                 <a:cs typeface="Calibri" pitchFamily="34" charset="-120"/>
               </a:rPr>
-              <a:t>23. Smart-RUDP: a Q-learning window controller</a:t>
+              <a:t>23. Congestion control: AIMD</a:t>
             </a:r>
             <a:endParaRPr lang="en-US" sz="2600" dirty="0"/>
           </a:p>
@@ -20512,7 +20634,7 @@
                 <a:ea typeface="Calibri" pitchFamily="34" charset="-122"/>
                 <a:cs typeface="Calibri" pitchFamily="34" charset="-120"/>
               </a:rPr>
-              <a:t>Q-learning with 80 states (RTT ratio, loss fraction, window size), sampled once per RTT.</a:t>
+              <a:t>Slow start: window grows by one per ACK until the threshold of 16. Then avoidance: plus 1/window per ACK.</a:t>
             </a:r>
             <a:endParaRPr lang="en-US" sz="1600" dirty="0"/>
           </a:p>
@@ -20533,7 +20655,7 @@
                 <a:ea typeface="Calibri" pitchFamily="34" charset="-122"/>
                 <a:cs typeface="Calibri" pitchFamily="34" charset="-120"/>
               </a:rPr>
-              <a:t>Five actions: multiply the window by 0.5, 0.85, 1.0, 1.15 or 1.5.</a:t>
+              <a:t>Three duplicate ACKs: window halves. A timeout: window resets to 1 and the threshold halves. Cap is 32.</a:t>
             </a:r>
             <a:endParaRPr lang="en-US" sz="1600" dirty="0"/>
           </a:p>
@@ -20554,7 +20676,7 @@
                 <a:ea typeface="Calibri" pitchFamily="34" charset="-122"/>
                 <a:cs typeface="Calibri" pitchFamily="34" charset="-120"/>
               </a:rPr>
-              <a:t>Reward: throughput gained, minus delay growth, minus retransmissions. Same Go-Back-N reliability; only the window policy changes. Paths are emulated in the program: 5G-like, lossy wireless, satellite-like.</a:t>
+              <a:t>The graph shows fresh runs at 0, 10, 20 and 40 percent loss. Red marks are timeouts, green are fast retransmits.</a:t>
             </a:r>
             <a:endParaRPr lang="en-US" sz="1600" dirty="0"/>
           </a:p>
@@ -20632,7 +20754,7 @@
                 <a:ea typeface="Calibri" pitchFamily="34" charset="-122"/>
                 <a:cs typeface="Calibri" pitchFamily="34" charset="-120"/>
               </a:rPr>
-              <a:t>Q: Is it really learning? A: Yes, 40 training episodes; the learning-curve figure shows it. It is small and tabular with limited training.</a:t>
+              <a:t>Q: Why cap 32 and ssthresh 16? A: The cap stops a lossless run growing without bound; 16 is where doubling switches to linear growth.</a:t>
             </a:r>
             <a:endParaRPr lang="en-US" sz="1400" dirty="0"/>
           </a:p>
@@ -20703,7 +20825,7 @@
                 <a:ea typeface="Calibri" pitchFamily="34" charset="-122"/>
                 <a:cs typeface="Calibri" pitchFamily="34" charset="-120"/>
               </a:rPr>
-              <a:t>24. The AI agent in our code</a:t>
+              <a:t>24. Smart-RUDP: a Q-learning window controller</a:t>
             </a:r>
             <a:endParaRPr lang="en-US" sz="2600" dirty="0"/>
           </a:p>
@@ -20742,7 +20864,7 @@
                 <a:ea typeface="Calibri" pitchFamily="34" charset="-122"/>
                 <a:cs typeface="Calibri" pitchFamily="34" charset="-120"/>
               </a:rPr>
-              <a:t>Time on this slide: 1:00</a:t>
+              <a:t>Time on this slide: 0:50</a:t>
             </a:r>
             <a:endParaRPr lang="en-US" sz="1300" dirty="0"/>
           </a:p>
@@ -20887,7 +21009,7 @@
               <a:buChar char="•"/>
             </a:pPr>
             <a:r>
-              <a:rPr lang="en-US" sz="1400" dirty="0">
+              <a:rPr lang="en-US" sz="1600" dirty="0">
                 <a:solidFill>
                   <a:srgbClr val="1B2430"/>
                 </a:solidFill>
@@ -20895,9 +21017,9 @@
                 <a:ea typeface="Calibri" pitchFamily="34" charset="-122"/>
                 <a:cs typeface="Calibri" pitchFamily="34" charset="-120"/>
               </a:rPr>
-              <a:t>This is the agent itself. Left: rl_cc.h, 73 lines of C. The state is 80 buckets of RTT ratio, loss and window size.</a:t>
-            </a:r>
-            <a:endParaRPr lang="en-US" sz="1400" dirty="0"/>
+              <a:t>Q-learning with 80 states (RTT ratio, loss fraction, window size), sampled once per RTT.</a:t>
+            </a:r>
+            <a:endParaRPr lang="en-US" sz="1600" dirty="0"/>
           </a:p>
           <a:p>
             <a:pPr marL="342900" indent="-342900">
@@ -20908,7 +21030,7 @@
               <a:buChar char="•"/>
             </a:pPr>
             <a:r>
-              <a:rPr lang="en-US" sz="1400" dirty="0">
+              <a:rPr lang="en-US" sz="1600" dirty="0">
                 <a:solidFill>
                   <a:srgbClr val="1B2430"/>
                 </a:solidFill>
@@ -20916,9 +21038,9 @@
                 <a:ea typeface="Calibri" pitchFamily="34" charset="-122"/>
                 <a:cs typeface="Calibri" pitchFamily="34" charset="-120"/>
               </a:rPr>
-              <a:t>choose picks one of five window multipliers, usually the best, sometimes random so it keeps exploring.</a:t>
-            </a:r>
-            <a:endParaRPr lang="en-US" sz="1400" dirty="0"/>
+              <a:t>Five actions: multiply the window by 0.5, 0.85, 1.0, 1.15 or 1.5.</a:t>
+            </a:r>
+            <a:endParaRPr lang="en-US" sz="1600" dirty="0"/>
           </a:p>
           <a:p>
             <a:pPr marL="342900" indent="-342900">
@@ -20929,7 +21051,7 @@
               <a:buChar char="•"/>
             </a:pPr>
             <a:r>
-              <a:rPr lang="en-US" sz="1400" dirty="0">
+              <a:rPr lang="en-US" sz="1600" dirty="0">
                 <a:solidFill>
                   <a:srgbClr val="1B2430"/>
                 </a:solidFill>
@@ -20937,72 +21059,9 @@
                 <a:ea typeface="Calibri" pitchFamily="34" charset="-122"/>
                 <a:cs typeface="Calibri" pitchFamily="34" charset="-120"/>
               </a:rPr>
-              <a:t>update is the Q-learning rule: move the value of the action we took toward the reward plus the best value of the next state.</a:t>
-            </a:r>
-            <a:endParaRPr lang="en-US" sz="1400" dirty="0"/>
-          </a:p>
-          <a:p>
-            <a:pPr marL="342900" indent="-342900">
-              <a:spcAft>
-                <a:spcPts val="600"/>
-              </a:spcAft>
-              <a:buSzPct val="100000"/>
-              <a:buChar char="•"/>
-            </a:pPr>
-            <a:r>
-              <a:rPr lang="en-US" sz="1400" dirty="0">
-                <a:solidFill>
-                  <a:srgbClr val="1B2430"/>
-                </a:solidFill>
-                <a:latin typeface="Calibri" pitchFamily="34" charset="0"/>
-                <a:ea typeface="Calibri" pitchFamily="34" charset="-122"/>
-                <a:cs typeface="Calibri" pitchFamily="34" charset="-120"/>
-              </a:rPr>
-              <a:t>Right: the loop in smart_client.c. Once per RTT it computes the reward, throughput minus delay growth minus loss, updates the table, picks the next action and scales the window.</a:t>
-            </a:r>
-            <a:endParaRPr lang="en-US" sz="1400" dirty="0"/>
-          </a:p>
-          <a:p>
-            <a:pPr marL="342900" indent="-342900">
-              <a:spcAft>
-                <a:spcPts val="600"/>
-              </a:spcAft>
-              <a:buSzPct val="100000"/>
-              <a:buChar char="•"/>
-            </a:pPr>
-            <a:r>
-              <a:rPr lang="en-US" sz="1400" dirty="0">
-                <a:solidFill>
-                  <a:srgbClr val="1B2430"/>
-                </a:solidFill>
-                <a:latin typeface="Calibri" pitchFamily="34" charset="0"/>
-                <a:ea typeface="Calibri" pitchFamily="34" charset="-122"/>
-                <a:cs typeface="Calibri" pitchFamily="34" charset="-120"/>
-              </a:rPr>
-              <a:t>The code on the slide is simplified; the real files are in the repo.</a:t>
-            </a:r>
-            <a:endParaRPr lang="en-US" sz="1400" dirty="0"/>
-          </a:p>
-          <a:p>
-            <a:pPr marL="342900" indent="-342900">
-              <a:spcAft>
-                <a:spcPts val="600"/>
-              </a:spcAft>
-              <a:buSzPct val="100000"/>
-              <a:buChar char="•"/>
-            </a:pPr>
-            <a:r>
-              <a:rPr lang="en-US" sz="1400" dirty="0">
-                <a:solidFill>
-                  <a:srgbClr val="1B2430"/>
-                </a:solidFill>
-                <a:latin typeface="Calibri" pitchFamily="34" charset="0"/>
-                <a:ea typeface="Calibri" pitchFamily="34" charset="-122"/>
-                <a:cs typeface="Calibri" pitchFamily="34" charset="-120"/>
-              </a:rPr>
-              <a:t>We also built a deep version: web/dqn.py is a small neural network, two hidden layers of 32, trained with DQN in the same simulator. It reads continuous inputs instead of buckets.</a:t>
-            </a:r>
-            <a:endParaRPr lang="en-US" sz="1400" dirty="0"/>
+              <a:t>Reward: throughput gained, minus delay growth, minus retransmissions. Same Go-Back-N reliability; only the window policy changes. Paths are emulated in the program: 5G-like, lossy wireless, satellite-like.</a:t>
+            </a:r>
+            <a:endParaRPr lang="en-US" sz="1600" dirty="0"/>
           </a:p>
         </p:txBody>
       </p:sp>
@@ -21078,7 +21137,7 @@
                 <a:ea typeface="Calibri" pitchFamily="34" charset="-122"/>
                 <a:cs typeface="Calibri" pitchFamily="34" charset="-120"/>
               </a:rPr>
-              <a:t>Q: Is this deep RL? A: The C agent is tabular. The chat also has a deep agent, a small DQN in numpy (5-32-32-5). Q: Does deep beat the table? A: Modestly: 3.20 s vs 3.73 s mean on 48 unseen paths, faster on 19, slower on 6. Q: Any problem? A: Training is seed-sensitive: 1 of 4 seeds failed, so we select on validation paths. It is simulated and not in the C code. Q: Where is it trained? A: web/train.py for the chat, the smart client trains online for the main experiments; table in results/q_chat.txt.</a:t>
+              <a:t>Q: Is it really learning? A: Yes, 40 training episodes; the learning-curve figure shows it. It is small and tabular with limited training.</a:t>
             </a:r>
             <a:endParaRPr lang="en-US" sz="1400" dirty="0"/>
           </a:p>
@@ -21149,7 +21208,7 @@
                 <a:ea typeface="Calibri" pitchFamily="34" charset="-122"/>
                 <a:cs typeface="Calibri" pitchFamily="34" charset="-120"/>
               </a:rPr>
-              <a:t>25. Neural agent in the C transport</a:t>
+              <a:t>25. The AI agent in our code</a:t>
             </a:r>
             <a:endParaRPr lang="en-US" sz="2600" dirty="0"/>
           </a:p>
@@ -21341,7 +21400,7 @@
                 <a:ea typeface="Calibri" pitchFamily="34" charset="-122"/>
                 <a:cs typeface="Calibri" pitchFamily="34" charset="-120"/>
               </a:rPr>
-              <a:t>We then put the neural agent into the C transport, the same code as Section 8, and tested it on the same three emulated paths with 15 runs each.</a:t>
+              <a:t>This is the agent itself. Left: rl_cc.h, 73 lines of C. The state is 80 buckets of RTT ratio, loss and window size.</a:t>
             </a:r>
             <a:endParaRPr lang="en-US" sz="1400" dirty="0"/>
           </a:p>
@@ -21362,7 +21421,7 @@
                 <a:ea typeface="Calibri" pitchFamily="34" charset="-122"/>
                 <a:cs typeface="Calibri" pitchFamily="34" charset="-120"/>
               </a:rPr>
-              <a:t>AIMD and the agents all start from a window of 10. The neural agent was faster than AIMD on all three: 15 percent on 5G-like, 27 percent on lossy, 24 percent on satellite-like. The intervals exclude zero.</a:t>
+              <a:t>choose picks one of five window multipliers, usually the best, sometimes random so it keeps exploring.</a:t>
             </a:r>
             <a:endParaRPr lang="en-US" sz="1400" dirty="0"/>
           </a:p>
@@ -21383,7 +21442,7 @@
                 <a:ea typeface="Calibri" pitchFamily="34" charset="-122"/>
                 <a:cs typeface="Calibri" pitchFamily="34" charset="-120"/>
               </a:rPr>
-              <a:t>The retrained table did not carry over: it was slower on 5G and satellite. A network generalises to unseen paths where a table does not.</a:t>
+              <a:t>update is the Q-learning rule: move the value of the action we took toward the reward plus the best value of the next state.</a:t>
             </a:r>
             <a:endParaRPr lang="en-US" sz="1400" dirty="0"/>
           </a:p>
@@ -21404,7 +21463,7 @@
                 <a:ea typeface="Calibri" pitchFamily="34" charset="-122"/>
                 <a:cs typeface="Calibri" pitchFamily="34" charset="-120"/>
               </a:rPr>
-              <a:t>We also added selective acknowledgments to the C code: about ten times fewer retransmissions, but no significant change in completion time on these emulated paths.</a:t>
+              <a:t>Right: the loop in smart_client.c. Once per RTT it computes the reward, throughput minus delay growth minus loss, updates the table, picks the next action and scales the window.</a:t>
             </a:r>
             <a:endParaRPr lang="en-US" sz="1400" dirty="0"/>
           </a:p>
@@ -21425,7 +21484,28 @@
                 <a:ea typeface="Calibri" pitchFamily="34" charset="-122"/>
                 <a:cs typeface="Calibri" pitchFamily="34" charset="-120"/>
               </a:rPr>
-              <a:t>We also reran it with AIMD capped at 32 like the agent: the neural agent still wins by 19, 29 and 28 percent, all significant.</a:t>
+              <a:t>The code on the slide is simplified; the real files are in the repo.</a:t>
+            </a:r>
+            <a:endParaRPr lang="en-US" sz="1400" dirty="0"/>
+          </a:p>
+          <a:p>
+            <a:pPr marL="342900" indent="-342900">
+              <a:spcAft>
+                <a:spcPts val="600"/>
+              </a:spcAft>
+              <a:buSzPct val="100000"/>
+              <a:buChar char="•"/>
+            </a:pPr>
+            <a:r>
+              <a:rPr lang="en-US" sz="1400" dirty="0">
+                <a:solidFill>
+                  <a:srgbClr val="1B2430"/>
+                </a:solidFill>
+                <a:latin typeface="Calibri" pitchFamily="34" charset="0"/>
+                <a:ea typeface="Calibri" pitchFamily="34" charset="-122"/>
+                <a:cs typeface="Calibri" pitchFamily="34" charset="-120"/>
+              </a:rPr>
+              <a:t>We also built a deep version: web/dqn.py is a small neural network, two hidden layers of 32, trained with DQN in the same simulator. It reads continuous inputs instead of buckets.</a:t>
             </a:r>
             <a:endParaRPr lang="en-US" sz="1400" dirty="0"/>
           </a:p>
@@ -21503,7 +21583,7 @@
                 <a:ea typeface="Calibri" pitchFamily="34" charset="-122"/>
                 <a:cs typeface="Calibri" pitchFamily="34" charset="-120"/>
               </a:rPr>
-              <a:t>Q: So Smart-RUDP now beats AIMD? A: The neural version does, in the C transport on emulated paths, trained in a simulator; the original table agent in Section 8 did not. Q: Is it fair? A: Same start window; AIMD keeps a cap of 128 while the agents are capped at 32; the agent retransmits more on random loss. Q: Why no gain from SACK? A: Those paths are limited by the bottleneck rate, so extra retransmissions cost little; the simulator, with different paths, showed a large gain.</a:t>
+              <a:t>Q: Is this deep RL? A: The C agent is tabular. The chat also has a deep agent, a small DQN in numpy (5-32-32-5). Q: Does deep beat the table? A: Modestly: 3.20 s vs 3.73 s mean on 48 unseen paths, faster on 19, slower on 6. Q: Any problem? A: Training is seed-sensitive: 1 of 4 seeds failed, so we select on validation paths. It is simulated and not in the C code. Q: Where is it trained? A: web/train.py for the chat, the smart client trains online for the main experiments; table in results/q_chat.txt.</a:t>
             </a:r>
             <a:endParaRPr lang="en-US" sz="1400" dirty="0"/>
           </a:p>
@@ -21574,7 +21654,7 @@
                 <a:ea typeface="Calibri" pitchFamily="34" charset="-122"/>
                 <a:cs typeface="Calibri" pitchFamily="34" charset="-120"/>
               </a:rPr>
-              <a:t>26. Literature behind the design</a:t>
+              <a:t>26. Neural agent in the C transport</a:t>
             </a:r>
             <a:endParaRPr lang="en-US" sz="2600" dirty="0"/>
           </a:p>
@@ -21613,7 +21693,7 @@
                 <a:ea typeface="Calibri" pitchFamily="34" charset="-122"/>
                 <a:cs typeface="Calibri" pitchFamily="34" charset="-120"/>
               </a:rPr>
-              <a:t>Time on this slide: 0:30</a:t>
+              <a:t>Time on this slide: 1:00</a:t>
             </a:r>
             <a:endParaRPr lang="en-US" sz="1300" dirty="0"/>
           </a:p>
@@ -21766,7 +21846,7 @@
                 <a:ea typeface="Calibri" pitchFamily="34" charset="-122"/>
                 <a:cs typeface="Calibri" pitchFamily="34" charset="-120"/>
               </a:rPr>
-              <a:t>Jacobson and Karels 1988 is the origin of AIMD; Chiu and Jain 1989 explains why it converges fairly.</a:t>
+              <a:t>We then put the neural agent into the C transport, the same code as Section 8, and tested it on the same three emulated paths with 15 runs each.</a:t>
             </a:r>
             <a:endParaRPr lang="en-US" sz="1400" dirty="0"/>
           </a:p>
@@ -21787,7 +21867,7 @@
                 <a:ea typeface="Calibri" pitchFamily="34" charset="-122"/>
                 <a:cs typeface="Calibri" pitchFamily="34" charset="-120"/>
               </a:rPr>
-              <a:t>RFC 5681 is the standard; CUBIC is future work; QUIC and RFC 9000 are reliable transport over UDP in production.</a:t>
+              <a:t>AIMD and the agents all start from a window of 10. The neural agent was faster than AIMD on all three: 15 percent on 5G-like, 27 percent on lossy, 24 percent on satellite-like. The intervals exclude zero.</a:t>
             </a:r>
             <a:endParaRPr lang="en-US" sz="1400" dirty="0"/>
           </a:p>
@@ -21808,7 +21888,7 @@
                 <a:ea typeface="Calibri" pitchFamily="34" charset="-122"/>
                 <a:cs typeface="Calibri" pitchFamily="34" charset="-120"/>
               </a:rPr>
-              <a:t>The AI part comes from Midhula and Arun Raj Kumar (2024) and Cao et al. (2023, DRLFcc): deep reinforcement learning for congestion control. Smart-RUDP applies the same idea with a smaller tabular Q-learning agent.</a:t>
+              <a:t>The retrained table did not carry over: it was slower on 5G and satellite. A network generalises to unseen paths where a table does not.</a:t>
             </a:r>
             <a:endParaRPr lang="en-US" sz="1400" dirty="0"/>
           </a:p>
@@ -21829,7 +21909,28 @@
                 <a:ea typeface="Calibri" pitchFamily="34" charset="-122"/>
                 <a:cs typeface="Calibri" pitchFamily="34" charset="-120"/>
               </a:rPr>
-              <a:t>Key researcher: Van Jacobson.</a:t>
+              <a:t>We also added selective acknowledgments to the C code: about ten times fewer retransmissions, but no significant change in completion time on these emulated paths.</a:t>
+            </a:r>
+            <a:endParaRPr lang="en-US" sz="1400" dirty="0"/>
+          </a:p>
+          <a:p>
+            <a:pPr marL="342900" indent="-342900">
+              <a:spcAft>
+                <a:spcPts val="600"/>
+              </a:spcAft>
+              <a:buSzPct val="100000"/>
+              <a:buChar char="•"/>
+            </a:pPr>
+            <a:r>
+              <a:rPr lang="en-US" sz="1400" dirty="0">
+                <a:solidFill>
+                  <a:srgbClr val="1B2430"/>
+                </a:solidFill>
+                <a:latin typeface="Calibri" pitchFamily="34" charset="0"/>
+                <a:ea typeface="Calibri" pitchFamily="34" charset="-122"/>
+                <a:cs typeface="Calibri" pitchFamily="34" charset="-120"/>
+              </a:rPr>
+              <a:t>We also reran it with AIMD capped at 32 like the agent: the neural agent still wins by 19, 29 and 28 percent, all significant.</a:t>
             </a:r>
             <a:endParaRPr lang="en-US" sz="1400" dirty="0"/>
           </a:p>
@@ -21907,7 +22008,7 @@
                 <a:ea typeface="Calibri" pitchFamily="34" charset="-122"/>
                 <a:cs typeface="Calibri" pitchFamily="34" charset="-120"/>
               </a:rPr>
-              <a:t>Q: Why AIMD? A: Chiu and Jain show it converges to a fair share. Q: Are those papers deep RL and yours is not? A: Yes; we used a lookup table, which is simpler and inspectable.</a:t>
+              <a:t>Q: So Smart-RUDP now beats AIMD? A: The neural version does, in the C transport on emulated paths, trained in a simulator; the original table agent in Section 8 did not. Q: Is it fair? A: Same start window; AIMD keeps a cap of 128 while the agents are capped at 32; the agent retransmits more on random loss. Q: Why no gain from SACK? A: Those paths are limited by the bottleneck rate, so extra retransmissions cost little; the simulator, with different paths, showed a large gain.</a:t>
             </a:r>
             <a:endParaRPr lang="en-US" sz="1400" dirty="0"/>
           </a:p>
@@ -21978,7 +22079,7 @@
                 <a:ea typeface="Calibri" pitchFamily="34" charset="-122"/>
                 <a:cs typeface="Calibri" pitchFamily="34" charset="-120"/>
               </a:rPr>
-              <a:t>27. How it was tested</a:t>
+              <a:t>27. Literature behind the design</a:t>
             </a:r>
             <a:endParaRPr lang="en-US" sz="2600" dirty="0"/>
           </a:p>
@@ -22017,7 +22118,7 @@
                 <a:ea typeface="Calibri" pitchFamily="34" charset="-122"/>
                 <a:cs typeface="Calibri" pitchFamily="34" charset="-120"/>
               </a:rPr>
-              <a:t>Time on this slide: 0:40</a:t>
+              <a:t>Time on this slide: 0:30</a:t>
             </a:r>
             <a:endParaRPr lang="en-US" sz="1300" dirty="0"/>
           </a:p>
@@ -22170,7 +22271,7 @@
                 <a:ea typeface="Calibri" pitchFamily="34" charset="-122"/>
                 <a:cs typeface="Calibri" pitchFamily="34" charset="-120"/>
               </a:rPr>
-              <a:t>Correctness first: unit, end-to-end, handshake, file-integrity, chat and simulator tests, and the packet parser is fuzzed under AddressSanitizer.</a:t>
+              <a:t>Jacobson and Karels 1988 is the origin of AIMD; Chiu and Jain 1989 explains why it converges fairly.</a:t>
             </a:r>
             <a:endParaRPr lang="en-US" sz="1400" dirty="0"/>
           </a:p>
@@ -22191,7 +22292,7 @@
                 <a:ea typeface="Calibri" pitchFamily="34" charset="-122"/>
                 <a:cs typeface="Calibri" pitchFamily="34" charset="-120"/>
               </a:rPr>
-              <a:t>For speed we use virtual time, which is the same C sender on a simulated clock. We checked it against the real clock, and it agreed in all 15 of 15 cells. We use paired seeds with 95 percent intervals and keep tuning seeds apart from test seeds.</a:t>
+              <a:t>RFC 5681 is the standard; CUBIC is future work; QUIC and RFC 9000 are reliable transport over UDP in production.</a:t>
             </a:r>
             <a:endParaRPr lang="en-US" sz="1400" dirty="0"/>
           </a:p>
@@ -22212,7 +22313,28 @@
                 <a:ea typeface="Calibri" pitchFamily="34" charset="-122"/>
                 <a:cs typeface="Calibri" pitchFamily="34" charset="-120"/>
               </a:rPr>
-              <a:t>Realism comes in four steps: emulation in the client, a separate proxy on real sockets, the Linux kernel with netem, and two laptops over the internet. Every result has its command in the report.</a:t>
+              <a:t>The AI part comes from Midhula and Arun Raj Kumar (2024) and Cao et al. (2023, DRLFcc): deep reinforcement learning for congestion control. Smart-RUDP applies the same idea with a smaller tabular Q-learning agent.</a:t>
+            </a:r>
+            <a:endParaRPr lang="en-US" sz="1400" dirty="0"/>
+          </a:p>
+          <a:p>
+            <a:pPr marL="342900" indent="-342900">
+              <a:spcAft>
+                <a:spcPts val="600"/>
+              </a:spcAft>
+              <a:buSzPct val="100000"/>
+              <a:buChar char="•"/>
+            </a:pPr>
+            <a:r>
+              <a:rPr lang="en-US" sz="1400" dirty="0">
+                <a:solidFill>
+                  <a:srgbClr val="1B2430"/>
+                </a:solidFill>
+                <a:latin typeface="Calibri" pitchFamily="34" charset="0"/>
+                <a:ea typeface="Calibri" pitchFamily="34" charset="-122"/>
+                <a:cs typeface="Calibri" pitchFamily="34" charset="-120"/>
+              </a:rPr>
+              <a:t>Key researcher: Van Jacobson.</a:t>
             </a:r>
             <a:endParaRPr lang="en-US" sz="1400" dirty="0"/>
           </a:p>
@@ -22290,7 +22412,7 @@
                 <a:ea typeface="Calibri" pitchFamily="34" charset="-122"/>
                 <a:cs typeface="Calibri" pitchFamily="34" charset="-120"/>
               </a:rPr>
-              <a:t>Did you make mistakes? Yes, and we logged them: untuned baselines, unequal payloads, and synthetic 40-byte packets in the kernel test, each found, fixed and re-run.</a:t>
+              <a:t>Q: Why AIMD? A: Chiu and Jain show it converges to a fair share. Q: Are those papers deep RL and yours is not? A: Yes; we used a lookup table, which is simpler and inspectable.</a:t>
             </a:r>
             <a:endParaRPr lang="en-US" sz="1400" dirty="0"/>
           </a:p>
@@ -22723,7 +22845,7 @@
                 <a:ea typeface="Calibri" pitchFamily="34" charset="-122"/>
                 <a:cs typeface="Calibri" pitchFamily="34" charset="-120"/>
               </a:rPr>
-              <a:t>28. A fast, faithful C simulator, and what it showed</a:t>
+              <a:t>28. How it was tested</a:t>
             </a:r>
             <a:endParaRPr lang="en-US" sz="2600" dirty="0"/>
           </a:p>
@@ -22762,7 +22884,7 @@
                 <a:ea typeface="Calibri" pitchFamily="34" charset="-122"/>
                 <a:cs typeface="Calibri" pitchFamily="34" charset="-120"/>
               </a:rPr>
-              <a:t>Time on this slide: 1:00</a:t>
+              <a:t>Time on this slide: 0:40</a:t>
             </a:r>
             <a:endParaRPr lang="en-US" sz="1300" dirty="0"/>
           </a:p>
@@ -22915,7 +23037,7 @@
                 <a:ea typeface="Calibri" pitchFamily="34" charset="-122"/>
                 <a:cs typeface="Calibri" pitchFamily="34" charset="-120"/>
               </a:rPr>
-              <a:t>Our old simulator was in Python and never matched the C code exactly. So we added a virtual-time mode to the C sender itself: same code, simulated receiver and clock, about a thousand times faster. It reproduces the real-clock results in all 15 calibration cells.</a:t>
+              <a:t>Correctness first: unit, end-to-end, handshake, file-integrity, chat and simulator tests, and the packet parser is fuzzed under AddressSanitizer.</a:t>
             </a:r>
             <a:endParaRPr lang="en-US" sz="1400" dirty="0"/>
           </a:p>
@@ -22936,7 +23058,7 @@
                 <a:ea typeface="Calibri" pitchFamily="34" charset="-122"/>
                 <a:cs typeface="Calibri" pitchFamily="34" charset="-120"/>
               </a:rPr>
-              <a:t>That let us test on 100 random paths that we never tuned on. The neural agent needs 0.53 times the time of tuned AIMD, is faster on 89 paths and never more than 20 percent slower. Tuned CUBIC is slower by more than 20 percent on 27 paths.</a:t>
+              <a:t>For speed we use virtual time, which is the same C sender on a simulated clock. We checked it against the real clock, and it agreed in all 15 of 15 cells. We use paired seeds with 95 percent intervals and keep tuning seeds apart from test seeds.</a:t>
             </a:r>
             <a:endParaRPr lang="en-US" sz="1400" dirty="0"/>
           </a:p>
@@ -22957,7 +23079,7 @@
                 <a:ea typeface="Calibri" pitchFamily="34" charset="-122"/>
                 <a:cs typeface="Calibri" pitchFamily="34" charset="-120"/>
               </a:rPr>
-              <a:t>The ablation shows which parts matter: the window cap of 128 most, then pacing, the timer floor and slow start. We also tried evolution-strategy retraining directly in the C sender and it only gave 2 percent, so we did not adopt it.</a:t>
+              <a:t>Realism comes in four steps: emulation in the client, a separate proxy on real sockets, the Linux kernel with netem, and two laptops over the internet. Every result has its command in the report.</a:t>
             </a:r>
             <a:endParaRPr lang="en-US" sz="1400" dirty="0"/>
           </a:p>
@@ -23035,7 +23157,7 @@
                 <a:ea typeface="Calibri" pitchFamily="34" charset="-122"/>
                 <a:cs typeface="Calibri" pitchFamily="34" charset="-120"/>
               </a:rPr>
-              <a:t>Is the test set separate from tuning? Yes. Slow-start and hand-over settings were chosen on a different set of random paths; the 100 test paths were used only for the reported numbers.</a:t>
+              <a:t>Did you make mistakes? Yes, and we logged them: untuned baselines, unequal payloads, and synthetic 40-byte packets in the kernel test, each found, fixed and re-run.</a:t>
             </a:r>
             <a:endParaRPr lang="en-US" sz="1400" dirty="0"/>
           </a:p>
@@ -23106,7 +23228,7 @@
                 <a:ea typeface="Calibri" pitchFamily="34" charset="-122"/>
                 <a:cs typeface="Calibri" pitchFamily="34" charset="-120"/>
               </a:rPr>
-              <a:t>29. Issues we found along the way</a:t>
+              <a:t>29. A fast, faithful C simulator, and what it showed</a:t>
             </a:r>
             <a:endParaRPr lang="en-US" sz="2600" dirty="0"/>
           </a:p>
@@ -23145,7 +23267,7 @@
                 <a:ea typeface="Calibri" pitchFamily="34" charset="-122"/>
                 <a:cs typeface="Calibri" pitchFamily="34" charset="-120"/>
               </a:rPr>
-              <a:t>Time on this slide: 0:50</a:t>
+              <a:t>Time on this slide: 1:00</a:t>
             </a:r>
             <a:endParaRPr lang="en-US" sz="1300" dirty="0"/>
           </a:p>
@@ -23298,7 +23420,7 @@
                 <a:ea typeface="Calibri" pitchFamily="34" charset="-122"/>
                 <a:cs typeface="Calibri" pitchFamily="34" charset="-120"/>
               </a:rPr>
-              <a:t>Now the issues, and we list them plainly. Our first learned controller, a Q-table, was not faster than AIMD. At 10 percent random loss the neural agent was 7 times slower, 85 seconds against 11.</a:t>
+              <a:t>Our old simulator was in Python and never matched the C code exactly. So we added a virtual-time mode to the C sender itself: same code, simulated receiver and clock, about a thousand times faster. It reproduces the real-clock results in all 15 calibration cells.</a:t>
             </a:r>
             <a:endParaRPr lang="en-US" sz="1400" dirty="0"/>
           </a:p>
@@ -23319,7 +23441,7 @@
                 <a:ea typeface="Calibri" pitchFamily="34" charset="-122"/>
                 <a:cs typeface="Calibri" pitchFamily="34" charset="-120"/>
               </a:rPr>
-              <a:t>Real sockets exposed a lost-handshake hang, spurious timeouts, 262 retransmissions for about 3 losses, and a weak checksum. Our early baselines were weak: untuned AIMD made the first wins look bigger than they are.</a:t>
+              <a:t>That let us test on 100 random paths that we never tuned on. The neural agent needs 0.53 times the time of tuned AIMD, is faster on 89 paths and never more than 20 percent slower. Tuned CUBIC is slower by more than 20 percent on 27 paths.</a:t>
             </a:r>
             <a:endParaRPr lang="en-US" sz="1400" dirty="0"/>
           </a:p>
@@ -23340,7 +23462,7 @@
                 <a:ea typeface="Calibri" pitchFamily="34" charset="-122"/>
                 <a:cs typeface="Calibri" pitchFamily="34" charset="-120"/>
               </a:rPr>
-              <a:t>Our own kernel tests were wrong four times and our first BBR-style baseline had two bugs. And the agent is a pushier neighbour than AIMD or CUBIC. Each of these has a fix on the next slide.</a:t>
+              <a:t>The ablation shows which parts matter: the window cap of 128 most, then pacing, the timer floor and slow start. We also tried evolution-strategy retraining directly in the C sender and it only gave 2 percent, so we did not adopt it.</a:t>
             </a:r>
             <a:endParaRPr lang="en-US" sz="1400" dirty="0"/>
           </a:p>
@@ -23418,7 +23540,7 @@
                 <a:ea typeface="Calibri" pitchFamily="34" charset="-122"/>
                 <a:cs typeface="Calibri" pitchFamily="34" charset="-120"/>
               </a:rPr>
-              <a:t>How did you find these? By testing on real sockets and the kernel, comparing against tuned baselines, and checking our own numbers, for example a goodput above the link rate gave away the 40-byte packet bug.</a:t>
+              <a:t>Is the test set separate from tuning? Yes. Slow-start and hand-over settings were chosen on a different set of random paths; the 100 test paths were used only for the reported numbers.</a:t>
             </a:r>
             <a:endParaRPr lang="en-US" sz="1400" dirty="0"/>
           </a:p>
@@ -23489,7 +23611,7 @@
                 <a:ea typeface="Calibri" pitchFamily="34" charset="-122"/>
                 <a:cs typeface="Calibri" pitchFamily="34" charset="-120"/>
               </a:rPr>
-              <a:t>30. What we changed to make it better</a:t>
+              <a:t>30. Issues we found along the way</a:t>
             </a:r>
             <a:endParaRPr lang="en-US" sz="2600" dirty="0"/>
           </a:p>
@@ -23528,7 +23650,7 @@
                 <a:ea typeface="Calibri" pitchFamily="34" charset="-122"/>
                 <a:cs typeface="Calibri" pitchFamily="34" charset="-120"/>
               </a:rPr>
-              <a:t>Time on this slide: 1:00</a:t>
+              <a:t>Time on this slide: 0:50</a:t>
             </a:r>
             <a:endParaRPr lang="en-US" sz="1300" dirty="0"/>
           </a:p>
@@ -23681,7 +23803,7 @@
                 <a:ea typeface="Calibri" pitchFamily="34" charset="-122"/>
                 <a:cs typeface="Calibri" pitchFamily="34" charset="-120"/>
               </a:rPr>
-              <a:t>Every issue led to a change. Go-Back-N with a fixed timer became Selective Repeat with bitmap ACKs, per-packet timers and an adaptive timer, about 10 times fewer retransmissions. The byte-sum checksum became CRC-16.</a:t>
+              <a:t>Now the issues, and we list them plainly. Our first learned controller, a Q-table, was not faster than AIMD. At 10 percent random loss the neural agent was 7 times slower, 85 seconds against 11.</a:t>
             </a:r>
             <a:endParaRPr lang="en-US" sz="1400" dirty="0"/>
           </a:p>
@@ -23702,7 +23824,7 @@
                 <a:ea typeface="Calibri" pitchFamily="34" charset="-122"/>
                 <a:cs typeface="Calibri" pitchFamily="34" charset="-120"/>
               </a:rPr>
-              <a:t>The lost-handshake hang was fixed as TCP does it. The Q-table became a small neural network with a bigger window cap, slow start and pacing. The 10 percent loss collapse is handled by handing over to AIMD while loss is high: 13.9 seconds instead of 84.9.</a:t>
+              <a:t>Real sockets exposed a lost-handshake hang, spurious timeouts, 262 retransmissions for about 3 losses, and a weak checksum. Our early baselines were weak: untuned AIMD made the first wins look bigger than they are.</a:t>
             </a:r>
             <a:endParaRPr lang="en-US" sz="1400" dirty="0"/>
           </a:p>
@@ -23723,7 +23845,7 @@
                 <a:ea typeface="Calibri" pitchFamily="34" charset="-122"/>
                 <a:cs typeface="Calibri" pitchFamily="34" charset="-120"/>
               </a:rPr>
-              <a:t>We tuned the AIMD and CUBIC baselines so every win is against a fair opponent, and we fixed our test methodology and re-ran the kernel tests.</a:t>
+              <a:t>Our own kernel tests were wrong four times and our first BBR-style baseline had two bugs. And the agent is a pushier neighbour than AIMD or CUBIC. Each of these has a fix on the next slide.</a:t>
             </a:r>
             <a:endParaRPr lang="en-US" sz="1400" dirty="0"/>
           </a:p>
@@ -23801,7 +23923,7 @@
                 <a:ea typeface="Calibri" pitchFamily="34" charset="-122"/>
                 <a:cs typeface="Calibri" pitchFamily="34" charset="-120"/>
               </a:rPr>
-              <a:t>Which change mattered most? The ablation says window cap 128, pacing, the timer floor and slow start do most of the work, and the hand-over is what makes the hostile path safe.</a:t>
+              <a:t>How did you find these? By testing on real sockets and the kernel, comparing against tuned baselines, and checking our own numbers, for example a goodput above the link rate gave away the 40-byte packet bug.</a:t>
             </a:r>
             <a:endParaRPr lang="en-US" sz="1400" dirty="0"/>
           </a:p>
@@ -23872,7 +23994,7 @@
                 <a:ea typeface="Calibri" pitchFamily="34" charset="-122"/>
                 <a:cs typeface="Calibri" pitchFamily="34" charset="-120"/>
               </a:rPr>
-              <a:t>31. Benchmark results</a:t>
+              <a:t>31. What we changed to make it better</a:t>
             </a:r>
             <a:endParaRPr lang="en-US" sz="2600" dirty="0"/>
           </a:p>
@@ -23911,7 +24033,7 @@
                 <a:ea typeface="Calibri" pitchFamily="34" charset="-122"/>
                 <a:cs typeface="Calibri" pitchFamily="34" charset="-120"/>
               </a:rPr>
-              <a:t>Time on this slide: 0:40</a:t>
+              <a:t>Time on this slide: 1:00</a:t>
             </a:r>
             <a:endParaRPr lang="en-US" sz="1300" dirty="0"/>
           </a:p>
@@ -24056,7 +24178,7 @@
               <a:buChar char="•"/>
             </a:pPr>
             <a:r>
-              <a:rPr lang="en-US" sz="1600" dirty="0">
+              <a:rPr lang="en-US" sz="1400" dirty="0">
                 <a:solidFill>
                   <a:srgbClr val="1B2430"/>
                 </a:solidFill>
@@ -24064,9 +24186,9 @@
                 <a:ea typeface="Calibri" pitchFamily="34" charset="-122"/>
                 <a:cs typeface="Calibri" pitchFamily="34" charset="-120"/>
               </a:rPr>
-              <a:t>62 of 62 packets were delivered at every loss level from 0 to 40 percent.</a:t>
-            </a:r>
-            <a:endParaRPr lang="en-US" sz="1600" dirty="0"/>
+              <a:t>Every issue led to a change. Go-Back-N with a fixed timer became Selective Repeat with bitmap ACKs, per-packet timers and an adaptive timer, about 10 times fewer retransmissions. The byte-sum checksum became CRC-16.</a:t>
+            </a:r>
+            <a:endParaRPr lang="en-US" sz="1400" dirty="0"/>
           </a:p>
           <a:p>
             <a:pPr marL="342900" indent="-342900">
@@ -24077,7 +24199,7 @@
               <a:buChar char="•"/>
             </a:pPr>
             <a:r>
-              <a:rPr lang="en-US" sz="1600" dirty="0">
+              <a:rPr lang="en-US" sz="1400" dirty="0">
                 <a:solidFill>
                   <a:srgbClr val="1B2430"/>
                 </a:solidFill>
@@ -24085,9 +24207,30 @@
                 <a:ea typeface="Calibri" pitchFamily="34" charset="-122"/>
                 <a:cs typeface="Calibri" pitchFamily="34" charset="-120"/>
               </a:rPr>
-              <a:t>Higher loss costs time and retransmissions, never correctness.</a:t>
-            </a:r>
-            <a:endParaRPr lang="en-US" sz="1600" dirty="0"/>
+              <a:t>The lost-handshake hang was fixed as TCP does it. The Q-table became a small neural network with a bigger window cap, slow start and pacing. The 10 percent loss collapse is handled by handing over to AIMD while loss is high: 13.9 seconds instead of 84.9.</a:t>
+            </a:r>
+            <a:endParaRPr lang="en-US" sz="1400" dirty="0"/>
+          </a:p>
+          <a:p>
+            <a:pPr marL="342900" indent="-342900">
+              <a:spcAft>
+                <a:spcPts val="600"/>
+              </a:spcAft>
+              <a:buSzPct val="100000"/>
+              <a:buChar char="•"/>
+            </a:pPr>
+            <a:r>
+              <a:rPr lang="en-US" sz="1400" dirty="0">
+                <a:solidFill>
+                  <a:srgbClr val="1B2430"/>
+                </a:solidFill>
+                <a:latin typeface="Calibri" pitchFamily="34" charset="0"/>
+                <a:ea typeface="Calibri" pitchFamily="34" charset="-122"/>
+                <a:cs typeface="Calibri" pitchFamily="34" charset="-120"/>
+              </a:rPr>
+              <a:t>We tuned the AIMD and CUBIC baselines so every win is against a fair opponent, and we fixed our test methodology and re-ran the kernel tests.</a:t>
+            </a:r>
+            <a:endParaRPr lang="en-US" sz="1400" dirty="0"/>
           </a:p>
         </p:txBody>
       </p:sp>
@@ -24163,7 +24306,7 @@
                 <a:ea typeface="Calibri" pitchFamily="34" charset="-122"/>
                 <a:cs typeface="Calibri" pitchFamily="34" charset="-120"/>
               </a:rPr>
-              <a:t>Q: Single runs? A: Yes, the original benchmark ran each level once. Smart-RUDP evaluation uses 6 runs per scenario.</a:t>
+              <a:t>Which change mattered most? The ablation says window cap 128, pacing, the timer floor and slow start do most of the work, and the hand-over is what makes the hostile path safe.</a:t>
             </a:r>
             <a:endParaRPr lang="en-US" sz="1400" dirty="0"/>
           </a:p>
@@ -24234,7 +24377,7 @@
                 <a:ea typeface="Calibri" pitchFamily="34" charset="-122"/>
                 <a:cs typeface="Calibri" pitchFamily="34" charset="-120"/>
               </a:rPr>
-              <a:t>32. Problems we hit and fixed</a:t>
+              <a:t>32. Benchmark results</a:t>
             </a:r>
             <a:endParaRPr lang="en-US" sz="2600" dirty="0"/>
           </a:p>
@@ -24426,7 +24569,7 @@
                 <a:ea typeface="Calibri" pitchFamily="34" charset="-122"/>
                 <a:cs typeface="Calibri" pitchFamily="34" charset="-120"/>
               </a:rPr>
-              <a:t>Server stuck after a killed client: it hung 15.5 s; fix was to accept SYN in any state.</a:t>
+              <a:t>62 of 62 packets were delivered at every loss level from 0 to 40 percent.</a:t>
             </a:r>
             <a:endParaRPr lang="en-US" sz="1600" dirty="0"/>
           </a:p>
@@ -24447,49 +24590,7 @@
                 <a:ea typeface="Calibri" pitchFamily="34" charset="-122"/>
                 <a:cs typeface="Calibri" pitchFamily="34" charset="-120"/>
               </a:rPr>
-              <a:t>A leftover netem rule distorted results; we now check tc qdisc before each test.</a:t>
-            </a:r>
-            <a:endParaRPr lang="en-US" sz="1600" dirty="0"/>
-          </a:p>
-          <a:p>
-            <a:pPr marL="342900" indent="-342900">
-              <a:spcAft>
-                <a:spcPts val="600"/>
-              </a:spcAft>
-              <a:buSzPct val="100000"/>
-              <a:buChar char="•"/>
-            </a:pPr>
-            <a:r>
-              <a:rPr lang="en-US" sz="1600" dirty="0">
-                <a:solidFill>
-                  <a:srgbClr val="1B2430"/>
-                </a:solidFill>
-                <a:latin typeface="Calibri" pitchFamily="34" charset="0"/>
-                <a:ea typeface="Calibri" pitchFamily="34" charset="-122"/>
-                <a:cs typeface="Calibri" pitchFamily="34" charset="-120"/>
-              </a:rPr>
-              <a:t>Windows Wireshark saw nothing: capture inside WSL.</a:t>
-            </a:r>
-            <a:endParaRPr lang="en-US" sz="1600" dirty="0"/>
-          </a:p>
-          <a:p>
-            <a:pPr marL="342900" indent="-342900">
-              <a:spcAft>
-                <a:spcPts val="600"/>
-              </a:spcAft>
-              <a:buSzPct val="100000"/>
-              <a:buChar char="•"/>
-            </a:pPr>
-            <a:r>
-              <a:rPr lang="en-US" sz="1600" dirty="0">
-                <a:solidFill>
-                  <a:srgbClr val="1B2430"/>
-                </a:solidFill>
-                <a:latin typeface="Calibri" pitchFamily="34" charset="0"/>
-                <a:ea typeface="Calibri" pitchFamily="34" charset="-122"/>
-                <a:cs typeface="Calibri" pitchFamily="34" charset="-120"/>
-              </a:rPr>
-              <a:t>Benchmark script portability: replaced date and grep tricks with awk and sed.</a:t>
+              <a:t>Higher loss costs time and retransmissions, never correctness.</a:t>
             </a:r>
             <a:endParaRPr lang="en-US" sz="1600" dirty="0"/>
           </a:p>
@@ -24567,7 +24668,7 @@
                 <a:ea typeface="Calibri" pitchFamily="34" charset="-122"/>
                 <a:cs typeface="Calibri" pitchFamily="34" charset="-120"/>
               </a:rPr>
-              <a:t>Say these quickly: it shows real debugging, which is what separates a project from a lab.</a:t>
+              <a:t>Q: Single runs? A: Yes, the original benchmark ran each level once. Smart-RUDP evaluation uses 6 runs per scenario.</a:t>
             </a:r>
             <a:endParaRPr lang="en-US" sz="1400" dirty="0"/>
           </a:p>
@@ -24638,7 +24739,7 @@
                 <a:ea typeface="Calibri" pitchFamily="34" charset="-122"/>
                 <a:cs typeface="Calibri" pitchFamily="34" charset="-120"/>
               </a:rPr>
-              <a:t>33. Our first learned agent: an honest result</a:t>
+              <a:t>33. Problems we hit and fixed</a:t>
             </a:r>
             <a:endParaRPr lang="en-US" sz="2600" dirty="0"/>
           </a:p>
@@ -24677,7 +24778,7 @@
                 <a:ea typeface="Calibri" pitchFamily="34" charset="-122"/>
                 <a:cs typeface="Calibri" pitchFamily="34" charset="-120"/>
               </a:rPr>
-              <a:t>Time on this slide: 0:50</a:t>
+              <a:t>Time on this slide: 0:40</a:t>
             </a:r>
             <a:endParaRPr lang="en-US" sz="1300" dirty="0"/>
           </a:p>
@@ -24822,7 +24923,7 @@
               <a:buChar char="•"/>
             </a:pPr>
             <a:r>
-              <a:rPr lang="en-US" sz="1400" dirty="0">
+              <a:rPr lang="en-US" sz="1600" dirty="0">
                 <a:solidFill>
                   <a:srgbClr val="1B2430"/>
                 </a:solidFill>
@@ -24830,9 +24931,9 @@
                 <a:ea typeface="Calibri" pitchFamily="34" charset="-122"/>
                 <a:cs typeface="Calibri" pitchFamily="34" charset="-120"/>
               </a:rPr>
-              <a:t>Be honest: it did not beat AIMD. Plus 63 percent time on 5G-like, plus 10 percent on satellite, a tie on the lossy path.</a:t>
-            </a:r>
-            <a:endParaRPr lang="en-US" sz="1400" dirty="0"/>
+              <a:t>Server stuck after a killed client: it hung 15.5 s; fix was to accept SYN in any state.</a:t>
+            </a:r>
+            <a:endParaRPr lang="en-US" sz="1600" dirty="0"/>
           </a:p>
           <a:p>
             <a:pPr marL="342900" indent="-342900">
@@ -24843,7 +24944,7 @@
               <a:buChar char="•"/>
             </a:pPr>
             <a:r>
-              <a:rPr lang="en-US" sz="1400" dirty="0">
+              <a:rPr lang="en-US" sz="1600" dirty="0">
                 <a:solidFill>
                   <a:srgbClr val="1B2430"/>
                 </a:solidFill>
@@ -24851,9 +24952,9 @@
                 <a:ea typeface="Calibri" pitchFamily="34" charset="-122"/>
                 <a:cs typeface="Calibri" pitchFamily="34" charset="-120"/>
               </a:rPr>
-              <a:t>It used somewhat fewer retransmissions on two paths, within run-to-run noise.</a:t>
-            </a:r>
-            <a:endParaRPr lang="en-US" sz="1400" dirty="0"/>
+              <a:t>A leftover netem rule distorted results; we now check tc qdisc before each test.</a:t>
+            </a:r>
+            <a:endParaRPr lang="en-US" sz="1600" dirty="0"/>
           </a:p>
           <a:p>
             <a:pPr marL="342900" indent="-342900">
@@ -24864,7 +24965,7 @@
               <a:buChar char="•"/>
             </a:pPr>
             <a:r>
-              <a:rPr lang="en-US" sz="1400" dirty="0">
+              <a:rPr lang="en-US" sz="1600" dirty="0">
                 <a:solidFill>
                   <a:srgbClr val="1B2430"/>
                 </a:solidFill>
@@ -24872,9 +24973,9 @@
                 <a:ea typeface="Calibri" pitchFamily="34" charset="-122"/>
                 <a:cs typeface="Calibri" pitchFamily="34" charset="-120"/>
               </a:rPr>
-              <a:t>Earlier training rounds were much worse; this is the final configuration. The finding is that a simple learner does not beat a tuned rule.</a:t>
-            </a:r>
-            <a:endParaRPr lang="en-US" sz="1400" dirty="0"/>
+              <a:t>Windows Wireshark saw nothing: capture inside WSL.</a:t>
+            </a:r>
+            <a:endParaRPr lang="en-US" sz="1600" dirty="0"/>
           </a:p>
           <a:p>
             <a:pPr marL="342900" indent="-342900">
@@ -24885,7 +24986,7 @@
               <a:buChar char="•"/>
             </a:pPr>
             <a:r>
-              <a:rPr lang="en-US" sz="1400" dirty="0">
+              <a:rPr lang="en-US" sz="1600" dirty="0">
                 <a:solidFill>
                   <a:srgbClr val="1B2430"/>
                 </a:solidFill>
@@ -24893,9 +24994,9 @@
                 <a:ea typeface="Calibri" pitchFamily="34" charset="-122"/>
                 <a:cs typeface="Calibri" pitchFamily="34" charset="-120"/>
               </a:rPr>
-              <a:t>In the chat, retrained for bursty random-loss traffic, it does beat AIMD on most simulated paths; mention that on slide 19.</a:t>
-            </a:r>
-            <a:endParaRPr lang="en-US" sz="1400" dirty="0"/>
+              <a:t>Benchmark script portability: replaced date and grep tricks with awk and sed.</a:t>
+            </a:r>
+            <a:endParaRPr lang="en-US" sz="1600" dirty="0"/>
           </a:p>
         </p:txBody>
       </p:sp>
@@ -24971,7 +25072,7 @@
                 <a:ea typeface="Calibri" pitchFamily="34" charset="-122"/>
                 <a:cs typeface="Calibri" pitchFamily="34" charset="-120"/>
               </a:rPr>
-              <a:t>Q: Then what was the point? A: The experiment. We tested whether a learned window helps and report the answer, including the negative result.</a:t>
+              <a:t>Say these quickly: it shows real debugging, which is what separates a project from a lab.</a:t>
             </a:r>
             <a:endParaRPr lang="en-US" sz="1400" dirty="0"/>
           </a:p>
@@ -25042,7 +25143,7 @@
                 <a:ea typeface="Calibri" pitchFamily="34" charset="-122"/>
                 <a:cs typeface="Calibri" pitchFamily="34" charset="-120"/>
               </a:rPr>
-              <a:t>34. More evidence: baselines, SACK, reordering</a:t>
+              <a:t>34. Our first learned agent: an honest result</a:t>
             </a:r>
             <a:endParaRPr lang="en-US" sz="2600" dirty="0"/>
           </a:p>
@@ -25081,7 +25182,7 @@
                 <a:ea typeface="Calibri" pitchFamily="34" charset="-122"/>
                 <a:cs typeface="Calibri" pitchFamily="34" charset="-120"/>
               </a:rPr>
-              <a:t>Time on this slide: 1:00</a:t>
+              <a:t>Time on this slide: 0:50</a:t>
             </a:r>
             <a:endParaRPr lang="en-US" sz="1300" dirty="0"/>
           </a:p>
@@ -25234,7 +25335,7 @@
                 <a:ea typeface="Calibri" pitchFamily="34" charset="-122"/>
                 <a:cs typeface="Calibri" pitchFamily="34" charset="-120"/>
               </a:rPr>
-              <a:t>The abstract also promised TCP and plain UDP baselines, so we ran them on the same 48 unseen simulated paths.</a:t>
+              <a:t>Be honest: it did not beat AIMD. Plus 63 percent time on 5G-like, plus 10 percent on satellite, a tie on the lossy path.</a:t>
             </a:r>
             <a:endParaRPr lang="en-US" sz="1400" dirty="0"/>
           </a:p>
@@ -25255,7 +25356,7 @@
                 <a:ea typeface="Calibri" pitchFamily="34" charset="-122"/>
                 <a:cs typeface="Calibri" pitchFamily="34" charset="-120"/>
               </a:rPr>
-              <a:t>Plain UDP delivered only 68 percent of the messages, so reliability is needed. Our TCP model, with selective acknowledgments, has the lowest median at 1.48 seconds.</a:t>
+              <a:t>It used somewhat fewer retransmissions on two paths, within run-to-run noise.</a:t>
             </a:r>
             <a:endParaRPr lang="en-US" sz="1400" dirty="0"/>
           </a:p>
@@ -25276,7 +25377,7 @@
                 <a:ea typeface="Calibri" pitchFamily="34" charset="-122"/>
                 <a:cs typeface="Calibri" pitchFamily="34" charset="-120"/>
               </a:rPr>
-              <a:t>Smart-RUDP deep is at 3.20 seconds mean and is about even with the TCP model path by path: faster on 22, slower on 23.</a:t>
+              <a:t>Earlier training rounds were much worse; this is the final configuration. The finding is that a simple learner does not beat a tuned rule.</a:t>
             </a:r>
             <a:endParaRPr lang="en-US" sz="1400" dirty="0"/>
           </a:p>
@@ -25297,70 +25398,7 @@
                 <a:ea typeface="Calibri" pitchFamily="34" charset="-122"/>
                 <a:cs typeface="Calibri" pitchFamily="34" charset="-120"/>
               </a:rPr>
-              <a:t>The gap to TCP is mostly Go-Back-N. A selective-ack version of our transport cut AIMD from 7.16 to 4.90 seconds in simulation.</a:t>
-            </a:r>
-            <a:endParaRPr lang="en-US" sz="1400" dirty="0"/>
-          </a:p>
-          <a:p>
-            <a:pPr marL="342900" indent="-342900">
-              <a:spcAft>
-                <a:spcPts val="600"/>
-              </a:spcAft>
-              <a:buSzPct val="100000"/>
-              <a:buChar char="•"/>
-            </a:pPr>
-            <a:r>
-              <a:rPr lang="en-US" sz="1400" dirty="0">
-                <a:solidFill>
-                  <a:srgbClr val="1B2430"/>
-                </a:solidFill>
-                <a:latin typeface="Calibri" pitchFamily="34" charset="0"/>
-                <a:ea typeface="Calibri" pitchFamily="34" charset="-122"/>
-                <a:cs typeface="Calibri" pitchFamily="34" charset="-120"/>
-              </a:rPr>
-              <a:t>Reordering hurts Go-Back-N badly: AIMD goes from 0.82 to 6.79 seconds at 20 milliseconds of jitter. The learned agents cope better and selective ack removes most of the damage.</a:t>
-            </a:r>
-            <a:endParaRPr lang="en-US" sz="1400" dirty="0"/>
-          </a:p>
-          <a:p>
-            <a:pPr marL="342900" indent="-342900">
-              <a:spcAft>
-                <a:spcPts val="600"/>
-              </a:spcAft>
-              <a:buSzPct val="100000"/>
-              <a:buChar char="•"/>
-            </a:pPr>
-            <a:r>
-              <a:rPr lang="en-US" sz="1400" dirty="0">
-                <a:solidFill>
-                  <a:srgbClr val="1B2430"/>
-                </a:solidFill>
-                <a:latin typeface="Calibri" pitchFamily="34" charset="0"/>
-                <a:ea typeface="Calibri" pitchFamily="34" charset="-122"/>
-                <a:cs typeface="Calibri" pitchFamily="34" charset="-120"/>
-              </a:rPr>
-              <a:t>For the C experiments we repeated 20 runs per mode: Smart-RUDP is still slower on 5G and satellite and ties on lossy.</a:t>
-            </a:r>
-            <a:endParaRPr lang="en-US" sz="1400" dirty="0"/>
-          </a:p>
-          <a:p>
-            <a:pPr marL="342900" indent="-342900">
-              <a:spcAft>
-                <a:spcPts val="600"/>
-              </a:spcAft>
-              <a:buSzPct val="100000"/>
-              <a:buChar char="•"/>
-            </a:pPr>
-            <a:r>
-              <a:rPr lang="en-US" sz="1400" dirty="0">
-                <a:solidFill>
-                  <a:srgbClr val="1B2430"/>
-                </a:solidFill>
-                <a:latin typeface="Calibri" pitchFamily="34" charset="0"/>
-                <a:ea typeface="Calibri" pitchFamily="34" charset="-122"/>
-                <a:cs typeface="Calibri" pitchFamily="34" charset="-120"/>
-              </a:rPr>
-              <a:t>Be upfront: our simulator originally allowed a duplicate-ACK retransmission storm that flatters aggressive controllers. With the realistic rule the neural agent is about level with AIMD in simulation (7.27 s against 7.75 s). The C results are the evidence we rely on.</a:t>
+              <a:t>In the chat, retrained for bursty random-loss traffic, it does beat AIMD on most simulated paths; mention that on slide 19.</a:t>
             </a:r>
             <a:endParaRPr lang="en-US" sz="1400" dirty="0"/>
           </a:p>
@@ -25438,7 +25476,7 @@
                 <a:ea typeface="Calibri" pitchFamily="34" charset="-122"/>
                 <a:cs typeface="Calibri" pitchFamily="34" charset="-120"/>
               </a:rPr>
-              <a:t>Q: Is the TCP row real TCP? A: No, it is a model with the same window cap; real kernel TCP needs netem on Linux, and we provide the script. Q: Why did you not implement SACK in C? A: Time; the simulation shows it is the biggest win and it is the first item of future work. Q: Is 20 runs enough? A: The intervals exclude zero for 5G and satellite and include zero for lossy. Did you check it is not a simulator artefact? Yes: with the realistic rule the simulated gain mostly disappears, so we lean on the C results, which use that rule and equal window caps.</a:t>
+              <a:t>Q: Then what was the point? A: The experiment. We tested whether a learned window helps and report the answer, including the negative result.</a:t>
             </a:r>
             <a:endParaRPr lang="en-US" sz="1400" dirty="0"/>
           </a:p>
@@ -25509,7 +25547,7 @@
                 <a:ea typeface="Calibri" pitchFamily="34" charset="-122"/>
                 <a:cs typeface="Calibri" pitchFamily="34" charset="-120"/>
               </a:rPr>
-              <a:t>35. Real sockets found what the emulator could not</a:t>
+              <a:t>35. More evidence: baselines, SACK, reordering</a:t>
             </a:r>
             <a:endParaRPr lang="en-US" sz="2600" dirty="0"/>
           </a:p>
@@ -25548,7 +25586,7 @@
                 <a:ea typeface="Calibri" pitchFamily="34" charset="-122"/>
                 <a:cs typeface="Calibri" pitchFamily="34" charset="-120"/>
               </a:rPr>
-              <a:t>Time on this slide: 0:50</a:t>
+              <a:t>Time on this slide: 1:00</a:t>
             </a:r>
             <a:endParaRPr lang="en-US" sz="1300" dirty="0"/>
           </a:p>
@@ -25701,7 +25739,7 @@
                 <a:ea typeface="Calibri" pitchFamily="34" charset="-122"/>
                 <a:cs typeface="Calibri" pitchFamily="34" charset="-120"/>
               </a:rPr>
-              <a:t>The emulator is inside our client, so we also tested through a separate impairment process on real UDP sockets. That found three real defects.</a:t>
+              <a:t>The abstract also promised TCP and plain UDP baselines, so we ran them on the same 48 unseen simulated paths.</a:t>
             </a:r>
             <a:endParaRPr lang="en-US" sz="1400" dirty="0"/>
           </a:p>
@@ -25722,7 +25760,7 @@
                 <a:ea typeface="Calibri" pitchFamily="34" charset="-122"/>
                 <a:cs typeface="Calibri" pitchFamily="34" charset="-120"/>
               </a:rPr>
-              <a:t>First, if the client's last handshake ACK is lost, the server ignored all following data and the transfer hung. We fixed it the way TCP does and added a regression test. Second, the spurious timeouts I just mentioned. Third, a fuzzer showed our byte-sum checksum let about 2 percent of corrupted packets through, so it is now CRC-16 and the fuzzer accepts none.</a:t>
+              <a:t>Plain UDP delivered only 68 percent of the messages, so reliability is needed. Our TCP model, with selective acknowledgments, has the lowest median at 1.48 seconds.</a:t>
             </a:r>
             <a:endParaRPr lang="en-US" sz="1400" dirty="0"/>
           </a:p>
@@ -25743,7 +25781,91 @@
                 <a:ea typeface="Calibri" pitchFamily="34" charset="-122"/>
                 <a:cs typeface="Calibri" pitchFamily="34" charset="-120"/>
               </a:rPr>
-              <a:t>On real sockets the neural agent is again fastest on every path: 17, 53, 45 and 39 percent faster than tuned AIMD on 5G, lossy, satellite and fast, and a tie on the hostile path.</a:t>
+              <a:t>Smart-RUDP deep is at 3.20 seconds mean and is about even with the TCP model path by path: faster on 22, slower on 23.</a:t>
+            </a:r>
+            <a:endParaRPr lang="en-US" sz="1400" dirty="0"/>
+          </a:p>
+          <a:p>
+            <a:pPr marL="342900" indent="-342900">
+              <a:spcAft>
+                <a:spcPts val="600"/>
+              </a:spcAft>
+              <a:buSzPct val="100000"/>
+              <a:buChar char="•"/>
+            </a:pPr>
+            <a:r>
+              <a:rPr lang="en-US" sz="1400" dirty="0">
+                <a:solidFill>
+                  <a:srgbClr val="1B2430"/>
+                </a:solidFill>
+                <a:latin typeface="Calibri" pitchFamily="34" charset="0"/>
+                <a:ea typeface="Calibri" pitchFamily="34" charset="-122"/>
+                <a:cs typeface="Calibri" pitchFamily="34" charset="-120"/>
+              </a:rPr>
+              <a:t>The gap to TCP is mostly Go-Back-N. A selective-ack version of our transport cut AIMD from 7.16 to 4.90 seconds in simulation.</a:t>
+            </a:r>
+            <a:endParaRPr lang="en-US" sz="1400" dirty="0"/>
+          </a:p>
+          <a:p>
+            <a:pPr marL="342900" indent="-342900">
+              <a:spcAft>
+                <a:spcPts val="600"/>
+              </a:spcAft>
+              <a:buSzPct val="100000"/>
+              <a:buChar char="•"/>
+            </a:pPr>
+            <a:r>
+              <a:rPr lang="en-US" sz="1400" dirty="0">
+                <a:solidFill>
+                  <a:srgbClr val="1B2430"/>
+                </a:solidFill>
+                <a:latin typeface="Calibri" pitchFamily="34" charset="0"/>
+                <a:ea typeface="Calibri" pitchFamily="34" charset="-122"/>
+                <a:cs typeface="Calibri" pitchFamily="34" charset="-120"/>
+              </a:rPr>
+              <a:t>Reordering hurts Go-Back-N badly: AIMD goes from 0.82 to 6.79 seconds at 20 milliseconds of jitter. The learned agents cope better and selective ack removes most of the damage.</a:t>
+            </a:r>
+            <a:endParaRPr lang="en-US" sz="1400" dirty="0"/>
+          </a:p>
+          <a:p>
+            <a:pPr marL="342900" indent="-342900">
+              <a:spcAft>
+                <a:spcPts val="600"/>
+              </a:spcAft>
+              <a:buSzPct val="100000"/>
+              <a:buChar char="•"/>
+            </a:pPr>
+            <a:r>
+              <a:rPr lang="en-US" sz="1400" dirty="0">
+                <a:solidFill>
+                  <a:srgbClr val="1B2430"/>
+                </a:solidFill>
+                <a:latin typeface="Calibri" pitchFamily="34" charset="0"/>
+                <a:ea typeface="Calibri" pitchFamily="34" charset="-122"/>
+                <a:cs typeface="Calibri" pitchFamily="34" charset="-120"/>
+              </a:rPr>
+              <a:t>For the C experiments we repeated 20 runs per mode: Smart-RUDP is still slower on 5G and satellite and ties on lossy.</a:t>
+            </a:r>
+            <a:endParaRPr lang="en-US" sz="1400" dirty="0"/>
+          </a:p>
+          <a:p>
+            <a:pPr marL="342900" indent="-342900">
+              <a:spcAft>
+                <a:spcPts val="600"/>
+              </a:spcAft>
+              <a:buSzPct val="100000"/>
+              <a:buChar char="•"/>
+            </a:pPr>
+            <a:r>
+              <a:rPr lang="en-US" sz="1400" dirty="0">
+                <a:solidFill>
+                  <a:srgbClr val="1B2430"/>
+                </a:solidFill>
+                <a:latin typeface="Calibri" pitchFamily="34" charset="0"/>
+                <a:ea typeface="Calibri" pitchFamily="34" charset="-122"/>
+                <a:cs typeface="Calibri" pitchFamily="34" charset="-120"/>
+              </a:rPr>
+              <a:t>Be upfront: our simulator originally allowed a duplicate-ACK retransmission storm that flatters aggressive controllers. With the realistic rule the neural agent is about level with AIMD in simulation (7.27 s against 7.75 s). The C results are the evidence we rely on.</a:t>
             </a:r>
             <a:endParaRPr lang="en-US" sz="1400" dirty="0"/>
           </a:p>
@@ -25821,7 +25943,7 @@
                 <a:ea typeface="Calibri" pitchFamily="34" charset="-122"/>
                 <a:cs typeface="Calibri" pitchFamily="34" charset="-120"/>
               </a:rPr>
-              <a:t>Is this a real network? It is real UDP sockets on one machine, with the impairment applied by a separate process. It is not a kernel netem or a multi-machine path; we provide the script for that but had no root access.</a:t>
+              <a:t>Q: Is the TCP row real TCP? A: No, it is a model with the same window cap; real kernel TCP needs netem on Linux, and we provide the script. Q: Why did you not implement SACK in C? A: Time; the simulation shows it is the biggest win and it is the first item of future work. Q: Is 20 runs enough? A: The intervals exclude zero for 5G and satellite and include zero for lossy. Did you check it is not a simulator artefact? Yes: with the realistic rule the simulated gain mostly disappears, so we lean on the C results, which use that rule and equal window caps.</a:t>
             </a:r>
             <a:endParaRPr lang="en-US" sz="1400" dirty="0"/>
           </a:p>
@@ -25892,7 +26014,7 @@
                 <a:ea typeface="Calibri" pitchFamily="34" charset="-122"/>
                 <a:cs typeface="Calibri" pitchFamily="34" charset="-120"/>
               </a:rPr>
-              <a:t>36. Safety net: hand over to AIMD</a:t>
+              <a:t>36. Real sockets found what the emulator could not</a:t>
             </a:r>
             <a:endParaRPr lang="en-US" sz="2600" dirty="0"/>
           </a:p>
@@ -26084,7 +26206,7 @@
                 <a:ea typeface="Calibri" pitchFamily="34" charset="-122"/>
                 <a:cs typeface="Calibri" pitchFamily="34" charset="-120"/>
               </a:rPr>
-              <a:t>While checking our own result we found where the neural agent fails: on a hostile path with 10 percent loss it needed about 85 seconds where AIMD needed 11.</a:t>
+              <a:t>The emulator is inside our client, so we also tested through a separate impairment process on real UDP sockets. That found three real defects.</a:t>
             </a:r>
             <a:endParaRPr lang="en-US" sz="1400" dirty="0"/>
           </a:p>
@@ -26105,7 +26227,7 @@
                 <a:ea typeface="Calibri" pitchFamily="34" charset="-122"/>
                 <a:cs typeface="Calibri" pitchFamily="34" charset="-120"/>
               </a:rPr>
-              <a:t>The fix is a hand-over: when a decision interval loses 10 percent or more of its packets, plain AIMD controls the window; after three clean intervals the agent takes over again.</a:t>
+              <a:t>First, if the client's last handshake ACK is lost, the server ignored all following data and the transfer hung. We fixed it the way TCP does and added a regression test. Second, the spurious timeouts I just mentioned. Third, a fuzzer showed our byte-sum checksum let about 2 percent of corrupted packets through, so it is now CRC-16 and the fuzzer accepts none.</a:t>
             </a:r>
             <a:endParaRPr lang="en-US" sz="1400" dirty="0"/>
           </a:p>
@@ -26126,28 +26248,7 @@
                 <a:ea typeface="Calibri" pitchFamily="34" charset="-122"/>
                 <a:cs typeface="Calibri" pitchFamily="34" charset="-120"/>
               </a:rPr>
-              <a:t>With that, the three benign paths keep the agent's advantage and the hostile path is back near AIMD at about 14 seconds.</a:t>
-            </a:r>
-            <a:endParaRPr lang="en-US" sz="1400" dirty="0"/>
-          </a:p>
-          <a:p>
-            <a:pPr marL="342900" indent="-342900">
-              <a:spcAft>
-                <a:spcPts val="600"/>
-              </a:spcAft>
-              <a:buSzPct val="100000"/>
-              <a:buChar char="•"/>
-            </a:pPr>
-            <a:r>
-              <a:rPr lang="en-US" sz="1400" dirty="0">
-                <a:solidFill>
-                  <a:srgbClr val="1B2430"/>
-                </a:solidFill>
-                <a:latin typeface="Calibri" pitchFamily="34" charset="0"/>
-                <a:ea typeface="Calibri" pitchFamily="34" charset="-122"/>
-                <a:cs typeface="Calibri" pitchFamily="34" charset="-120"/>
-              </a:rPr>
-              <a:t>We also tried cutting the window on every timeout; it fixed the hostile case but made the 2 percent path much worse, so we dropped it. So the learned agent is useful on clean to moderate paths and needs a classical safety net elsewhere.</a:t>
+              <a:t>On real sockets the neural agent is again fastest on every path: 17, 53, 45 and 39 percent faster than tuned AIMD on 5G, lossy, satellite and fast, and a tie on the hostile path.</a:t>
             </a:r>
             <a:endParaRPr lang="en-US" sz="1400" dirty="0"/>
           </a:p>
@@ -26225,7 +26326,7 @@
                 <a:ea typeface="Calibri" pitchFamily="34" charset="-122"/>
                 <a:cs typeface="Calibri" pitchFamily="34" charset="-120"/>
               </a:rPr>
-              <a:t>Is the hybrid still 'AI'? Yes on clean and moderate paths, where the neural network decides; on heavy loss it deliberately defers to AIMD. It is a rule we added, not something the network learned.</a:t>
+              <a:t>Is this a real network? It is real UDP sockets on one machine, with the impairment applied by a separate process. It is not a kernel netem or a multi-machine path; we provide the script for that but had no root access.</a:t>
             </a:r>
             <a:endParaRPr lang="en-US" sz="1400" dirty="0"/>
           </a:p>
@@ -26296,7 +26397,7 @@
                 <a:ea typeface="Calibri" pitchFamily="34" charset="-122"/>
                 <a:cs typeface="Calibri" pitchFamily="34" charset="-120"/>
               </a:rPr>
-              <a:t>37. Fairness, ablations, chat fixes</a:t>
+              <a:t>37. Safety net: hand over to AIMD</a:t>
             </a:r>
             <a:endParaRPr lang="en-US" sz="2600" dirty="0"/>
           </a:p>
@@ -26488,7 +26589,7 @@
                 <a:ea typeface="Calibri" pitchFamily="34" charset="-122"/>
                 <a:cs typeface="Calibri" pitchFamily="34" charset="-120"/>
               </a:rPr>
-              <a:t>We also tested two things people ask about. Fairness: two flows through one bottleneck. The neural agent is fair against itself and on short paths, but takes 74 percent against AIMD on the long 120 ms path, about like a fixed window.</a:t>
+              <a:t>While checking our own result we found where the neural agent fails: on a hostile path with 10 percent loss it needed about 85 seconds where AIMD needed 11.</a:t>
             </a:r>
             <a:endParaRPr lang="en-US" sz="1400" dirty="0"/>
           </a:p>
@@ -26509,7 +26610,7 @@
                 <a:ea typeface="Calibri" pitchFamily="34" charset="-122"/>
                 <a:cs typeface="Calibri" pitchFamily="34" charset="-120"/>
               </a:rPr>
-              <a:t>Ablation: we retrained the agent with one piece removed. Only the no-shrink mask matters; without it the agent is no better than AIMD. The other pieces showed no measurable value.</a:t>
+              <a:t>The fix is a hand-over: when a decision interval loses 10 percent or more of its packets, plain AIMD controls the window; after three clean intervals the agent takes over again.</a:t>
             </a:r>
             <a:endParaRPr lang="en-US" sz="1400" dirty="0"/>
           </a:p>
@@ -26530,7 +26631,7 @@
                 <a:ea typeface="Calibri" pitchFamily="34" charset="-122"/>
                 <a:cs typeface="Calibri" pitchFamily="34" charset="-120"/>
               </a:rPr>
-              <a:t>The same recipe also gave very different results by seed, between 3.2 and 7.4 seconds, so we pick the seed on validation paths.</a:t>
+              <a:t>With that, the three benign paths keep the agent's advantage and the hostile path is back near AIMD at about 14 seconds.</a:t>
             </a:r>
             <a:endParaRPr lang="en-US" sz="1400" dirty="0"/>
           </a:p>
@@ -26551,7 +26652,7 @@
                 <a:ea typeface="Calibri" pitchFamily="34" charset="-122"/>
                 <a:cs typeface="Calibri" pitchFamily="34" charset="-120"/>
               </a:rPr>
-              <a:t>While building the dashboard we found a retransmission storm in the web gateway and fixed it; there is also an adaptive timeout option now.</a:t>
+              <a:t>We also tried cutting the window on every timeout; it fixed the hostile case but made the 2 percent path much worse, so we dropped it. So the learned agent is useful on clean to moderate paths and needs a classical safety net elsewhere.</a:t>
             </a:r>
             <a:endParaRPr lang="en-US" sz="1400" dirty="0"/>
           </a:p>
@@ -26629,7 +26730,7 @@
                 <a:ea typeface="Calibri" pitchFamily="34" charset="-122"/>
                 <a:cs typeface="Calibri" pitchFamily="34" charset="-120"/>
               </a:rPr>
-              <a:t>Is the agent fair? Mostly, but not on the long path against AIMD (74% share, Jain 0.82). Fairness was only tested in the simulator, not in C.</a:t>
+              <a:t>Is the hybrid still 'AI'? Yes on clean and moderate paths, where the neural network decides; on heavy loss it deliberately defers to AIMD. It is a rule we added, not something the network learned.</a:t>
             </a:r>
             <a:endParaRPr lang="en-US" sz="1400" dirty="0"/>
           </a:p>
@@ -27104,7 +27205,7 @@
                 <a:ea typeface="Calibri" pitchFamily="34" charset="-122"/>
                 <a:cs typeface="Calibri" pitchFamily="34" charset="-120"/>
               </a:rPr>
-              <a:t>38. Fairness and file transfer</a:t>
+              <a:t>38. Fairness, ablations, chat fixes</a:t>
             </a:r>
             <a:endParaRPr lang="en-US" sz="2600" dirty="0"/>
           </a:p>
@@ -27296,7 +27397,7 @@
                 <a:ea typeface="Calibri" pitchFamily="34" charset="-122"/>
                 <a:cs typeface="Calibri" pitchFamily="34" charset="-120"/>
               </a:rPr>
-              <a:t>Fairness on real sockets: two neural flows split the link evenly, and so do two AIMD flows. But against tuned AIMD the neural agent takes 68 percent of the link, and 76 percent against the original AIMD. CUBIC takes 61 percent. So the agent is a more aggressive neighbour. Nothing starves, but it is not polite, and we did not test coexistence with TCP. That is our main limitation.</a:t>
+              <a:t>We also tested two things people ask about. Fairness: two flows through one bottleneck. The neural agent is fair against itself and on short paths, but takes 74 percent against AIMD on the long 120 ms path, about like a fixed window.</a:t>
             </a:r>
             <a:endParaRPr lang="en-US" sz="1400" dirty="0"/>
           </a:p>
@@ -27317,7 +27418,7 @@
                 <a:ea typeface="Calibri" pitchFamily="34" charset="-122"/>
                 <a:cs typeface="Calibri" pitchFamily="34" charset="-120"/>
               </a:rPr>
-              <a:t>We also added file transfer: the sender sends a real file and the received file is byte-identical in every run. A 4 megabyte file over the fast path takes 8.9 seconds with the agent against 21 seconds with tuned AIMD.</a:t>
+              <a:t>Ablation: we retrained the agent with one piece removed. Only the no-shrink mask matters; without it the agent is no better than AIMD. The other pieces showed no measurable value.</a:t>
             </a:r>
             <a:endParaRPr lang="en-US" sz="1400" dirty="0"/>
           </a:p>
@@ -27338,7 +27439,28 @@
                 <a:ea typeface="Calibri" pitchFamily="34" charset="-122"/>
                 <a:cs typeface="Calibri" pitchFamily="34" charset="-120"/>
               </a:rPr>
-              <a:t>The chat and web gateway now use the same window and bitmap as the C transport, and there is CI, fuzzing and an architecture document.</a:t>
+              <a:t>The same recipe also gave very different results by seed, between 3.2 and 7.4 seconds, so we pick the seed on validation paths.</a:t>
+            </a:r>
+            <a:endParaRPr lang="en-US" sz="1400" dirty="0"/>
+          </a:p>
+          <a:p>
+            <a:pPr marL="342900" indent="-342900">
+              <a:spcAft>
+                <a:spcPts val="600"/>
+              </a:spcAft>
+              <a:buSzPct val="100000"/>
+              <a:buChar char="•"/>
+            </a:pPr>
+            <a:r>
+              <a:rPr lang="en-US" sz="1400" dirty="0">
+                <a:solidFill>
+                  <a:srgbClr val="1B2430"/>
+                </a:solidFill>
+                <a:latin typeface="Calibri" pitchFamily="34" charset="0"/>
+                <a:ea typeface="Calibri" pitchFamily="34" charset="-122"/>
+                <a:cs typeface="Calibri" pitchFamily="34" charset="-120"/>
+              </a:rPr>
+              <a:t>While building the dashboard we found a retransmission storm in the web gateway and fixed it; there is also an adaptive timeout option now.</a:t>
             </a:r>
             <a:endParaRPr lang="en-US" sz="1400" dirty="0"/>
           </a:p>
@@ -27416,7 +27538,7 @@
                 <a:ea typeface="Calibri" pitchFamily="34" charset="-122"/>
                 <a:cs typeface="Calibri" pitchFamily="34" charset="-120"/>
               </a:rPr>
-              <a:t>Would this be safe to deploy? Not on a shared link yet: it needs fairness-aware training and TCP coexistence tests. For a dedicated path it is a clear win.</a:t>
+              <a:t>Is the agent fair? Mostly, but not on the long path against AIMD (74% share, Jain 0.82). Fairness was only tested in the simulator, not in C.</a:t>
             </a:r>
             <a:endParaRPr lang="en-US" sz="1400" dirty="0"/>
           </a:p>
@@ -27487,7 +27609,7 @@
                 <a:ea typeface="Calibri" pitchFamily="34" charset="-122"/>
                 <a:cs typeface="Calibri" pitchFamily="34" charset="-120"/>
               </a:rPr>
-              <a:t>39. Closing gaps: fairness and cross traffic</a:t>
+              <a:t>39. Fairness and file transfer</a:t>
             </a:r>
             <a:endParaRPr lang="en-US" sz="2600" dirty="0"/>
           </a:p>
@@ -27679,7 +27801,7 @@
                 <a:ea typeface="Calibri" pitchFamily="34" charset="-122"/>
                 <a:cs typeface="Calibri" pitchFamily="34" charset="-120"/>
               </a:rPr>
-              <a:t>We worked on the weaknesses we had listed. For fairness we added an optional polite mode: when a standing queue builds, the agent backs off. Over 8 runs against tuned AIMD it takes 52 percent of the link instead of 70, and the Jain index rises from 0.86 to 0.94. The price is speed: on 100 random paths the average time goes from 0.53 to 0.58 times AIMD's, and the worst path is 2.95 times slower, so it stays off by default.</a:t>
+              <a:t>Fairness on real sockets: two neural flows split the link evenly, and so do two AIMD flows. But against tuned AIMD the neural agent takes 68 percent of the link, and 76 percent against the original AIMD. CUBIC takes 61 percent. So the agent is a more aggressive neighbour. Nothing starves, but it is not polite, and we did not test coexistence with TCP. That is our main limitation.</a:t>
             </a:r>
             <a:endParaRPr lang="en-US" sz="1400" dirty="0"/>
           </a:p>
@@ -27700,7 +27822,28 @@
                 <a:ea typeface="Calibri" pitchFamily="34" charset="-122"/>
                 <a:cs typeface="Calibri" pitchFamily="34" charset="-120"/>
               </a:rPr>
-              <a:t>We also added bursty cross traffic to the test proxy. Here the result is less flattering: the agent is 15 percent faster than tuned AIMD, but level with CUBIC, and it retransmits about three times as often as AIMD. Three tweaks did not fix that, so we report it as a limit. Finally the server now handles up to 16 clients, checked by sending two files at once.</a:t>
+              <a:t>We also added file transfer: the sender sends a real file and the received file is byte-identical in every run. A 4 megabyte file over the fast path takes 8.9 seconds with the agent against 21 seconds with tuned AIMD.</a:t>
+            </a:r>
+            <a:endParaRPr lang="en-US" sz="1400" dirty="0"/>
+          </a:p>
+          <a:p>
+            <a:pPr marL="342900" indent="-342900">
+              <a:spcAft>
+                <a:spcPts val="600"/>
+              </a:spcAft>
+              <a:buSzPct val="100000"/>
+              <a:buChar char="•"/>
+            </a:pPr>
+            <a:r>
+              <a:rPr lang="en-US" sz="1400" dirty="0">
+                <a:solidFill>
+                  <a:srgbClr val="1B2430"/>
+                </a:solidFill>
+                <a:latin typeface="Calibri" pitchFamily="34" charset="0"/>
+                <a:ea typeface="Calibri" pitchFamily="34" charset="-122"/>
+                <a:cs typeface="Calibri" pitchFamily="34" charset="-120"/>
+              </a:rPr>
+              <a:t>The chat and web gateway now use the same window and bitmap as the C transport, and there is CI, fuzzing and an architecture document.</a:t>
             </a:r>
             <a:endParaRPr lang="en-US" sz="1400" dirty="0"/>
           </a:p>
@@ -27778,7 +27921,7 @@
                 <a:ea typeface="Calibri" pitchFamily="34" charset="-122"/>
                 <a:cs typeface="Calibri" pitchFamily="34" charset="-120"/>
               </a:rPr>
-              <a:t>Is polite mode learned? No. It is a hand-made rule on the delay signal. A learned version needs a two-flow training environment, which is future work.</a:t>
+              <a:t>Would this be safe to deploy? Not on a shared link yet: it needs fairness-aware training and TCP coexistence tests. For a dedicated path it is a clear win.</a:t>
             </a:r>
             <a:endParaRPr lang="en-US" sz="1400" dirty="0"/>
           </a:p>
@@ -27849,7 +27992,7 @@
                 <a:ea typeface="Calibri" pitchFamily="34" charset="-122"/>
                 <a:cs typeface="Calibri" pitchFamily="34" charset="-120"/>
               </a:rPr>
-              <a:t>40. Limits we state openly</a:t>
+              <a:t>40. Closing gaps: fairness and cross traffic</a:t>
             </a:r>
             <a:endParaRPr lang="en-US" sz="2600" dirty="0"/>
           </a:p>
@@ -28041,7 +28184,7 @@
                 <a:ea typeface="Calibri" pitchFamily="34" charset="-122"/>
                 <a:cs typeface="Calibri" pitchFamily="34" charset="-120"/>
               </a:rPr>
-              <a:t>What is still not good. Kernel TCP is 1.5 to 1.7 times faster than our agent. Against tuned AIMD the agent takes about 70 percent of a shared link, and the polite mode that fixes it costs speed.</a:t>
+              <a:t>We worked on the weaknesses we had listed. For fairness we added an optional polite mode: when a standing queue builds, the agent backs off. Over 8 runs against tuned AIMD it takes 52 percent of the link instead of 70, and the Jain index rises from 0.86 to 0.94. The price is speed: on 100 random paths the average time goes from 0.53 to 0.58 times AIMD's, and the worst path is 2.95 times slower, so it stays off by default.</a:t>
             </a:r>
             <a:endParaRPr lang="en-US" sz="1400" dirty="0"/>
           </a:p>
@@ -28062,28 +28205,7 @@
                 <a:ea typeface="Calibri" pitchFamily="34" charset="-122"/>
                 <a:cs typeface="Calibri" pitchFamily="34" charset="-120"/>
               </a:rPr>
-              <a:t>It is level with CUBIC under bursty cross traffic, it gains nothing at 10 percent random loss, and the BBR-style baseline is faster on the 2 percent lossy path.</a:t>
-            </a:r>
-            <a:endParaRPr lang="en-US" sz="1400" dirty="0"/>
-          </a:p>
-          <a:p>
-            <a:pPr marL="342900" indent="-342900">
-              <a:spcAft>
-                <a:spcPts val="600"/>
-              </a:spcAft>
-              <a:buSzPct val="100000"/>
-              <a:buChar char="•"/>
-            </a:pPr>
-            <a:r>
-              <a:rPr lang="en-US" sz="1400" dirty="0">
-                <a:solidFill>
-                  <a:srgbClr val="1B2430"/>
-                </a:solidFill>
-                <a:latin typeface="Calibri" pitchFamily="34" charset="0"/>
-                <a:ea typeface="Calibri" pitchFamily="34" charset="-122"/>
-                <a:cs typeface="Calibri" pitchFamily="34" charset="-120"/>
-              </a:rPr>
-              <a:t>It is not formally verified: only 43 percent of decisions are certified at plus or minus 0.001. It was trained in a simulator. The two-machine run was one drifting relay path with four timeouts, so we claim no ranking from it.</a:t>
+              <a:t>We also added bursty cross traffic to the test proxy. Here the result is less flattering: the agent is 15 percent faster than tuned AIMD, but level with CUBIC, and it retransmits about three times as often as AIMD. Three tweaks did not fix that, so we report it as a limit. Finally the server now handles up to 16 clients, checked by sending two files at once.</a:t>
             </a:r>
             <a:endParaRPr lang="en-US" sz="1400" dirty="0"/>
           </a:p>
@@ -28161,7 +28283,7 @@
                 <a:ea typeface="Calibri" pitchFamily="34" charset="-122"/>
                 <a:cs typeface="Calibri" pitchFamily="34" charset="-120"/>
               </a:rPr>
-              <a:t>What would you do next? A direct-network multi-machine run with more repetitions, training with a competing flow so fairness is learned, and training on real traces.</a:t>
+              <a:t>Is polite mode learned? No. It is a hand-made rule on the delay signal. A learned version needs a two-flow training environment, which is future work.</a:t>
             </a:r>
             <a:endParaRPr lang="en-US" sz="1400" dirty="0"/>
           </a:p>
@@ -28232,7 +28354,7 @@
                 <a:ea typeface="Calibri" pitchFamily="34" charset="-122"/>
                 <a:cs typeface="Calibri" pitchFamily="34" charset="-120"/>
               </a:rPr>
-              <a:t>41. Learnings and future work</a:t>
+              <a:t>41. Limits we state openly</a:t>
             </a:r>
             <a:endParaRPr lang="en-US" sz="2600" dirty="0"/>
           </a:p>
@@ -28424,7 +28546,7 @@
                 <a:ea typeface="Calibri" pitchFamily="34" charset="-122"/>
                 <a:cs typeface="Calibri" pitchFamily="34" charset="-120"/>
               </a:rPr>
-              <a:t>What we learned: reliability is a set of simple rules working together, congestion control matters as much as retransmission, and tests tell you things about your own results that you do not want to hear.</a:t>
+              <a:t>What is still not good. Kernel TCP is 1.5 to 1.7 times faster than our agent. Against tuned AIMD the agent takes about 70 percent of a shared link, and the polite mode that fixes it costs speed.</a:t>
             </a:r>
             <a:endParaRPr lang="en-US" sz="1400" dirty="0"/>
           </a:p>
@@ -28445,7 +28567,7 @@
                 <a:ea typeface="Calibri" pitchFamily="34" charset="-122"/>
                 <a:cs typeface="Calibri" pitchFamily="34" charset="-120"/>
               </a:rPr>
-              <a:t>The limits are on the previous slide; in short: only one noisy two-machine run, the agent is not a polite neighbour, there is no gain at 10 percent random loss, and the tabular agent did not beat AIMD.</a:t>
+              <a:t>It is level with CUBIC under bursty cross traffic, it gains nothing at 10 percent random loss, and the BBR-style baseline is faster on the 2 percent lossy path.</a:t>
             </a:r>
             <a:endParaRPr lang="en-US" sz="1400" dirty="0"/>
           </a:p>
@@ -28466,7 +28588,7 @@
                 <a:ea typeface="Calibri" pitchFamily="34" charset="-122"/>
                 <a:cs typeface="Calibri" pitchFamily="34" charset="-120"/>
               </a:rPr>
-              <a:t>Next: fairness-aware training with TCP coexistence, training on real traces, and controlled multi-machine tests.</a:t>
+              <a:t>It is not formally verified: only 43 percent of decisions are certified at plus or minus 0.001. It was trained in a simulator. The two-machine run was one drifting relay path with four timeouts, so we claim no ranking from it.</a:t>
             </a:r>
             <a:endParaRPr lang="en-US" sz="1400" dirty="0"/>
           </a:p>
@@ -28544,7 +28666,7 @@
                 <a:ea typeface="Calibri" pitchFamily="34" charset="-122"/>
                 <a:cs typeface="Calibri" pitchFamily="34" charset="-120"/>
               </a:rPr>
-              <a:t>What would you do first? Run the netem script on a Linux machine for kernel TCP and RUDP on the same path, then add a competing flow to the training.</a:t>
+              <a:t>What would you do next? A direct-network multi-machine run with more repetitions, training with a competing flow so fairness is learned, and training on real traces.</a:t>
             </a:r>
             <a:endParaRPr lang="en-US" sz="1400" dirty="0"/>
           </a:p>
@@ -28615,7 +28737,7 @@
                 <a:ea typeface="Calibri" pitchFamily="34" charset="-122"/>
                 <a:cs typeface="Calibri" pitchFamily="34" charset="-120"/>
               </a:rPr>
-              <a:t>42. Thank you</a:t>
+              <a:t>42. Learnings and future work</a:t>
             </a:r>
             <a:endParaRPr lang="en-US" sz="2600" dirty="0"/>
           </a:p>
@@ -28654,7 +28776,7 @@
                 <a:ea typeface="Calibri" pitchFamily="34" charset="-122"/>
                 <a:cs typeface="Calibri" pitchFamily="34" charset="-120"/>
               </a:rPr>
-              <a:t>Time on this slide: 0:15</a:t>
+              <a:t>Time on this slide: 0:50</a:t>
             </a:r>
             <a:endParaRPr lang="en-US" sz="1300" dirty="0"/>
           </a:p>
@@ -28799,7 +28921,7 @@
               <a:buChar char="•"/>
             </a:pPr>
             <a:r>
-              <a:rPr lang="en-US" sz="1600" dirty="0">
+              <a:rPr lang="en-US" sz="1400" dirty="0">
                 <a:solidFill>
                   <a:srgbClr val="1B2430"/>
                 </a:solidFill>
@@ -28807,9 +28929,51 @@
                 <a:ea typeface="Calibri" pitchFamily="34" charset="-122"/>
                 <a:cs typeface="Calibri" pitchFamily="34" charset="-120"/>
               </a:rPr>
-              <a:t>Thank you. The code, report and captures are at github.com/Capsturrrr/rudp. Happy to take questions.</a:t>
-            </a:r>
-            <a:endParaRPr lang="en-US" sz="1600" dirty="0"/>
+              <a:t>What we learned: reliability is a set of simple rules working together, congestion control matters as much as retransmission, and tests tell you things about your own results that you do not want to hear.</a:t>
+            </a:r>
+            <a:endParaRPr lang="en-US" sz="1400" dirty="0"/>
+          </a:p>
+          <a:p>
+            <a:pPr marL="342900" indent="-342900">
+              <a:spcAft>
+                <a:spcPts val="600"/>
+              </a:spcAft>
+              <a:buSzPct val="100000"/>
+              <a:buChar char="•"/>
+            </a:pPr>
+            <a:r>
+              <a:rPr lang="en-US" sz="1400" dirty="0">
+                <a:solidFill>
+                  <a:srgbClr val="1B2430"/>
+                </a:solidFill>
+                <a:latin typeface="Calibri" pitchFamily="34" charset="0"/>
+                <a:ea typeface="Calibri" pitchFamily="34" charset="-122"/>
+                <a:cs typeface="Calibri" pitchFamily="34" charset="-120"/>
+              </a:rPr>
+              <a:t>The limits are on the previous slide; in short: only one noisy two-machine run, the agent is not a polite neighbour, there is no gain at 10 percent random loss, and the tabular agent did not beat AIMD.</a:t>
+            </a:r>
+            <a:endParaRPr lang="en-US" sz="1400" dirty="0"/>
+          </a:p>
+          <a:p>
+            <a:pPr marL="342900" indent="-342900">
+              <a:spcAft>
+                <a:spcPts val="600"/>
+              </a:spcAft>
+              <a:buSzPct val="100000"/>
+              <a:buChar char="•"/>
+            </a:pPr>
+            <a:r>
+              <a:rPr lang="en-US" sz="1400" dirty="0">
+                <a:solidFill>
+                  <a:srgbClr val="1B2430"/>
+                </a:solidFill>
+                <a:latin typeface="Calibri" pitchFamily="34" charset="0"/>
+                <a:ea typeface="Calibri" pitchFamily="34" charset="-122"/>
+                <a:cs typeface="Calibri" pitchFamily="34" charset="-120"/>
+              </a:rPr>
+              <a:t>Next: fairness-aware training with TCP coexistence, training on real traces, and controlled multi-machine tests.</a:t>
+            </a:r>
+            <a:endParaRPr lang="en-US" sz="1400" dirty="0"/>
           </a:p>
         </p:txBody>
       </p:sp>
@@ -28885,7 +29049,7 @@
                 <a:ea typeface="Calibri" pitchFamily="34" charset="-122"/>
                 <a:cs typeface="Calibri" pitchFamily="34" charset="-120"/>
               </a:rPr>
-              <a:t>Pause and smile; hand over to questions.</a:t>
+              <a:t>What would you do first? Run the netem script on a Linux machine for kernel TCP and RUDP on the same path, then add a competing flow to the training.</a:t>
             </a:r>
             <a:endParaRPr lang="en-US" sz="1400" dirty="0"/>
           </a:p>
@@ -28956,7 +29120,7 @@
                 <a:ea typeface="Calibri" pitchFamily="34" charset="-122"/>
                 <a:cs typeface="Calibri" pitchFamily="34" charset="-120"/>
               </a:rPr>
-              <a:t>43. Appendix: slow start and congestion avoidance</a:t>
+              <a:t>43. Thank you</a:t>
             </a:r>
             <a:endParaRPr lang="en-US" sz="2600" dirty="0"/>
           </a:p>
@@ -28995,7 +29159,7 @@
                 <a:ea typeface="Calibri" pitchFamily="34" charset="-122"/>
                 <a:cs typeface="Calibri" pitchFamily="34" charset="-120"/>
               </a:rPr>
-              <a:t>Time on this slide: -</a:t>
+              <a:t>Time on this slide: 0:15</a:t>
             </a:r>
             <a:endParaRPr lang="en-US" sz="1300" dirty="0"/>
           </a:p>
@@ -29148,7 +29312,7 @@
                 <a:ea typeface="Calibri" pitchFamily="34" charset="-122"/>
                 <a:cs typeface="Calibri" pitchFamily="34" charset="-120"/>
               </a:rPr>
-              <a:t>Only if asked: the window starts at 1, adds 1 per ACK until the threshold 16, then 1/window per ACK. In the 62-packet run the final window was 18.71.</a:t>
+              <a:t>Thank you. The code, report and captures are at github.com/Capsturrrr/rudp. Happy to take questions.</a:t>
             </a:r>
             <a:endParaRPr lang="en-US" sz="1600" dirty="0"/>
           </a:p>
@@ -29226,7 +29390,7 @@
                 <a:ea typeface="Calibri" pitchFamily="34" charset="-122"/>
                 <a:cs typeface="Calibri" pitchFamily="34" charset="-120"/>
               </a:rPr>
-              <a:t>Use this slide to answer 'show me congestion avoidance'.</a:t>
+              <a:t>Pause and smile; hand over to questions.</a:t>
             </a:r>
             <a:endParaRPr lang="en-US" sz="1400" dirty="0"/>
           </a:p>
@@ -29297,7 +29461,7 @@
                 <a:ea typeface="Calibri" pitchFamily="34" charset="-122"/>
                 <a:cs typeface="Calibri" pitchFamily="34" charset="-120"/>
               </a:rPr>
-              <a:t>Hard questions and short answers (1 of 3)</a:t>
+              <a:t>44. Appendix: slow start and congestion avoidance</a:t>
             </a:r>
             <a:endParaRPr lang="en-US" sz="2600" dirty="0"/>
           </a:p>
@@ -29305,7 +29469,46 @@
       </p:sp>
       <p:sp>
         <p:nvSpPr>
-          <p:cNvPr id="3" name="Shape 1"/>
+          <p:cNvPr id="3" name="Text 1"/>
+          <p:cNvSpPr/>
+          <p:nvPr/>
+        </p:nvSpPr>
+        <p:spPr>
+          <a:xfrm>
+            <a:off x="457200" y="804672"/>
+            <a:ext cx="10972800" cy="320040"/>
+          </a:xfrm>
+          <a:prstGeom prst="rect">
+            <a:avLst/>
+          </a:prstGeom>
+          <a:noFill/>
+          <a:ln/>
+        </p:spPr>
+        <p:txBody>
+          <a:bodyPr wrap="square" lIns="0" tIns="0" rIns="0" bIns="0" rtlCol="0" anchor="ctr"/>
+          <a:lstStyle/>
+          <a:p>
+            <a:pPr indent="0" marL="0">
+              <a:buNone/>
+            </a:pPr>
+            <a:r>
+              <a:rPr lang="en-US" sz="1300" dirty="0">
+                <a:solidFill>
+                  <a:srgbClr val="5B6775"/>
+                </a:solidFill>
+                <a:latin typeface="Calibri" pitchFamily="34" charset="0"/>
+                <a:ea typeface="Calibri" pitchFamily="34" charset="-122"/>
+                <a:cs typeface="Calibri" pitchFamily="34" charset="-120"/>
+              </a:rPr>
+              <a:t>Time on this slide: -</a:t>
+            </a:r>
+            <a:endParaRPr lang="en-US" sz="1300" dirty="0"/>
+          </a:p>
+        </p:txBody>
+      </p:sp>
+      <p:sp>
+        <p:nvSpPr>
+          <p:cNvPr id="4" name="Shape 2"/>
           <p:cNvSpPr/>
           <p:nvPr/>
         </p:nvSpPr>
@@ -29328,26 +29531,47 @@
           </a:ln>
         </p:spPr>
       </p:sp>
-      <p:sp>
-        <p:nvSpPr>
-          <p:cNvPr id="4" name="Shape 2"/>
-          <p:cNvSpPr/>
-          <p:nvPr/>
-        </p:nvSpPr>
+      <p:pic>
+        <p:nvPicPr>
+          <p:cNvPr id="5" name="Image 0" descr="th-44.png">    </p:cNvPr>
+          <p:cNvPicPr>
+            <a:picLocks noChangeAspect="1"/>
+          </p:cNvPicPr>
+          <p:nvPr/>
+        </p:nvPicPr>
+        <p:blipFill>
+          <a:blip r:embed="rId1"/>
+          <a:stretch>
+            <a:fillRect/>
+          </a:stretch>
+        </p:blipFill>
         <p:spPr>
           <a:xfrm>
             <a:off x="457200" y="1371600"/>
-            <a:ext cx="11274552" cy="914400"/>
-          </a:xfrm>
-          <a:prstGeom prst="rect">
-            <a:avLst/>
-          </a:prstGeom>
-          <a:solidFill>
-            <a:srgbClr val="F2F6FB"/>
-          </a:solidFill>
-          <a:ln w="9525">
+            <a:ext cx="5669280" cy="3188970"/>
+          </a:xfrm>
+          <a:prstGeom prst="rect">
+            <a:avLst/>
+          </a:prstGeom>
+        </p:spPr>
+      </p:pic>
+      <p:sp>
+        <p:nvSpPr>
+          <p:cNvPr id="6" name="Shape 3"/>
+          <p:cNvSpPr/>
+          <p:nvPr/>
+        </p:nvSpPr>
+        <p:spPr>
+          <a:xfrm>
+            <a:off x="457200" y="1371600"/>
+            <a:ext cx="5669280" cy="3188970"/>
+          </a:xfrm>
+          <a:prstGeom prst="rect">
+            <a:avLst/>
+          </a:prstGeom>
+          <a:ln w="12700">
             <a:solidFill>
-              <a:srgbClr val="D5DEE9"/>
+              <a:srgbClr val="C9D3E0"/>
             </a:solidFill>
             <a:prstDash val="solid"/>
           </a:ln>
@@ -29355,14 +29579,14 @@
       </p:sp>
       <p:sp>
         <p:nvSpPr>
-          <p:cNvPr id="5" name="Text 3"/>
-          <p:cNvSpPr/>
-          <p:nvPr/>
-        </p:nvSpPr>
-        <p:spPr>
-          <a:xfrm>
-            <a:off x="640080" y="1417320"/>
-            <a:ext cx="10972800" cy="320040"/>
+          <p:cNvPr id="7" name="Text 4"/>
+          <p:cNvSpPr/>
+          <p:nvPr/>
+        </p:nvSpPr>
+        <p:spPr>
+          <a:xfrm>
+            <a:off x="6400800" y="1325880"/>
+            <a:ext cx="1828800" cy="320040"/>
           </a:xfrm>
           <a:prstGeom prst="rect">
             <a:avLst/>
@@ -29378,7 +29602,7 @@
               <a:buNone/>
             </a:pPr>
             <a:r>
-              <a:rPr lang="en-US" sz="1500" b="1" dirty="0">
+              <a:rPr lang="en-US" sz="1300" b="1" dirty="0">
                 <a:solidFill>
                   <a:srgbClr val="1F6FEB"/>
                 </a:solidFill>
@@ -29386,22 +29610,22 @@
                 <a:ea typeface="Calibri" pitchFamily="34" charset="-122"/>
                 <a:cs typeface="Calibri" pitchFamily="34" charset="-120"/>
               </a:rPr>
-              <a:t>Is this a lab exercise?</a:t>
-            </a:r>
-            <a:endParaRPr lang="en-US" sz="1500" dirty="0"/>
-          </a:p>
-        </p:txBody>
-      </p:sp>
-      <p:sp>
-        <p:nvSpPr>
-          <p:cNvPr id="6" name="Text 4"/>
-          <p:cNvSpPr/>
-          <p:nvPr/>
-        </p:nvSpPr>
-        <p:spPr>
-          <a:xfrm>
-            <a:off x="640080" y="1737360"/>
-            <a:ext cx="10972800" cy="530352"/>
+              <a:t>SAY</a:t>
+            </a:r>
+            <a:endParaRPr lang="en-US" sz="1300" dirty="0"/>
+          </a:p>
+        </p:txBody>
+      </p:sp>
+      <p:sp>
+        <p:nvSpPr>
+          <p:cNvPr id="8" name="Text 5"/>
+          <p:cNvSpPr/>
+          <p:nvPr/>
+        </p:nvSpPr>
+        <p:spPr>
+          <a:xfrm>
+            <a:off x="6400800" y="1645920"/>
+            <a:ext cx="5349240" cy="3017520"/>
           </a:xfrm>
           <a:prstGeom prst="rect">
             <a:avLst/>
@@ -29413,11 +29637,15 @@
           <a:bodyPr wrap="square" lIns="0" tIns="0" rIns="0" bIns="0" rtlCol="0" anchor="t"/>
           <a:lstStyle/>
           <a:p>
-            <a:pPr indent="0" marL="0">
-              <a:buNone/>
-            </a:pPr>
-            <a:r>
-              <a:rPr lang="en-US" sz="1350" dirty="0">
+            <a:pPr marL="342900" indent="-342900">
+              <a:spcAft>
+                <a:spcPts val="600"/>
+              </a:spcAft>
+              <a:buSzPct val="100000"/>
+              <a:buChar char="•"/>
+            </a:pPr>
+            <a:r>
+              <a:rPr lang="en-US" sz="1600" dirty="0">
                 <a:solidFill>
                   <a:srgbClr val="1B2430"/>
                 </a:solidFill>
@@ -29425,32 +29653,32 @@
                 <a:ea typeface="Calibri" pitchFamily="34" charset="-122"/>
                 <a:cs typeface="Calibri" pitchFamily="34" charset="-120"/>
               </a:rPr>
-              <a:t>A lab sends datagrams. We built reliability and congestion control on top, measured them, and used them in a real chat and a routed network.</a:t>
-            </a:r>
-            <a:endParaRPr lang="en-US" sz="1350" dirty="0"/>
-          </a:p>
-        </p:txBody>
-      </p:sp>
-      <p:sp>
-        <p:nvSpPr>
-          <p:cNvPr id="7" name="Shape 5"/>
-          <p:cNvSpPr/>
-          <p:nvPr/>
-        </p:nvSpPr>
-        <p:spPr>
-          <a:xfrm>
-            <a:off x="457200" y="2377440"/>
-            <a:ext cx="11274552" cy="914400"/>
+              <a:t>Only if asked: the window starts at 1, adds 1 per ACK until the threshold 16, then 1/window per ACK. In the 62-packet run the final window was 18.71.</a:t>
+            </a:r>
+            <a:endParaRPr lang="en-US" sz="1600" dirty="0"/>
+          </a:p>
+        </p:txBody>
+      </p:sp>
+      <p:sp>
+        <p:nvSpPr>
+          <p:cNvPr id="9" name="Shape 6"/>
+          <p:cNvSpPr/>
+          <p:nvPr/>
+        </p:nvSpPr>
+        <p:spPr>
+          <a:xfrm>
+            <a:off x="457200" y="4709160"/>
+            <a:ext cx="5669280" cy="1737360"/>
           </a:xfrm>
           <a:prstGeom prst="rect">
             <a:avLst/>
           </a:prstGeom>
           <a:solidFill>
-            <a:srgbClr val="F2F6FB"/>
+            <a:srgbClr val="FFF6E5"/>
           </a:solidFill>
-          <a:ln w="9525">
+          <a:ln w="12700">
             <a:solidFill>
-              <a:srgbClr val="D5DEE9"/>
+              <a:srgbClr val="F0C987"/>
             </a:solidFill>
             <a:prstDash val="solid"/>
           </a:ln>
@@ -29458,14 +29686,14 @@
       </p:sp>
       <p:sp>
         <p:nvSpPr>
-          <p:cNvPr id="8" name="Text 6"/>
-          <p:cNvSpPr/>
-          <p:nvPr/>
-        </p:nvSpPr>
-        <p:spPr>
-          <a:xfrm>
-            <a:off x="640080" y="2423160"/>
-            <a:ext cx="10972800" cy="320040"/>
+          <p:cNvPr id="10" name="Text 7"/>
+          <p:cNvSpPr/>
+          <p:nvPr/>
+        </p:nvSpPr>
+        <p:spPr>
+          <a:xfrm>
+            <a:off x="594360" y="4754880"/>
+            <a:ext cx="5394960" cy="1645920"/>
           </a:xfrm>
           <a:prstGeom prst="rect">
             <a:avLst/>
@@ -29474,53 +29702,28 @@
           <a:ln/>
         </p:spPr>
         <p:txBody>
-          <a:bodyPr wrap="square" lIns="0" tIns="0" rIns="0" bIns="0" rtlCol="0" anchor="ctr"/>
+          <a:bodyPr wrap="square" lIns="0" tIns="0" rIns="0" bIns="0" rtlCol="0" anchor="t"/>
           <a:lstStyle/>
           <a:p>
             <a:pPr indent="0" marL="0">
               <a:buNone/>
             </a:pPr>
             <a:r>
-              <a:rPr lang="en-US" sz="1500" b="1" dirty="0">
-                <a:solidFill>
-                  <a:srgbClr val="1F6FEB"/>
-                </a:solidFill>
-                <a:latin typeface="Calibri" pitchFamily="34" charset="0"/>
-                <a:ea typeface="Calibri" pitchFamily="34" charset="-122"/>
-                <a:cs typeface="Calibri" pitchFamily="34" charset="-120"/>
-              </a:rPr>
-              <a:t>Why not TCP?</a:t>
-            </a:r>
-            <a:endParaRPr lang="en-US" sz="1500" dirty="0"/>
-          </a:p>
-        </p:txBody>
-      </p:sp>
-      <p:sp>
-        <p:nvSpPr>
-          <p:cNvPr id="9" name="Text 7"/>
-          <p:cNvSpPr/>
-          <p:nvPr/>
-        </p:nvSpPr>
-        <p:spPr>
-          <a:xfrm>
-            <a:off x="640080" y="2743200"/>
-            <a:ext cx="10972800" cy="530352"/>
-          </a:xfrm>
-          <a:prstGeom prst="rect">
-            <a:avLst/>
-          </a:prstGeom>
-          <a:noFill/>
-          <a:ln/>
-        </p:spPr>
-        <p:txBody>
-          <a:bodyPr wrap="square" lIns="0" tIns="0" rIns="0" bIns="0" rtlCol="0" anchor="t"/>
-          <a:lstStyle/>
-          <a:p>
+              <a:rPr lang="en-US" sz="1400" b="1" dirty="0">
+                <a:solidFill>
+                  <a:srgbClr val="B45309"/>
+                </a:solidFill>
+                <a:latin typeface="Calibri" pitchFamily="34" charset="0"/>
+                <a:ea typeface="Calibri" pitchFamily="34" charset="-122"/>
+                <a:cs typeface="Calibri" pitchFamily="34" charset="-120"/>
+              </a:rPr>
+              <a:t>IF ASKED  </a:t>
+            </a:r>
             <a:pPr indent="0" marL="0">
               <a:buNone/>
             </a:pPr>
             <a:r>
-              <a:rPr lang="en-US" sz="1350" dirty="0">
+              <a:rPr lang="en-US" sz="1400" dirty="0">
                 <a:solidFill>
                   <a:srgbClr val="1B2430"/>
                 </a:solidFill>
@@ -29528,318 +29731,9 @@
                 <a:ea typeface="Calibri" pitchFamily="34" charset="-122"/>
                 <a:cs typeface="Calibri" pitchFamily="34" charset="-120"/>
               </a:rPr>
-              <a:t>TCP is in the kernel and cannot be changed. Building our own makes every mechanism visible. QUIC and HTTP/3 do the same.</a:t>
-            </a:r>
-            <a:endParaRPr lang="en-US" sz="1350" dirty="0"/>
-          </a:p>
-        </p:txBody>
-      </p:sp>
-      <p:sp>
-        <p:nvSpPr>
-          <p:cNvPr id="10" name="Shape 8"/>
-          <p:cNvSpPr/>
-          <p:nvPr/>
-        </p:nvSpPr>
-        <p:spPr>
-          <a:xfrm>
-            <a:off x="457200" y="3383280"/>
-            <a:ext cx="11274552" cy="914400"/>
-          </a:xfrm>
-          <a:prstGeom prst="rect">
-            <a:avLst/>
-          </a:prstGeom>
-          <a:solidFill>
-            <a:srgbClr val="F2F6FB"/>
-          </a:solidFill>
-          <a:ln w="9525">
-            <a:solidFill>
-              <a:srgbClr val="D5DEE9"/>
-            </a:solidFill>
-            <a:prstDash val="solid"/>
-          </a:ln>
-        </p:spPr>
-      </p:sp>
-      <p:sp>
-        <p:nvSpPr>
-          <p:cNvPr id="11" name="Text 9"/>
-          <p:cNvSpPr/>
-          <p:nvPr/>
-        </p:nvSpPr>
-        <p:spPr>
-          <a:xfrm>
-            <a:off x="640080" y="3429000"/>
-            <a:ext cx="10972800" cy="320040"/>
-          </a:xfrm>
-          <a:prstGeom prst="rect">
-            <a:avLst/>
-          </a:prstGeom>
-          <a:noFill/>
-          <a:ln/>
-        </p:spPr>
-        <p:txBody>
-          <a:bodyPr wrap="square" lIns="0" tIns="0" rIns="0" bIns="0" rtlCol="0" anchor="ctr"/>
-          <a:lstStyle/>
-          <a:p>
-            <a:pPr indent="0" marL="0">
-              <a:buNone/>
-            </a:pPr>
-            <a:r>
-              <a:rPr lang="en-US" sz="1500" b="1" dirty="0">
-                <a:solidFill>
-                  <a:srgbClr val="1F6FEB"/>
-                </a:solidFill>
-                <a:latin typeface="Calibri" pitchFamily="34" charset="0"/>
-                <a:ea typeface="Calibri" pitchFamily="34" charset="-122"/>
-                <a:cs typeface="Calibri" pitchFamily="34" charset="-120"/>
-              </a:rPr>
-              <a:t>Did Smart-RUDP win?</a:t>
-            </a:r>
-            <a:endParaRPr lang="en-US" sz="1500" dirty="0"/>
-          </a:p>
-        </p:txBody>
-      </p:sp>
-      <p:sp>
-        <p:nvSpPr>
-          <p:cNvPr id="12" name="Text 10"/>
-          <p:cNvSpPr/>
-          <p:nvPr/>
-        </p:nvSpPr>
-        <p:spPr>
-          <a:xfrm>
-            <a:off x="640080" y="3749040"/>
-            <a:ext cx="10972800" cy="530352"/>
-          </a:xfrm>
-          <a:prstGeom prst="rect">
-            <a:avLst/>
-          </a:prstGeom>
-          <a:noFill/>
-          <a:ln/>
-        </p:spPr>
-        <p:txBody>
-          <a:bodyPr wrap="square" lIns="0" tIns="0" rIns="0" bIns="0" rtlCol="0" anchor="t"/>
-          <a:lstStyle/>
-          <a:p>
-            <a:pPr indent="0" marL="0">
-              <a:buNone/>
-            </a:pPr>
-            <a:r>
-              <a:rPr lang="en-US" sz="1350" dirty="0">
-                <a:solidFill>
-                  <a:srgbClr val="1B2430"/>
-                </a:solidFill>
-                <a:latin typeface="Calibri" pitchFamily="34" charset="0"/>
-                <a:ea typeface="Calibri" pitchFamily="34" charset="-122"/>
-                <a:cs typeface="Calibri" pitchFamily="34" charset="-120"/>
-              </a:rPr>
-              <a:t>Yes, in the final C transport against tuned baselines: 15 to 52 percent less time than tuned AIMD on four ordinary paths (real clock, real sockets and 100 random held-out paths agree), a tie on the 10 percent loss path. Against a simplified BBR it wins on the satellite-like and fast paths and loses on the 2 percent lossy path. The first tabular agent did not beat AIMD, and we say so.</a:t>
-            </a:r>
-            <a:endParaRPr lang="en-US" sz="1350" dirty="0"/>
-          </a:p>
-        </p:txBody>
-      </p:sp>
-      <p:sp>
-        <p:nvSpPr>
-          <p:cNvPr id="13" name="Shape 11"/>
-          <p:cNvSpPr/>
-          <p:nvPr/>
-        </p:nvSpPr>
-        <p:spPr>
-          <a:xfrm>
-            <a:off x="457200" y="4389120"/>
-            <a:ext cx="11274552" cy="914400"/>
-          </a:xfrm>
-          <a:prstGeom prst="rect">
-            <a:avLst/>
-          </a:prstGeom>
-          <a:solidFill>
-            <a:srgbClr val="F2F6FB"/>
-          </a:solidFill>
-          <a:ln w="9525">
-            <a:solidFill>
-              <a:srgbClr val="D5DEE9"/>
-            </a:solidFill>
-            <a:prstDash val="solid"/>
-          </a:ln>
-        </p:spPr>
-      </p:sp>
-      <p:sp>
-        <p:nvSpPr>
-          <p:cNvPr id="14" name="Text 12"/>
-          <p:cNvSpPr/>
-          <p:nvPr/>
-        </p:nvSpPr>
-        <p:spPr>
-          <a:xfrm>
-            <a:off x="640080" y="4434840"/>
-            <a:ext cx="10972800" cy="320040"/>
-          </a:xfrm>
-          <a:prstGeom prst="rect">
-            <a:avLst/>
-          </a:prstGeom>
-          <a:noFill/>
-          <a:ln/>
-        </p:spPr>
-        <p:txBody>
-          <a:bodyPr wrap="square" lIns="0" tIns="0" rIns="0" bIns="0" rtlCol="0" anchor="ctr"/>
-          <a:lstStyle/>
-          <a:p>
-            <a:pPr indent="0" marL="0">
-              <a:buNone/>
-            </a:pPr>
-            <a:r>
-              <a:rPr lang="en-US" sz="1500" b="1" dirty="0">
-                <a:solidFill>
-                  <a:srgbClr val="1F6FEB"/>
-                </a:solidFill>
-                <a:latin typeface="Calibri" pitchFamily="34" charset="0"/>
-                <a:ea typeface="Calibri" pitchFamily="34" charset="-122"/>
-                <a:cs typeface="Calibri" pitchFamily="34" charset="-120"/>
-              </a:rPr>
-              <a:t>Why Go-Back-N?</a:t>
-            </a:r>
-            <a:endParaRPr lang="en-US" sz="1500" dirty="0"/>
-          </a:p>
-        </p:txBody>
-      </p:sp>
-      <p:sp>
-        <p:nvSpPr>
-          <p:cNvPr id="15" name="Text 13"/>
-          <p:cNvSpPr/>
-          <p:nvPr/>
-        </p:nvSpPr>
-        <p:spPr>
-          <a:xfrm>
-            <a:off x="640080" y="4754880"/>
-            <a:ext cx="10972800" cy="530352"/>
-          </a:xfrm>
-          <a:prstGeom prst="rect">
-            <a:avLst/>
-          </a:prstGeom>
-          <a:noFill/>
-          <a:ln/>
-        </p:spPr>
-        <p:txBody>
-          <a:bodyPr wrap="square" lIns="0" tIns="0" rIns="0" bIns="0" rtlCol="0" anchor="t"/>
-          <a:lstStyle/>
-          <a:p>
-            <a:pPr indent="0" marL="0">
-              <a:buNone/>
-            </a:pPr>
-            <a:r>
-              <a:rPr lang="en-US" sz="1350" dirty="0">
-                <a:solidFill>
-                  <a:srgbClr val="1B2430"/>
-                </a:solidFill>
-                <a:latin typeface="Calibri" pitchFamily="34" charset="0"/>
-                <a:ea typeface="Calibri" pitchFamily="34" charset="-122"/>
-                <a:cs typeface="Calibri" pitchFamily="34" charset="-120"/>
-              </a:rPr>
-              <a:t>We started with it because it is simple to build and explain, then replaced it as the default with Selective Repeat: the receiver buffers out-of-order packets and reports them in an ACK bitmap, and the sender resends only what is missing. Go-Back-N stays behind a flag for comparison.</a:t>
-            </a:r>
-            <a:endParaRPr lang="en-US" sz="1350" dirty="0"/>
-          </a:p>
-        </p:txBody>
-      </p:sp>
-      <p:sp>
-        <p:nvSpPr>
-          <p:cNvPr id="16" name="Shape 14"/>
-          <p:cNvSpPr/>
-          <p:nvPr/>
-        </p:nvSpPr>
-        <p:spPr>
-          <a:xfrm>
-            <a:off x="457200" y="5394960"/>
-            <a:ext cx="11274552" cy="914400"/>
-          </a:xfrm>
-          <a:prstGeom prst="rect">
-            <a:avLst/>
-          </a:prstGeom>
-          <a:solidFill>
-            <a:srgbClr val="F2F6FB"/>
-          </a:solidFill>
-          <a:ln w="9525">
-            <a:solidFill>
-              <a:srgbClr val="D5DEE9"/>
-            </a:solidFill>
-            <a:prstDash val="solid"/>
-          </a:ln>
-        </p:spPr>
-      </p:sp>
-      <p:sp>
-        <p:nvSpPr>
-          <p:cNvPr id="17" name="Text 15"/>
-          <p:cNvSpPr/>
-          <p:nvPr/>
-        </p:nvSpPr>
-        <p:spPr>
-          <a:xfrm>
-            <a:off x="640080" y="5440680"/>
-            <a:ext cx="10972800" cy="320040"/>
-          </a:xfrm>
-          <a:prstGeom prst="rect">
-            <a:avLst/>
-          </a:prstGeom>
-          <a:noFill/>
-          <a:ln/>
-        </p:spPr>
-        <p:txBody>
-          <a:bodyPr wrap="square" lIns="0" tIns="0" rIns="0" bIns="0" rtlCol="0" anchor="ctr"/>
-          <a:lstStyle/>
-          <a:p>
-            <a:pPr indent="0" marL="0">
-              <a:buNone/>
-            </a:pPr>
-            <a:r>
-              <a:rPr lang="en-US" sz="1500" b="1" dirty="0">
-                <a:solidFill>
-                  <a:srgbClr val="1F6FEB"/>
-                </a:solidFill>
-                <a:latin typeface="Calibri" pitchFamily="34" charset="0"/>
-                <a:ea typeface="Calibri" pitchFamily="34" charset="-122"/>
-                <a:cs typeface="Calibri" pitchFamily="34" charset="-120"/>
-              </a:rPr>
-              <a:t>Was it tested between machines?</a:t>
-            </a:r>
-            <a:endParaRPr lang="en-US" sz="1500" dirty="0"/>
-          </a:p>
-        </p:txBody>
-      </p:sp>
-      <p:sp>
-        <p:nvSpPr>
-          <p:cNvPr id="18" name="Text 16"/>
-          <p:cNvSpPr/>
-          <p:nvPr/>
-        </p:nvSpPr>
-        <p:spPr>
-          <a:xfrm>
-            <a:off x="640080" y="5760720"/>
-            <a:ext cx="10972800" cy="530352"/>
-          </a:xfrm>
-          <a:prstGeom prst="rect">
-            <a:avLst/>
-          </a:prstGeom>
-          <a:noFill/>
-          <a:ln/>
-        </p:spPr>
-        <p:txBody>
-          <a:bodyPr wrap="square" lIns="0" tIns="0" rIns="0" bIns="0" rtlCol="0" anchor="t"/>
-          <a:lstStyle/>
-          <a:p>
-            <a:pPr indent="0" marL="0">
-              <a:buNone/>
-            </a:pPr>
-            <a:r>
-              <a:rPr lang="en-US" sz="1350" dirty="0">
-                <a:solidFill>
-                  <a:srgbClr val="1B2430"/>
-                </a:solidFill>
-                <a:latin typeface="Calibri" pitchFamily="34" charset="0"/>
-                <a:ea typeface="Calibri" pitchFamily="34" charset="-122"/>
-                <a:cs typeface="Calibri" pitchFamily="34" charset="-120"/>
-              </a:rPr>
-              <a:t>Yes. Delay, loss and jitter are emulated in our client, in a separate proxy on real UDP sockets, and in virtual time; these agree with each other. We also ran it once on the Linux kernel with tc netem on one laptop: the agent beat tuned AIMD there, but kernel TCP was 1.5 to 1.7 times faster than us. We also made one run between two laptops on different networks over a Tailscale relay: RUDP delivered every transfer that finished, but the path drifted and four of twenty runs timed out, so we do not rank the policies from it; kernel TCP was 2 to 6 times faster on the clean repetitions.</a:t>
-            </a:r>
-            <a:endParaRPr lang="en-US" sz="1350" dirty="0"/>
+              <a:t>Use this slide to answer 'show me congestion avoidance'.</a:t>
+            </a:r>
+            <a:endParaRPr lang="en-US" sz="1400" dirty="0"/>
           </a:p>
         </p:txBody>
       </p:sp>
@@ -29908,7 +29802,7 @@
                 <a:ea typeface="Calibri" pitchFamily="34" charset="-122"/>
                 <a:cs typeface="Calibri" pitchFamily="34" charset="-120"/>
               </a:rPr>
-              <a:t>Hard questions and short answers (2 of 3)</a:t>
+              <a:t>Hard questions and short answers (1 of 3)</a:t>
             </a:r>
             <a:endParaRPr lang="en-US" sz="2600" dirty="0"/>
           </a:p>
@@ -29997,7 +29891,7 @@
                 <a:ea typeface="Calibri" pitchFamily="34" charset="-122"/>
                 <a:cs typeface="Calibri" pitchFamily="34" charset="-120"/>
               </a:rPr>
-              <a:t>What does Packet Tracer prove?</a:t>
+              <a:t>Is this a lab exercise?</a:t>
             </a:r>
             <a:endParaRPr lang="en-US" sz="1500" dirty="0"/>
           </a:p>
@@ -30036,7 +29930,7 @@
                 <a:ea typeface="Calibri" pitchFamily="34" charset="-122"/>
                 <a:cs typeface="Calibri" pitchFamily="34" charset="-120"/>
               </a:rPr>
-              <a:t>The network design: OSPF, VLANs, ACL, 70/71 failover. The protocol is validated separately with emulation and Wireshark.</a:t>
+              <a:t>A lab sends datagrams. We built reliability and congestion control on top, measured them, and used them in a real chat and a routed network.</a:t>
             </a:r>
             <a:endParaRPr lang="en-US" sz="1350" dirty="0"/>
           </a:p>
@@ -30100,7 +29994,7 @@
                 <a:ea typeface="Calibri" pitchFamily="34" charset="-122"/>
                 <a:cs typeface="Calibri" pitchFamily="34" charset="-120"/>
               </a:rPr>
-              <a:t>Peer disappears?</a:t>
+              <a:t>Why not TCP?</a:t>
             </a:r>
             <a:endParaRPr lang="en-US" sz="1500" dirty="0"/>
           </a:p>
@@ -30139,7 +30033,7 @@
                 <a:ea typeface="Calibri" pitchFamily="34" charset="-122"/>
                 <a:cs typeface="Calibri" pitchFamily="34" charset="-120"/>
               </a:rPr>
-              <a:t>Sender keeps retransmitting on timeout. A connection abort after repeated timeouts is not built; it is the fix we would add.</a:t>
+              <a:t>TCP is in the kernel and cannot be changed. Building our own makes every mechanism visible. QUIC and HTTP/3 do the same.</a:t>
             </a:r>
             <a:endParaRPr lang="en-US" sz="1350" dirty="0"/>
           </a:p>
@@ -30203,7 +30097,7 @@
                 <a:ea typeface="Calibri" pitchFamily="34" charset="-122"/>
                 <a:cs typeface="Calibri" pitchFamily="34" charset="-120"/>
               </a:rPr>
-              <a:t>Does the checksum catch errors?</a:t>
+              <a:t>Did Smart-RUDP win?</a:t>
             </a:r>
             <a:endParaRPr lang="en-US" sz="1500" dirty="0"/>
           </a:p>
@@ -30242,7 +30136,7 @@
                 <a:ea typeface="Calibri" pitchFamily="34" charset="-122"/>
                 <a:cs typeface="Calibri" pitchFamily="34" charset="-120"/>
               </a:rPr>
-              <a:t>It is CRC-16/CCITT now. The first version was a byte sum and a fuzzer showed 2 percent of corrupted packets got through; with CRC-16 none of 333,000 did. It cannot catch every error pattern, as no 16-bit check can.</a:t>
+              <a:t>Yes, in the final C transport against tuned baselines: 15 to 52 percent less time than tuned AIMD on four ordinary paths (real clock, real sockets and 100 random held-out paths agree), a tie on the 10 percent loss path. Against a simplified BBR it wins on the satellite-like and fast paths and loses on the 2 percent lossy path. The first tabular agent did not beat AIMD, and we say so.</a:t>
             </a:r>
             <a:endParaRPr lang="en-US" sz="1350" dirty="0"/>
           </a:p>
@@ -30306,7 +30200,7 @@
                 <a:ea typeface="Calibri" pitchFamily="34" charset="-122"/>
                 <a:cs typeface="Calibri" pitchFamily="34" charset="-120"/>
               </a:rPr>
-              <a:t>Why no handshake in the exported trace?</a:t>
+              <a:t>Why Go-Back-N?</a:t>
             </a:r>
             <a:endParaRPr lang="en-US" sz="1500" dirty="0"/>
           </a:p>
@@ -30345,7 +30239,7 @@
                 <a:ea typeface="Calibri" pitchFamily="34" charset="-122"/>
                 <a:cs typeface="Calibri" pitchFamily="34" charset="-120"/>
               </a:rPr>
-              <a:t>The export builds synthetic packets. The real tshark capture shows SYN, SYN-ACK, ACK.</a:t>
+              <a:t>We started with it because it is simple to build and explain, then replaced it as the default with Selective Repeat: the receiver buffers out-of-order packets and reports them in an ACK bitmap, and the sender resends only what is missing. Go-Back-N stays behind a flag for comparison.</a:t>
             </a:r>
             <a:endParaRPr lang="en-US" sz="1350" dirty="0"/>
           </a:p>
@@ -30409,7 +30303,7 @@
                 <a:ea typeface="Calibri" pitchFamily="34" charset="-122"/>
                 <a:cs typeface="Calibri" pitchFamily="34" charset="-120"/>
               </a:rPr>
-              <a:t>Is the baseline fair?</a:t>
+              <a:t>Was it tested between machines?</a:t>
             </a:r>
             <a:endParaRPr lang="en-US" sz="1500" dirty="0"/>
           </a:p>
@@ -30448,7 +30342,7 @@
                 <a:ea typeface="Calibri" pitchFamily="34" charset="-122"/>
                 <a:cs typeface="Calibri" pitchFamily="34" charset="-120"/>
               </a:rPr>
-              <a:t>We tuned it: window cap 128 and a high start threshold, plus the same retransmission-timer floor for every policy. We also compare against tuned CUBIC. Tuned AIMD improved a lot, and the agent is still ahead on four paths.</a:t>
+              <a:t>Yes. Delay, loss and jitter are emulated in our client, in a separate proxy on real UDP sockets, and in virtual time; these agree with each other. We also ran it once on the Linux kernel with tc netem on one laptop: the agent beat tuned AIMD there, but kernel TCP was 1.5 to 1.7 times faster than us. We also made one run between two laptops on different networks over a Tailscale relay: RUDP delivered every transfer that finished, but the path drifted and four of twenty runs timed out, so we do not rank the policies from it; kernel TCP was 2 to 6 times faster on the clean repetitions.</a:t>
             </a:r>
             <a:endParaRPr lang="en-US" sz="1350" dirty="0"/>
           </a:p>
@@ -30465,6 +30359,617 @@
 <file path=ppt/slides/slide48.xml><?xml version="1.0" encoding="utf-8"?>
 <p:sld xmlns:a="http://schemas.openxmlformats.org/drawingml/2006/main" xmlns:r="http://schemas.openxmlformats.org/officeDocument/2006/relationships" xmlns:p="http://schemas.openxmlformats.org/presentationml/2006/main">
   <p:cSld name="Slide 48">
+    <p:bg>
+      <p:bgPr>
+        <a:solidFill>
+          <a:srgbClr val="FFFFFF"/>
+        </a:solidFill>
+      </p:bgPr>
+    </p:bg>
+    <p:spTree>
+      <p:nvGrpSpPr>
+        <p:cNvPr id="1" name=""/>
+        <p:cNvGrpSpPr/>
+        <p:nvPr/>
+      </p:nvGrpSpPr>
+      <p:grpSpPr>
+        <a:xfrm>
+          <a:off x="0" y="0"/>
+          <a:ext cx="0" cy="0"/>
+          <a:chOff x="0" y="0"/>
+          <a:chExt cx="0" cy="0"/>
+        </a:xfrm>
+      </p:grpSpPr>
+      <p:sp>
+        <p:nvSpPr>
+          <p:cNvPr id="2" name="Text 0"/>
+          <p:cNvSpPr/>
+          <p:nvPr/>
+        </p:nvSpPr>
+        <p:spPr>
+          <a:xfrm>
+            <a:off x="457200" y="274320"/>
+            <a:ext cx="9601200" cy="548640"/>
+          </a:xfrm>
+          <a:prstGeom prst="rect">
+            <a:avLst/>
+          </a:prstGeom>
+          <a:noFill/>
+          <a:ln/>
+        </p:spPr>
+        <p:txBody>
+          <a:bodyPr wrap="square" lIns="0" tIns="0" rIns="0" bIns="0" rtlCol="0" anchor="ctr"/>
+          <a:lstStyle/>
+          <a:p>
+            <a:pPr indent="0" marL="0">
+              <a:buNone/>
+            </a:pPr>
+            <a:r>
+              <a:rPr lang="en-US" sz="2600" b="1" dirty="0">
+                <a:solidFill>
+                  <a:srgbClr val="1B2430"/>
+                </a:solidFill>
+                <a:latin typeface="Calibri" pitchFamily="34" charset="0"/>
+                <a:ea typeface="Calibri" pitchFamily="34" charset="-122"/>
+                <a:cs typeface="Calibri" pitchFamily="34" charset="-120"/>
+              </a:rPr>
+              <a:t>Hard questions and short answers (2 of 3)</a:t>
+            </a:r>
+            <a:endParaRPr lang="en-US" sz="2600" dirty="0"/>
+          </a:p>
+        </p:txBody>
+      </p:sp>
+      <p:sp>
+        <p:nvSpPr>
+          <p:cNvPr id="3" name="Shape 1"/>
+          <p:cNvSpPr/>
+          <p:nvPr/>
+        </p:nvSpPr>
+        <p:spPr>
+          <a:xfrm>
+            <a:off x="457200" y="1143000"/>
+            <a:ext cx="11274552" cy="36576"/>
+          </a:xfrm>
+          <a:prstGeom prst="rect">
+            <a:avLst/>
+          </a:prstGeom>
+          <a:solidFill>
+            <a:srgbClr val="1F6FEB"/>
+          </a:solidFill>
+          <a:ln w="12700">
+            <a:solidFill>
+              <a:srgbClr val="1F6FEB"/>
+            </a:solidFill>
+            <a:prstDash val="solid"/>
+          </a:ln>
+        </p:spPr>
+      </p:sp>
+      <p:sp>
+        <p:nvSpPr>
+          <p:cNvPr id="4" name="Shape 2"/>
+          <p:cNvSpPr/>
+          <p:nvPr/>
+        </p:nvSpPr>
+        <p:spPr>
+          <a:xfrm>
+            <a:off x="457200" y="1371600"/>
+            <a:ext cx="11274552" cy="914400"/>
+          </a:xfrm>
+          <a:prstGeom prst="rect">
+            <a:avLst/>
+          </a:prstGeom>
+          <a:solidFill>
+            <a:srgbClr val="F2F6FB"/>
+          </a:solidFill>
+          <a:ln w="9525">
+            <a:solidFill>
+              <a:srgbClr val="D5DEE9"/>
+            </a:solidFill>
+            <a:prstDash val="solid"/>
+          </a:ln>
+        </p:spPr>
+      </p:sp>
+      <p:sp>
+        <p:nvSpPr>
+          <p:cNvPr id="5" name="Text 3"/>
+          <p:cNvSpPr/>
+          <p:nvPr/>
+        </p:nvSpPr>
+        <p:spPr>
+          <a:xfrm>
+            <a:off x="640080" y="1417320"/>
+            <a:ext cx="10972800" cy="320040"/>
+          </a:xfrm>
+          <a:prstGeom prst="rect">
+            <a:avLst/>
+          </a:prstGeom>
+          <a:noFill/>
+          <a:ln/>
+        </p:spPr>
+        <p:txBody>
+          <a:bodyPr wrap="square" lIns="0" tIns="0" rIns="0" bIns="0" rtlCol="0" anchor="ctr"/>
+          <a:lstStyle/>
+          <a:p>
+            <a:pPr indent="0" marL="0">
+              <a:buNone/>
+            </a:pPr>
+            <a:r>
+              <a:rPr lang="en-US" sz="1500" b="1" dirty="0">
+                <a:solidFill>
+                  <a:srgbClr val="1F6FEB"/>
+                </a:solidFill>
+                <a:latin typeface="Calibri" pitchFamily="34" charset="0"/>
+                <a:ea typeface="Calibri" pitchFamily="34" charset="-122"/>
+                <a:cs typeface="Calibri" pitchFamily="34" charset="-120"/>
+              </a:rPr>
+              <a:t>What does Packet Tracer prove?</a:t>
+            </a:r>
+            <a:endParaRPr lang="en-US" sz="1500" dirty="0"/>
+          </a:p>
+        </p:txBody>
+      </p:sp>
+      <p:sp>
+        <p:nvSpPr>
+          <p:cNvPr id="6" name="Text 4"/>
+          <p:cNvSpPr/>
+          <p:nvPr/>
+        </p:nvSpPr>
+        <p:spPr>
+          <a:xfrm>
+            <a:off x="640080" y="1737360"/>
+            <a:ext cx="10972800" cy="530352"/>
+          </a:xfrm>
+          <a:prstGeom prst="rect">
+            <a:avLst/>
+          </a:prstGeom>
+          <a:noFill/>
+          <a:ln/>
+        </p:spPr>
+        <p:txBody>
+          <a:bodyPr wrap="square" lIns="0" tIns="0" rIns="0" bIns="0" rtlCol="0" anchor="t"/>
+          <a:lstStyle/>
+          <a:p>
+            <a:pPr indent="0" marL="0">
+              <a:buNone/>
+            </a:pPr>
+            <a:r>
+              <a:rPr lang="en-US" sz="1350" dirty="0">
+                <a:solidFill>
+                  <a:srgbClr val="1B2430"/>
+                </a:solidFill>
+                <a:latin typeface="Calibri" pitchFamily="34" charset="0"/>
+                <a:ea typeface="Calibri" pitchFamily="34" charset="-122"/>
+                <a:cs typeface="Calibri" pitchFamily="34" charset="-120"/>
+              </a:rPr>
+              <a:t>The network design: OSPF, VLANs, ACL, 70/71 failover. The protocol is validated separately with emulation and Wireshark.</a:t>
+            </a:r>
+            <a:endParaRPr lang="en-US" sz="1350" dirty="0"/>
+          </a:p>
+        </p:txBody>
+      </p:sp>
+      <p:sp>
+        <p:nvSpPr>
+          <p:cNvPr id="7" name="Shape 5"/>
+          <p:cNvSpPr/>
+          <p:nvPr/>
+        </p:nvSpPr>
+        <p:spPr>
+          <a:xfrm>
+            <a:off x="457200" y="2377440"/>
+            <a:ext cx="11274552" cy="914400"/>
+          </a:xfrm>
+          <a:prstGeom prst="rect">
+            <a:avLst/>
+          </a:prstGeom>
+          <a:solidFill>
+            <a:srgbClr val="F2F6FB"/>
+          </a:solidFill>
+          <a:ln w="9525">
+            <a:solidFill>
+              <a:srgbClr val="D5DEE9"/>
+            </a:solidFill>
+            <a:prstDash val="solid"/>
+          </a:ln>
+        </p:spPr>
+      </p:sp>
+      <p:sp>
+        <p:nvSpPr>
+          <p:cNvPr id="8" name="Text 6"/>
+          <p:cNvSpPr/>
+          <p:nvPr/>
+        </p:nvSpPr>
+        <p:spPr>
+          <a:xfrm>
+            <a:off x="640080" y="2423160"/>
+            <a:ext cx="10972800" cy="320040"/>
+          </a:xfrm>
+          <a:prstGeom prst="rect">
+            <a:avLst/>
+          </a:prstGeom>
+          <a:noFill/>
+          <a:ln/>
+        </p:spPr>
+        <p:txBody>
+          <a:bodyPr wrap="square" lIns="0" tIns="0" rIns="0" bIns="0" rtlCol="0" anchor="ctr"/>
+          <a:lstStyle/>
+          <a:p>
+            <a:pPr indent="0" marL="0">
+              <a:buNone/>
+            </a:pPr>
+            <a:r>
+              <a:rPr lang="en-US" sz="1500" b="1" dirty="0">
+                <a:solidFill>
+                  <a:srgbClr val="1F6FEB"/>
+                </a:solidFill>
+                <a:latin typeface="Calibri" pitchFamily="34" charset="0"/>
+                <a:ea typeface="Calibri" pitchFamily="34" charset="-122"/>
+                <a:cs typeface="Calibri" pitchFamily="34" charset="-120"/>
+              </a:rPr>
+              <a:t>Peer disappears?</a:t>
+            </a:r>
+            <a:endParaRPr lang="en-US" sz="1500" dirty="0"/>
+          </a:p>
+        </p:txBody>
+      </p:sp>
+      <p:sp>
+        <p:nvSpPr>
+          <p:cNvPr id="9" name="Text 7"/>
+          <p:cNvSpPr/>
+          <p:nvPr/>
+        </p:nvSpPr>
+        <p:spPr>
+          <a:xfrm>
+            <a:off x="640080" y="2743200"/>
+            <a:ext cx="10972800" cy="530352"/>
+          </a:xfrm>
+          <a:prstGeom prst="rect">
+            <a:avLst/>
+          </a:prstGeom>
+          <a:noFill/>
+          <a:ln/>
+        </p:spPr>
+        <p:txBody>
+          <a:bodyPr wrap="square" lIns="0" tIns="0" rIns="0" bIns="0" rtlCol="0" anchor="t"/>
+          <a:lstStyle/>
+          <a:p>
+            <a:pPr indent="0" marL="0">
+              <a:buNone/>
+            </a:pPr>
+            <a:r>
+              <a:rPr lang="en-US" sz="1350" dirty="0">
+                <a:solidFill>
+                  <a:srgbClr val="1B2430"/>
+                </a:solidFill>
+                <a:latin typeface="Calibri" pitchFamily="34" charset="0"/>
+                <a:ea typeface="Calibri" pitchFamily="34" charset="-122"/>
+                <a:cs typeface="Calibri" pitchFamily="34" charset="-120"/>
+              </a:rPr>
+              <a:t>Sender keeps retransmitting on timeout. A connection abort after repeated timeouts is not built; it is the fix we would add.</a:t>
+            </a:r>
+            <a:endParaRPr lang="en-US" sz="1350" dirty="0"/>
+          </a:p>
+        </p:txBody>
+      </p:sp>
+      <p:sp>
+        <p:nvSpPr>
+          <p:cNvPr id="10" name="Shape 8"/>
+          <p:cNvSpPr/>
+          <p:nvPr/>
+        </p:nvSpPr>
+        <p:spPr>
+          <a:xfrm>
+            <a:off x="457200" y="3383280"/>
+            <a:ext cx="11274552" cy="914400"/>
+          </a:xfrm>
+          <a:prstGeom prst="rect">
+            <a:avLst/>
+          </a:prstGeom>
+          <a:solidFill>
+            <a:srgbClr val="F2F6FB"/>
+          </a:solidFill>
+          <a:ln w="9525">
+            <a:solidFill>
+              <a:srgbClr val="D5DEE9"/>
+            </a:solidFill>
+            <a:prstDash val="solid"/>
+          </a:ln>
+        </p:spPr>
+      </p:sp>
+      <p:sp>
+        <p:nvSpPr>
+          <p:cNvPr id="11" name="Text 9"/>
+          <p:cNvSpPr/>
+          <p:nvPr/>
+        </p:nvSpPr>
+        <p:spPr>
+          <a:xfrm>
+            <a:off x="640080" y="3429000"/>
+            <a:ext cx="10972800" cy="320040"/>
+          </a:xfrm>
+          <a:prstGeom prst="rect">
+            <a:avLst/>
+          </a:prstGeom>
+          <a:noFill/>
+          <a:ln/>
+        </p:spPr>
+        <p:txBody>
+          <a:bodyPr wrap="square" lIns="0" tIns="0" rIns="0" bIns="0" rtlCol="0" anchor="ctr"/>
+          <a:lstStyle/>
+          <a:p>
+            <a:pPr indent="0" marL="0">
+              <a:buNone/>
+            </a:pPr>
+            <a:r>
+              <a:rPr lang="en-US" sz="1500" b="1" dirty="0">
+                <a:solidFill>
+                  <a:srgbClr val="1F6FEB"/>
+                </a:solidFill>
+                <a:latin typeface="Calibri" pitchFamily="34" charset="0"/>
+                <a:ea typeface="Calibri" pitchFamily="34" charset="-122"/>
+                <a:cs typeface="Calibri" pitchFamily="34" charset="-120"/>
+              </a:rPr>
+              <a:t>Does the checksum catch errors?</a:t>
+            </a:r>
+            <a:endParaRPr lang="en-US" sz="1500" dirty="0"/>
+          </a:p>
+        </p:txBody>
+      </p:sp>
+      <p:sp>
+        <p:nvSpPr>
+          <p:cNvPr id="12" name="Text 10"/>
+          <p:cNvSpPr/>
+          <p:nvPr/>
+        </p:nvSpPr>
+        <p:spPr>
+          <a:xfrm>
+            <a:off x="640080" y="3749040"/>
+            <a:ext cx="10972800" cy="530352"/>
+          </a:xfrm>
+          <a:prstGeom prst="rect">
+            <a:avLst/>
+          </a:prstGeom>
+          <a:noFill/>
+          <a:ln/>
+        </p:spPr>
+        <p:txBody>
+          <a:bodyPr wrap="square" lIns="0" tIns="0" rIns="0" bIns="0" rtlCol="0" anchor="t"/>
+          <a:lstStyle/>
+          <a:p>
+            <a:pPr indent="0" marL="0">
+              <a:buNone/>
+            </a:pPr>
+            <a:r>
+              <a:rPr lang="en-US" sz="1350" dirty="0">
+                <a:solidFill>
+                  <a:srgbClr val="1B2430"/>
+                </a:solidFill>
+                <a:latin typeface="Calibri" pitchFamily="34" charset="0"/>
+                <a:ea typeface="Calibri" pitchFamily="34" charset="-122"/>
+                <a:cs typeface="Calibri" pitchFamily="34" charset="-120"/>
+              </a:rPr>
+              <a:t>It is CRC-16/CCITT now. The first version was a byte sum and a fuzzer showed 2 percent of corrupted packets got through; with CRC-16 none of 333,000 did. It cannot catch every error pattern, as no 16-bit check can.</a:t>
+            </a:r>
+            <a:endParaRPr lang="en-US" sz="1350" dirty="0"/>
+          </a:p>
+        </p:txBody>
+      </p:sp>
+      <p:sp>
+        <p:nvSpPr>
+          <p:cNvPr id="13" name="Shape 11"/>
+          <p:cNvSpPr/>
+          <p:nvPr/>
+        </p:nvSpPr>
+        <p:spPr>
+          <a:xfrm>
+            <a:off x="457200" y="4389120"/>
+            <a:ext cx="11274552" cy="914400"/>
+          </a:xfrm>
+          <a:prstGeom prst="rect">
+            <a:avLst/>
+          </a:prstGeom>
+          <a:solidFill>
+            <a:srgbClr val="F2F6FB"/>
+          </a:solidFill>
+          <a:ln w="9525">
+            <a:solidFill>
+              <a:srgbClr val="D5DEE9"/>
+            </a:solidFill>
+            <a:prstDash val="solid"/>
+          </a:ln>
+        </p:spPr>
+      </p:sp>
+      <p:sp>
+        <p:nvSpPr>
+          <p:cNvPr id="14" name="Text 12"/>
+          <p:cNvSpPr/>
+          <p:nvPr/>
+        </p:nvSpPr>
+        <p:spPr>
+          <a:xfrm>
+            <a:off x="640080" y="4434840"/>
+            <a:ext cx="10972800" cy="320040"/>
+          </a:xfrm>
+          <a:prstGeom prst="rect">
+            <a:avLst/>
+          </a:prstGeom>
+          <a:noFill/>
+          <a:ln/>
+        </p:spPr>
+        <p:txBody>
+          <a:bodyPr wrap="square" lIns="0" tIns="0" rIns="0" bIns="0" rtlCol="0" anchor="ctr"/>
+          <a:lstStyle/>
+          <a:p>
+            <a:pPr indent="0" marL="0">
+              <a:buNone/>
+            </a:pPr>
+            <a:r>
+              <a:rPr lang="en-US" sz="1500" b="1" dirty="0">
+                <a:solidFill>
+                  <a:srgbClr val="1F6FEB"/>
+                </a:solidFill>
+                <a:latin typeface="Calibri" pitchFamily="34" charset="0"/>
+                <a:ea typeface="Calibri" pitchFamily="34" charset="-122"/>
+                <a:cs typeface="Calibri" pitchFamily="34" charset="-120"/>
+              </a:rPr>
+              <a:t>Why no handshake in the exported trace?</a:t>
+            </a:r>
+            <a:endParaRPr lang="en-US" sz="1500" dirty="0"/>
+          </a:p>
+        </p:txBody>
+      </p:sp>
+      <p:sp>
+        <p:nvSpPr>
+          <p:cNvPr id="15" name="Text 13"/>
+          <p:cNvSpPr/>
+          <p:nvPr/>
+        </p:nvSpPr>
+        <p:spPr>
+          <a:xfrm>
+            <a:off x="640080" y="4754880"/>
+            <a:ext cx="10972800" cy="530352"/>
+          </a:xfrm>
+          <a:prstGeom prst="rect">
+            <a:avLst/>
+          </a:prstGeom>
+          <a:noFill/>
+          <a:ln/>
+        </p:spPr>
+        <p:txBody>
+          <a:bodyPr wrap="square" lIns="0" tIns="0" rIns="0" bIns="0" rtlCol="0" anchor="t"/>
+          <a:lstStyle/>
+          <a:p>
+            <a:pPr indent="0" marL="0">
+              <a:buNone/>
+            </a:pPr>
+            <a:r>
+              <a:rPr lang="en-US" sz="1350" dirty="0">
+                <a:solidFill>
+                  <a:srgbClr val="1B2430"/>
+                </a:solidFill>
+                <a:latin typeface="Calibri" pitchFamily="34" charset="0"/>
+                <a:ea typeface="Calibri" pitchFamily="34" charset="-122"/>
+                <a:cs typeface="Calibri" pitchFamily="34" charset="-120"/>
+              </a:rPr>
+              <a:t>The export builds synthetic packets. The real tshark capture shows SYN, SYN-ACK, ACK.</a:t>
+            </a:r>
+            <a:endParaRPr lang="en-US" sz="1350" dirty="0"/>
+          </a:p>
+        </p:txBody>
+      </p:sp>
+      <p:sp>
+        <p:nvSpPr>
+          <p:cNvPr id="16" name="Shape 14"/>
+          <p:cNvSpPr/>
+          <p:nvPr/>
+        </p:nvSpPr>
+        <p:spPr>
+          <a:xfrm>
+            <a:off x="457200" y="5394960"/>
+            <a:ext cx="11274552" cy="914400"/>
+          </a:xfrm>
+          <a:prstGeom prst="rect">
+            <a:avLst/>
+          </a:prstGeom>
+          <a:solidFill>
+            <a:srgbClr val="F2F6FB"/>
+          </a:solidFill>
+          <a:ln w="9525">
+            <a:solidFill>
+              <a:srgbClr val="D5DEE9"/>
+            </a:solidFill>
+            <a:prstDash val="solid"/>
+          </a:ln>
+        </p:spPr>
+      </p:sp>
+      <p:sp>
+        <p:nvSpPr>
+          <p:cNvPr id="17" name="Text 15"/>
+          <p:cNvSpPr/>
+          <p:nvPr/>
+        </p:nvSpPr>
+        <p:spPr>
+          <a:xfrm>
+            <a:off x="640080" y="5440680"/>
+            <a:ext cx="10972800" cy="320040"/>
+          </a:xfrm>
+          <a:prstGeom prst="rect">
+            <a:avLst/>
+          </a:prstGeom>
+          <a:noFill/>
+          <a:ln/>
+        </p:spPr>
+        <p:txBody>
+          <a:bodyPr wrap="square" lIns="0" tIns="0" rIns="0" bIns="0" rtlCol="0" anchor="ctr"/>
+          <a:lstStyle/>
+          <a:p>
+            <a:pPr indent="0" marL="0">
+              <a:buNone/>
+            </a:pPr>
+            <a:r>
+              <a:rPr lang="en-US" sz="1500" b="1" dirty="0">
+                <a:solidFill>
+                  <a:srgbClr val="1F6FEB"/>
+                </a:solidFill>
+                <a:latin typeface="Calibri" pitchFamily="34" charset="0"/>
+                <a:ea typeface="Calibri" pitchFamily="34" charset="-122"/>
+                <a:cs typeface="Calibri" pitchFamily="34" charset="-120"/>
+              </a:rPr>
+              <a:t>Is the baseline fair?</a:t>
+            </a:r>
+            <a:endParaRPr lang="en-US" sz="1500" dirty="0"/>
+          </a:p>
+        </p:txBody>
+      </p:sp>
+      <p:sp>
+        <p:nvSpPr>
+          <p:cNvPr id="18" name="Text 16"/>
+          <p:cNvSpPr/>
+          <p:nvPr/>
+        </p:nvSpPr>
+        <p:spPr>
+          <a:xfrm>
+            <a:off x="640080" y="5760720"/>
+            <a:ext cx="10972800" cy="530352"/>
+          </a:xfrm>
+          <a:prstGeom prst="rect">
+            <a:avLst/>
+          </a:prstGeom>
+          <a:noFill/>
+          <a:ln/>
+        </p:spPr>
+        <p:txBody>
+          <a:bodyPr wrap="square" lIns="0" tIns="0" rIns="0" bIns="0" rtlCol="0" anchor="t"/>
+          <a:lstStyle/>
+          <a:p>
+            <a:pPr indent="0" marL="0">
+              <a:buNone/>
+            </a:pPr>
+            <a:r>
+              <a:rPr lang="en-US" sz="1350" dirty="0">
+                <a:solidFill>
+                  <a:srgbClr val="1B2430"/>
+                </a:solidFill>
+                <a:latin typeface="Calibri" pitchFamily="34" charset="0"/>
+                <a:ea typeface="Calibri" pitchFamily="34" charset="-122"/>
+                <a:cs typeface="Calibri" pitchFamily="34" charset="-120"/>
+              </a:rPr>
+              <a:t>We tuned it: window cap 128 and a high start threshold, plus the same retransmission-timer floor for every policy. We also compare against tuned CUBIC. Tuned AIMD improved a lot, and the agent is still ahead on four paths.</a:t>
+            </a:r>
+            <a:endParaRPr lang="en-US" sz="1350" dirty="0"/>
+          </a:p>
+        </p:txBody>
+      </p:sp>
+    </p:spTree>
+  </p:cSld>
+  <p:clrMapOvr>
+    <a:masterClrMapping/>
+  </p:clrMapOvr>
+</p:sld>
+</file>
+
+<file path=ppt/slides/slide49.xml><?xml version="1.0" encoding="utf-8"?>
+<p:sld xmlns:a="http://schemas.openxmlformats.org/drawingml/2006/main" xmlns:r="http://schemas.openxmlformats.org/officeDocument/2006/relationships" xmlns:p="http://schemas.openxmlformats.org/presentationml/2006/main">
+  <p:cSld name="Slide 49">
     <p:bg>
       <p:bgPr>
         <a:solidFill>

</xml_diff>